<commit_message>
Fix report accuracy: cleaning finding, assumptions, and PDF source
Add the missing 145% data-cleaning finding and a Limitations & Honest Scope section to both the PDF and the slide deck. Disclose the two cleaning values as an assumption (Diana's city) and a placeholder (ID 9's name) instead of presenting Diana's city as a mode. Remove the unsupported 'monthly' payroll claim in favour of the real payroll ramp (55,000 -> 554,500). Reconcile the issue count as 7 data defects + 1 format issue across README, PDF and deck.

reports/generate_report.py now recomputes every figure from the raw and cleaned CSVs, replacing the hand-built PDF with a reproducible one.
</commit_message>
<xml_diff>
--- a/reports/Employee Salary & Headcount Dashboard.pptx
+++ b/reports/Employee Salary & Headcount Dashboard.pptx
@@ -11,6 +11,7 @@
     <p:sldId id="259" r:id="rId5"/>
     <p:sldId id="260" r:id="rId6"/>
     <p:sldId id="261" r:id="rId7"/>
+    <p:sldId id="271" r:id="rId24"/>
     <p:sldId id="262" r:id="rId8"/>
     <p:sldId id="263" r:id="rId9"/>
     <p:sldId id="264" r:id="rId10"/>
@@ -3802,7 +3803,7 @@
                 <a:ea typeface="Quattrocento Sans" pitchFamily="34" charset="-122"/>
                 <a:cs typeface="Quattrocento Sans" pitchFamily="34" charset="-120"/>
               </a:rPr>
-              <a:t>, driven by senior hires.</a:t>
+              <a:t>, driven by one senior hire.</a:t>
             </a:r>
             <a:endParaRPr lang="en-US" sz="1600" dirty="0"/>
           </a:p>
@@ -8739,7 +8740,7 @@
                 <a:ea typeface="Quattrocento Sans" pitchFamily="34" charset="-122"/>
                 <a:cs typeface="Quattrocento Sans" pitchFamily="34" charset="-120"/>
               </a:rPr>
-              <a:t>, driven by senior hires. </a:t>
+              <a:t>, driven by one senior hire. </a:t>
             </a:r>
             <a:pPr algn="l">
               <a:lnSpc>
@@ -9367,7 +9368,7 @@
                 <a:ea typeface="Liter" pitchFamily="34" charset="-122"/>
                 <a:cs typeface="Liter" pitchFamily="34" charset="-120"/>
               </a:rPr>
-              <a:t>Monthly Payroll Summary</a:t>
+              <a:t>Payroll Growth</a:t>
             </a:r>
             <a:endParaRPr lang="en-US" sz="2000" dirty="0"/>
           </a:p>
@@ -9408,7 +9409,7 @@
                 <a:ea typeface="Quattrocento Sans" pitchFamily="34" charset="-122"/>
                 <a:cs typeface="Quattrocento Sans" pitchFamily="34" charset="-120"/>
               </a:rPr>
-              <a:t>The total monthly salary expense is </a:t>
+              <a:t>The total salary expense is </a:t>
             </a:r>
             <a:pPr algn="l">
               <a:lnSpc>
@@ -9472,7 +9473,7 @@
                 <a:ea typeface="Quattrocento Sans" pitchFamily="34" charset="-122"/>
                 <a:cs typeface="Quattrocento Sans" pitchFamily="34" charset="-120"/>
               </a:rPr>
-              <a:t> per employee. This provides a clear baseline for workforce budgeting.</a:t>
+              <a:t> per employee. Payroll ramped from KES 55,000 in January to KES 554,500 by May as headcount grew from 1 to 9.</a:t>
             </a:r>
             <a:endParaRPr lang="en-US" sz="1600" dirty="0"/>
           </a:p>
@@ -9783,6 +9784,969 @@
     <p:fade/>
     <p:spd val="med"/>
   </p:transition>
+</p:sld>
+</file>
+
+<file path=ppt/slides/slide16.xml><?xml version="1.0" encoding="utf-8"?>
+<p:sld xmlns:a="http://schemas.openxmlformats.org/drawingml/2006/main" xmlns:p="http://schemas.openxmlformats.org/presentationml/2006/main" xmlns:r="http://schemas.openxmlformats.org/officeDocument/2006/relationships">
+  <p:cSld>
+    <p:bg>
+      <p:bgPr>
+        <a:solidFill>
+          <a:srgbClr val="0F1923"/>
+        </a:solidFill>
+      </p:bgPr>
+    </p:bg>
+    <p:spTree>
+      <p:nvGrpSpPr>
+        <p:cNvPr id="1" name=""/>
+        <p:cNvGrpSpPr/>
+        <p:nvPr/>
+      </p:nvGrpSpPr>
+      <p:grpSpPr/>
+      <p:sp>
+        <p:nvSpPr>
+          <p:cNvPr id="2" name="Text 0"/>
+          <p:cNvSpPr/>
+          <p:nvPr/>
+        </p:nvSpPr>
+        <p:spPr>
+          <a:xfrm>
+            <a:off x="13208000" y="8636000"/>
+            <a:ext cx="2540000" cy="254000"/>
+          </a:xfrm>
+          <a:prstGeom prst="rect">
+            <a:avLst/>
+          </a:prstGeom>
+          <a:noFill/>
+          <a:ln/>
+        </p:spPr>
+        <p:txBody>
+          <a:bodyPr wrap="none" lIns="0" tIns="0" rIns="0" bIns="0" rtlCol="0" anchor="ctr"/>
+          <a:lstStyle/>
+          <a:p>
+            <a:pPr algn="r">
+              <a:lnSpc>
+                <a:spcPct val="120000"/>
+              </a:lnSpc>
+            </a:pPr>
+            <a:r>
+              <a:rPr lang="en-US" sz="1200" spc="200" kern="0" dirty="0">
+                <a:solidFill>
+                  <a:srgbClr val="8B95A5"/>
+                </a:solidFill>
+                <a:latin typeface="Liter" pitchFamily="34" charset="0"/>
+                <a:ea typeface="Liter" pitchFamily="34" charset="-122"/>
+                <a:cs typeface="Liter" pitchFamily="34" charset="-120"/>
+              </a:rPr>
+              <a:t>DATA CLEANING</a:t>
+            </a:r>
+            <a:endParaRPr lang="en-US" sz="1200" dirty="0"/>
+          </a:p>
+        </p:txBody>
+      </p:sp>
+      <p:sp>
+        <p:nvSpPr>
+          <p:cNvPr id="3" name="Text 1"/>
+          <p:cNvSpPr/>
+          <p:nvPr/>
+        </p:nvSpPr>
+        <p:spPr>
+          <a:xfrm>
+            <a:off x="762000" y="571500"/>
+            <a:ext cx="8890000" cy="533400"/>
+          </a:xfrm>
+          <a:prstGeom prst="rect">
+            <a:avLst/>
+          </a:prstGeom>
+          <a:noFill/>
+          <a:ln/>
+        </p:spPr>
+        <p:txBody>
+          <a:bodyPr wrap="none" lIns="0" tIns="0" rIns="0" bIns="0" rtlCol="0" anchor="ctr"/>
+          <a:lstStyle/>
+          <a:p>
+            <a:pPr algn="l">
+              <a:lnSpc>
+                <a:spcPct val="120000"/>
+              </a:lnSpc>
+            </a:pPr>
+            <a:r>
+              <a:rPr lang="en-US" sz="3000" dirty="0">
+                <a:solidFill>
+                  <a:srgbClr val="F0F2F5"/>
+                </a:solidFill>
+                <a:latin typeface="Liter" pitchFamily="34" charset="0"/>
+                <a:ea typeface="Liter" pitchFamily="34" charset="-122"/>
+                <a:cs typeface="Liter" pitchFamily="34" charset="-120"/>
+              </a:rPr>
+              <a:t>Cleaning Impact &amp; Honest Scope</a:t>
+            </a:r>
+            <a:endParaRPr lang="en-US" sz="3000" dirty="0"/>
+          </a:p>
+        </p:txBody>
+      </p:sp>
+      <p:sp>
+        <p:nvSpPr>
+          <p:cNvPr id="4" name="Shape 2"/>
+          <p:cNvSpPr/>
+          <p:nvPr/>
+        </p:nvSpPr>
+        <p:spPr>
+          <a:xfrm>
+            <a:off x="762000" y="1181100"/>
+            <a:ext cx="762000" cy="38100"/>
+          </a:xfrm>
+          <a:prstGeom prst="rect">
+            <a:avLst/>
+          </a:prstGeom>
+          <a:solidFill>
+            <a:srgbClr val="F5A623"/>
+          </a:solidFill>
+          <a:ln/>
+        </p:spPr>
+      </p:sp>
+      <p:sp>
+        <p:nvSpPr>
+          <p:cNvPr id="5" name="Shape 3"/>
+          <p:cNvSpPr/>
+          <p:nvPr/>
+        </p:nvSpPr>
+        <p:spPr>
+          <a:xfrm>
+            <a:off x="762000" y="1587500"/>
+            <a:ext cx="7175500" cy="3238500"/>
+          </a:xfrm>
+          <a:prstGeom prst="rect">
+            <a:avLst/>
+          </a:prstGeom>
+          <a:solidFill>
+            <a:srgbClr val="1A2634"/>
+          </a:solidFill>
+          <a:ln/>
+        </p:spPr>
+      </p:sp>
+      <p:sp>
+        <p:nvSpPr>
+          <p:cNvPr id="6" name="Text 4"/>
+          <p:cNvSpPr/>
+          <p:nvPr/>
+        </p:nvSpPr>
+        <p:spPr>
+          <a:xfrm>
+            <a:off x="1079500" y="1778000"/>
+            <a:ext cx="1016000" cy="508000"/>
+          </a:xfrm>
+          <a:prstGeom prst="rect">
+            <a:avLst/>
+          </a:prstGeom>
+          <a:noFill/>
+          <a:ln/>
+        </p:spPr>
+        <p:txBody>
+          <a:bodyPr wrap="none" lIns="0" tIns="0" rIns="0" bIns="0" rtlCol="0" anchor="t"/>
+          <a:lstStyle/>
+          <a:p>
+            <a:pPr algn="l">
+              <a:lnSpc>
+                <a:spcPct val="120000"/>
+              </a:lnSpc>
+            </a:pPr>
+            <a:r>
+              <a:rPr lang="en-US" sz="3200" dirty="0">
+                <a:solidFill>
+                  <a:srgbClr val="F5A623"/>
+                </a:solidFill>
+                <a:latin typeface="Liter" pitchFamily="34" charset="0"/>
+                <a:ea typeface="Liter" pitchFamily="34" charset="-122"/>
+                <a:cs typeface="Liter" pitchFamily="34" charset="-120"/>
+              </a:rPr>
+              <a:t>01</a:t>
+            </a:r>
+            <a:endParaRPr lang="en-US" sz="3200" dirty="0"/>
+          </a:p>
+        </p:txBody>
+      </p:sp>
+      <p:sp>
+        <p:nvSpPr>
+          <p:cNvPr id="7" name="Text 5"/>
+          <p:cNvSpPr/>
+          <p:nvPr/>
+        </p:nvSpPr>
+        <p:spPr>
+          <a:xfrm>
+            <a:off x="1079500" y="2349500"/>
+            <a:ext cx="6540500" cy="355600"/>
+          </a:xfrm>
+          <a:prstGeom prst="rect">
+            <a:avLst/>
+          </a:prstGeom>
+          <a:noFill/>
+          <a:ln/>
+        </p:spPr>
+        <p:txBody>
+          <a:bodyPr wrap="none" lIns="0" tIns="0" rIns="0" bIns="0" rtlCol="0" anchor="ctr"/>
+          <a:lstStyle/>
+          <a:p>
+            <a:pPr algn="l">
+              <a:lnSpc>
+                <a:spcPct val="120000"/>
+              </a:lnSpc>
+            </a:pPr>
+            <a:r>
+              <a:rPr lang="en-US" sz="2000" dirty="0">
+                <a:solidFill>
+                  <a:srgbClr val="F0F2F5"/>
+                </a:solidFill>
+                <a:latin typeface="Liter" pitchFamily="34" charset="0"/>
+                <a:ea typeface="Liter" pitchFamily="34" charset="-122"/>
+                <a:cs typeface="Liter" pitchFamily="34" charset="-120"/>
+              </a:rPr>
+              <a:t>The 145% Finding</a:t>
+            </a:r>
+            <a:endParaRPr lang="en-US" sz="2000" dirty="0"/>
+          </a:p>
+        </p:txBody>
+      </p:sp>
+      <p:sp>
+        <p:nvSpPr>
+          <p:cNvPr id="8" name="Text 6"/>
+          <p:cNvSpPr/>
+          <p:nvPr/>
+        </p:nvSpPr>
+        <p:spPr>
+          <a:xfrm>
+            <a:off x="1079500" y="2794000"/>
+            <a:ext cx="6540500" cy="1714500"/>
+          </a:xfrm>
+          <a:prstGeom prst="rect">
+            <a:avLst/>
+          </a:prstGeom>
+          <a:noFill/>
+          <a:ln/>
+        </p:spPr>
+        <p:txBody>
+          <a:bodyPr wrap="square" lIns="0" tIns="0" rIns="0" bIns="0" rtlCol="0" anchor="t"/>
+          <a:lstStyle/>
+          <a:p>
+            <a:pPr algn="l">
+              <a:lnSpc>
+                <a:spcPct val="160000"/>
+              </a:lnSpc>
+            </a:pPr>
+            <a:r>
+              <a:rPr lang="en-US" sz="1600" dirty="0">
+                <a:solidFill>
+                  <a:srgbClr val="8B95A5"/>
+                </a:solidFill>
+                <a:latin typeface="Quattrocento Sans" pitchFamily="34" charset="0"/>
+                <a:ea typeface="Quattrocento Sans" pitchFamily="34" charset="-122"/>
+                <a:cs typeface="Quattrocento Sans" pitchFamily="34" charset="-120"/>
+              </a:rPr>
+              <a:t>Computed on the raw export, mean salary reads </a:t>
+            </a:r>
+            <a:r>
+              <a:rPr lang="en-US" sz="1600" b="1" dirty="0">
+                <a:solidFill>
+                  <a:srgbClr val="F5A623"/>
+                </a:solidFill>
+                <a:latin typeface="Quattrocento Sans" pitchFamily="34" charset="0"/>
+                <a:ea typeface="Quattrocento Sans" pitchFamily="34" charset="-122"/>
+                <a:cs typeface="Quattrocento Sans" pitchFamily="34" charset="-120"/>
+              </a:rPr>
+              <a:t>KES 151,111</a:t>
+            </a:r>
+            <a:r>
+              <a:rPr lang="en-US" sz="1600" dirty="0">
+                <a:solidFill>
+                  <a:srgbClr val="8B95A5"/>
+                </a:solidFill>
+                <a:latin typeface="Quattrocento Sans" pitchFamily="34" charset="0"/>
+                <a:ea typeface="Quattrocento Sans" pitchFamily="34" charset="-122"/>
+                <a:cs typeface="Quattrocento Sans" pitchFamily="34" charset="-120"/>
+              </a:rPr>
+              <a:t>; once cleaned it is </a:t>
+            </a:r>
+            <a:r>
+              <a:rPr lang="en-US" sz="1600" b="1" dirty="0">
+                <a:solidFill>
+                  <a:srgbClr val="F0F2F5"/>
+                </a:solidFill>
+                <a:latin typeface="Quattrocento Sans" pitchFamily="34" charset="0"/>
+                <a:ea typeface="Quattrocento Sans" pitchFamily="34" charset="-122"/>
+                <a:cs typeface="Quattrocento Sans" pitchFamily="34" charset="-120"/>
+              </a:rPr>
+              <a:t>KES 61,611</a:t>
+            </a:r>
+            <a:r>
+              <a:rPr lang="en-US" sz="1600" dirty="0">
+                <a:solidFill>
+                  <a:srgbClr val="8B95A5"/>
+                </a:solidFill>
+                <a:latin typeface="Quattrocento Sans" pitchFamily="34" charset="0"/>
+                <a:ea typeface="Quattrocento Sans" pitchFamily="34" charset="-122"/>
+                <a:cs typeface="Quattrocento Sans" pitchFamily="34" charset="-120"/>
+              </a:rPr>
+              <a:t> — an </a:t>
+            </a:r>
+            <a:r>
+              <a:rPr lang="en-US" sz="1600" b="1" dirty="0">
+                <a:solidFill>
+                  <a:srgbClr val="F5A623"/>
+                </a:solidFill>
+                <a:latin typeface="Quattrocento Sans" pitchFamily="34" charset="0"/>
+                <a:ea typeface="Quattrocento Sans" pitchFamily="34" charset="-122"/>
+                <a:cs typeface="Quattrocento Sans" pitchFamily="34" charset="-120"/>
+              </a:rPr>
+              <a:t>inflation of 145%</a:t>
+            </a:r>
+            <a:r>
+              <a:rPr lang="en-US" sz="1600" dirty="0">
+                <a:solidFill>
+                  <a:srgbClr val="8B95A5"/>
+                </a:solidFill>
+                <a:latin typeface="Quattrocento Sans" pitchFamily="34" charset="0"/>
+                <a:ea typeface="Quattrocento Sans" pitchFamily="34" charset="-122"/>
+                <a:cs typeface="Quattrocento Sans" pitchFamily="34" charset="-120"/>
+              </a:rPr>
+              <a:t>, caused by one 900,000 typo and a duplicated row.</a:t>
+            </a:r>
+            <a:endParaRPr lang="en-US" sz="1600" dirty="0"/>
+          </a:p>
+        </p:txBody>
+      </p:sp>
+      <p:sp>
+        <p:nvSpPr>
+          <p:cNvPr id="9" name="Shape 7"/>
+          <p:cNvSpPr/>
+          <p:nvPr/>
+        </p:nvSpPr>
+        <p:spPr>
+          <a:xfrm>
+            <a:off x="8318500" y="1587500"/>
+            <a:ext cx="7175500" cy="3238500"/>
+          </a:xfrm>
+          <a:prstGeom prst="rect">
+            <a:avLst/>
+          </a:prstGeom>
+          <a:solidFill>
+            <a:srgbClr val="1A2634"/>
+          </a:solidFill>
+          <a:ln/>
+        </p:spPr>
+      </p:sp>
+      <p:sp>
+        <p:nvSpPr>
+          <p:cNvPr id="10" name="Text 8"/>
+          <p:cNvSpPr/>
+          <p:nvPr/>
+        </p:nvSpPr>
+        <p:spPr>
+          <a:xfrm>
+            <a:off x="8636000" y="1778000"/>
+            <a:ext cx="1016000" cy="508000"/>
+          </a:xfrm>
+          <a:prstGeom prst="rect">
+            <a:avLst/>
+          </a:prstGeom>
+          <a:noFill/>
+          <a:ln/>
+        </p:spPr>
+        <p:txBody>
+          <a:bodyPr wrap="none" lIns="0" tIns="0" rIns="0" bIns="0" rtlCol="0" anchor="t"/>
+          <a:lstStyle/>
+          <a:p>
+            <a:pPr algn="l">
+              <a:lnSpc>
+                <a:spcPct val="120000"/>
+              </a:lnSpc>
+            </a:pPr>
+            <a:r>
+              <a:rPr lang="en-US" sz="3200" dirty="0">
+                <a:solidFill>
+                  <a:srgbClr val="F5A623"/>
+                </a:solidFill>
+                <a:latin typeface="Liter" pitchFamily="34" charset="0"/>
+                <a:ea typeface="Liter" pitchFamily="34" charset="-122"/>
+                <a:cs typeface="Liter" pitchFamily="34" charset="-120"/>
+              </a:rPr>
+              <a:t>02</a:t>
+            </a:r>
+            <a:endParaRPr lang="en-US" sz="3200" dirty="0"/>
+          </a:p>
+        </p:txBody>
+      </p:sp>
+      <p:sp>
+        <p:nvSpPr>
+          <p:cNvPr id="11" name="Text 9"/>
+          <p:cNvSpPr/>
+          <p:nvPr/>
+        </p:nvSpPr>
+        <p:spPr>
+          <a:xfrm>
+            <a:off x="8636000" y="2349500"/>
+            <a:ext cx="6540500" cy="355600"/>
+          </a:xfrm>
+          <a:prstGeom prst="rect">
+            <a:avLst/>
+          </a:prstGeom>
+          <a:noFill/>
+          <a:ln/>
+        </p:spPr>
+        <p:txBody>
+          <a:bodyPr wrap="none" lIns="0" tIns="0" rIns="0" bIns="0" rtlCol="0" anchor="ctr"/>
+          <a:lstStyle/>
+          <a:p>
+            <a:pPr algn="l">
+              <a:lnSpc>
+                <a:spcPct val="120000"/>
+              </a:lnSpc>
+            </a:pPr>
+            <a:r>
+              <a:rPr lang="en-US" sz="2000" dirty="0">
+                <a:solidFill>
+                  <a:srgbClr val="F0F2F5"/>
+                </a:solidFill>
+                <a:latin typeface="Liter" pitchFamily="34" charset="0"/>
+                <a:ea typeface="Liter" pitchFamily="34" charset="-122"/>
+                <a:cs typeface="Liter" pitchFamily="34" charset="-120"/>
+              </a:rPr>
+              <a:t>Diana’s City Is Assumed</a:t>
+            </a:r>
+            <a:endParaRPr lang="en-US" sz="2000" dirty="0"/>
+          </a:p>
+        </p:txBody>
+      </p:sp>
+      <p:sp>
+        <p:nvSpPr>
+          <p:cNvPr id="12" name="Text 10"/>
+          <p:cNvSpPr/>
+          <p:nvPr/>
+        </p:nvSpPr>
+        <p:spPr>
+          <a:xfrm>
+            <a:off x="8636000" y="2794000"/>
+            <a:ext cx="6540500" cy="1714500"/>
+          </a:xfrm>
+          <a:prstGeom prst="rect">
+            <a:avLst/>
+          </a:prstGeom>
+          <a:noFill/>
+          <a:ln/>
+        </p:spPr>
+        <p:txBody>
+          <a:bodyPr wrap="square" lIns="0" tIns="0" rIns="0" bIns="0" rtlCol="0" anchor="t"/>
+          <a:lstStyle/>
+          <a:p>
+            <a:pPr algn="l">
+              <a:lnSpc>
+                <a:spcPct val="160000"/>
+              </a:lnSpc>
+            </a:pPr>
+            <a:r>
+              <a:rPr lang="en-US" sz="1600" dirty="0">
+                <a:solidFill>
+                  <a:srgbClr val="2DD4BF"/>
+                </a:solidFill>
+                <a:latin typeface="Quattrocento Sans" pitchFamily="34" charset="0"/>
+                <a:ea typeface="Quattrocento Sans" pitchFamily="34" charset="-122"/>
+                <a:cs typeface="Quattrocento Sans" pitchFamily="34" charset="-120"/>
+              </a:rPr>
+              <a:t>Kisumu</a:t>
+            </a:r>
+            <a:r>
+              <a:rPr lang="en-US" sz="1600" dirty="0">
+                <a:solidFill>
+                  <a:srgbClr val="8B95A5"/>
+                </a:solidFill>
+                <a:latin typeface="Quattrocento Sans" pitchFamily="34" charset="0"/>
+                <a:ea typeface="Quattrocento Sans" pitchFamily="34" charset="-122"/>
+                <a:cs typeface="Quattrocento Sans" pitchFamily="34" charset="-120"/>
+              </a:rPr>
+              <a:t> was assumed, not recovered. Location cannot be derived from age, salary or join date, and the </a:t>
+            </a:r>
+            <a:r>
+              <a:rPr lang="en-US" sz="1600" b="1" dirty="0">
+                <a:solidFill>
+                  <a:srgbClr val="F0F2F5"/>
+                </a:solidFill>
+                <a:latin typeface="Quattrocento Sans" pitchFamily="34" charset="0"/>
+                <a:ea typeface="Quattrocento Sans" pitchFamily="34" charset="-122"/>
+                <a:cs typeface="Quattrocento Sans" pitchFamily="34" charset="-120"/>
+              </a:rPr>
+              <a:t>mode is not unique</a:t>
+            </a:r>
+            <a:r>
+              <a:rPr lang="en-US" sz="1600" dirty="0">
+                <a:solidFill>
+                  <a:srgbClr val="8B95A5"/>
+                </a:solidFill>
+                <a:latin typeface="Quattrocento Sans" pitchFamily="34" charset="0"/>
+                <a:ea typeface="Quattrocento Sans" pitchFamily="34" charset="-122"/>
+                <a:cs typeface="Quattrocento Sans" pitchFamily="34" charset="-120"/>
+              </a:rPr>
+              <a:t> (3-way tie). </a:t>
+            </a:r>
+            <a:r>
+              <a:rPr lang="en-US" sz="1600" b="1" dirty="0">
+                <a:solidFill>
+                  <a:srgbClr val="F0F2F5"/>
+                </a:solidFill>
+                <a:latin typeface="Quattrocento Sans" pitchFamily="34" charset="0"/>
+                <a:ea typeface="Quattrocento Sans" pitchFamily="34" charset="-122"/>
+                <a:cs typeface="Quattrocento Sans" pitchFamily="34" charset="-120"/>
+              </a:rPr>
+              <a:t>KES 63,500</a:t>
+            </a:r>
+            <a:r>
+              <a:rPr lang="en-US" sz="1600" dirty="0">
+                <a:solidFill>
+                  <a:srgbClr val="8B95A5"/>
+                </a:solidFill>
+                <a:latin typeface="Quattrocento Sans" pitchFamily="34" charset="0"/>
+                <a:ea typeface="Quattrocento Sans" pitchFamily="34" charset="-122"/>
+                <a:cs typeface="Quattrocento Sans" pitchFamily="34" charset="-120"/>
+              </a:rPr>
+              <a:t> with it vs </a:t>
+            </a:r>
+            <a:r>
+              <a:rPr lang="en-US" sz="1600" b="1" dirty="0">
+                <a:solidFill>
+                  <a:srgbClr val="F0F2F5"/>
+                </a:solidFill>
+                <a:latin typeface="Quattrocento Sans" pitchFamily="34" charset="0"/>
+                <a:ea typeface="Quattrocento Sans" pitchFamily="34" charset="-122"/>
+                <a:cs typeface="Quattrocento Sans" pitchFamily="34" charset="-120"/>
+              </a:rPr>
+              <a:t>KES 60,250</a:t>
+            </a:r>
+            <a:r>
+              <a:rPr lang="en-US" sz="1600" dirty="0">
+                <a:solidFill>
+                  <a:srgbClr val="8B95A5"/>
+                </a:solidFill>
+                <a:latin typeface="Quattrocento Sans" pitchFamily="34" charset="0"/>
+                <a:ea typeface="Quattrocento Sans" pitchFamily="34" charset="-122"/>
+                <a:cs typeface="Quattrocento Sans" pitchFamily="34" charset="-120"/>
+              </a:rPr>
+              <a:t> without.</a:t>
+            </a:r>
+            <a:endParaRPr lang="en-US" sz="1600" dirty="0"/>
+          </a:p>
+        </p:txBody>
+      </p:sp>
+      <p:sp>
+        <p:nvSpPr>
+          <p:cNvPr id="13" name="Shape 11"/>
+          <p:cNvSpPr/>
+          <p:nvPr/>
+        </p:nvSpPr>
+        <p:spPr>
+          <a:xfrm>
+            <a:off x="762000" y="5207000"/>
+            <a:ext cx="7175500" cy="3238500"/>
+          </a:xfrm>
+          <a:prstGeom prst="rect">
+            <a:avLst/>
+          </a:prstGeom>
+          <a:solidFill>
+            <a:srgbClr val="1A2634"/>
+          </a:solidFill>
+          <a:ln/>
+        </p:spPr>
+      </p:sp>
+      <p:sp>
+        <p:nvSpPr>
+          <p:cNvPr id="14" name="Text 12"/>
+          <p:cNvSpPr/>
+          <p:nvPr/>
+        </p:nvSpPr>
+        <p:spPr>
+          <a:xfrm>
+            <a:off x="1079500" y="5397500"/>
+            <a:ext cx="1016000" cy="508000"/>
+          </a:xfrm>
+          <a:prstGeom prst="rect">
+            <a:avLst/>
+          </a:prstGeom>
+          <a:noFill/>
+          <a:ln/>
+        </p:spPr>
+        <p:txBody>
+          <a:bodyPr wrap="none" lIns="0" tIns="0" rIns="0" bIns="0" rtlCol="0" anchor="t"/>
+          <a:lstStyle/>
+          <a:p>
+            <a:pPr algn="l">
+              <a:lnSpc>
+                <a:spcPct val="120000"/>
+              </a:lnSpc>
+            </a:pPr>
+            <a:r>
+              <a:rPr lang="en-US" sz="3200" dirty="0">
+                <a:solidFill>
+                  <a:srgbClr val="F5A623"/>
+                </a:solidFill>
+                <a:latin typeface="Liter" pitchFamily="34" charset="0"/>
+                <a:ea typeface="Liter" pitchFamily="34" charset="-122"/>
+                <a:cs typeface="Liter" pitchFamily="34" charset="-120"/>
+              </a:rPr>
+              <a:t>03</a:t>
+            </a:r>
+            <a:endParaRPr lang="en-US" sz="3200" dirty="0"/>
+          </a:p>
+        </p:txBody>
+      </p:sp>
+      <p:sp>
+        <p:nvSpPr>
+          <p:cNvPr id="15" name="Text 13"/>
+          <p:cNvSpPr/>
+          <p:nvPr/>
+        </p:nvSpPr>
+        <p:spPr>
+          <a:xfrm>
+            <a:off x="1079500" y="5969000"/>
+            <a:ext cx="6540500" cy="355600"/>
+          </a:xfrm>
+          <a:prstGeom prst="rect">
+            <a:avLst/>
+          </a:prstGeom>
+          <a:noFill/>
+          <a:ln/>
+        </p:spPr>
+        <p:txBody>
+          <a:bodyPr wrap="none" lIns="0" tIns="0" rIns="0" bIns="0" rtlCol="0" anchor="ctr"/>
+          <a:lstStyle/>
+          <a:p>
+            <a:pPr algn="l">
+              <a:lnSpc>
+                <a:spcPct val="120000"/>
+              </a:lnSpc>
+            </a:pPr>
+            <a:r>
+              <a:rPr lang="en-US" sz="2000" dirty="0">
+                <a:solidFill>
+                  <a:srgbClr val="F0F2F5"/>
+                </a:solidFill>
+                <a:latin typeface="Liter" pitchFamily="34" charset="0"/>
+                <a:ea typeface="Liter" pitchFamily="34" charset="-122"/>
+                <a:cs typeface="Liter" pitchFamily="34" charset="-120"/>
+              </a:rPr>
+              <a:t>ID 9’s Name Is a Placeholder</a:t>
+            </a:r>
+            <a:endParaRPr lang="en-US" sz="2000" dirty="0"/>
+          </a:p>
+        </p:txBody>
+      </p:sp>
+      <p:sp>
+        <p:nvSpPr>
+          <p:cNvPr id="16" name="Text 14"/>
+          <p:cNvSpPr/>
+          <p:nvPr/>
+        </p:nvSpPr>
+        <p:spPr>
+          <a:xfrm>
+            <a:off x="1079500" y="6413500"/>
+            <a:ext cx="6540500" cy="1714500"/>
+          </a:xfrm>
+          <a:prstGeom prst="rect">
+            <a:avLst/>
+          </a:prstGeom>
+          <a:noFill/>
+          <a:ln/>
+        </p:spPr>
+        <p:txBody>
+          <a:bodyPr wrap="square" lIns="0" tIns="0" rIns="0" bIns="0" rtlCol="0" anchor="t"/>
+          <a:lstStyle/>
+          <a:p>
+            <a:pPr algn="l">
+              <a:lnSpc>
+                <a:spcPct val="160000"/>
+              </a:lnSpc>
+            </a:pPr>
+            <a:r>
+              <a:rPr lang="en-US" sz="1600" b="1" dirty="0">
+                <a:solidFill>
+                  <a:srgbClr val="F0F2F5"/>
+                </a:solidFill>
+                <a:latin typeface="Quattrocento Sans" pitchFamily="34" charset="0"/>
+                <a:ea typeface="Quattrocento Sans" pitchFamily="34" charset="-122"/>
+                <a:cs typeface="Quattrocento Sans" pitchFamily="34" charset="-120"/>
+              </a:rPr>
+              <a:t>‘Jamal’</a:t>
+            </a:r>
+            <a:r>
+              <a:rPr lang="en-US" sz="1600" dirty="0">
+                <a:solidFill>
+                  <a:srgbClr val="8B95A5"/>
+                </a:solidFill>
+                <a:latin typeface="Quattrocento Sans" pitchFamily="34" charset="0"/>
+                <a:ea typeface="Quattrocento Sans" pitchFamily="34" charset="-122"/>
+                <a:cs typeface="Quattrocento Sans" pitchFamily="34" charset="-120"/>
+              </a:rPr>
+              <a:t> is a placeholder, not a recovery. Names carry </a:t>
+            </a:r>
+            <a:r>
+              <a:rPr lang="en-US" sz="1600" b="1" dirty="0">
+                <a:solidFill>
+                  <a:srgbClr val="F5A623"/>
+                </a:solidFill>
+                <a:latin typeface="Quattrocento Sans" pitchFamily="34" charset="0"/>
+                <a:ea typeface="Quattrocento Sans" pitchFamily="34" charset="-122"/>
+                <a:cs typeface="Quattrocento Sans" pitchFamily="34" charset="-120"/>
+              </a:rPr>
+              <a:t>no analytical weight</a:t>
+            </a:r>
+            <a:r>
+              <a:rPr lang="en-US" sz="1600" dirty="0">
+                <a:solidFill>
+                  <a:srgbClr val="8B95A5"/>
+                </a:solidFill>
+                <a:latin typeface="Quattrocento Sans" pitchFamily="34" charset="0"/>
+                <a:ea typeface="Quattrocento Sans" pitchFamily="34" charset="-122"/>
+                <a:cs typeface="Quattrocento Sans" pitchFamily="34" charset="-120"/>
+              </a:rPr>
+              <a:t> — no calculation touches this field, so the </a:t>
+            </a:r>
+            <a:r>
+              <a:rPr lang="en-US" sz="1600" b="1" dirty="0">
+                <a:solidFill>
+                  <a:srgbClr val="F0F2F5"/>
+                </a:solidFill>
+                <a:latin typeface="Quattrocento Sans" pitchFamily="34" charset="0"/>
+                <a:ea typeface="Quattrocento Sans" pitchFamily="34" charset="-122"/>
+                <a:cs typeface="Quattrocento Sans" pitchFamily="34" charset="-120"/>
+              </a:rPr>
+              <a:t>impact is none</a:t>
+            </a:r>
+            <a:r>
+              <a:rPr lang="en-US" sz="1600" dirty="0">
+                <a:solidFill>
+                  <a:srgbClr val="8B95A5"/>
+                </a:solidFill>
+                <a:latin typeface="Quattrocento Sans" pitchFamily="34" charset="0"/>
+                <a:ea typeface="Quattrocento Sans" pitchFamily="34" charset="-122"/>
+                <a:cs typeface="Quattrocento Sans" pitchFamily="34" charset="-120"/>
+              </a:rPr>
+              <a:t>.</a:t>
+            </a:r>
+            <a:endParaRPr lang="en-US" sz="1600" dirty="0"/>
+          </a:p>
+        </p:txBody>
+      </p:sp>
+      <p:sp>
+        <p:nvSpPr>
+          <p:cNvPr id="17" name="Shape 15"/>
+          <p:cNvSpPr/>
+          <p:nvPr/>
+        </p:nvSpPr>
+        <p:spPr>
+          <a:xfrm>
+            <a:off x="8318500" y="5207000"/>
+            <a:ext cx="7175500" cy="3238500"/>
+          </a:xfrm>
+          <a:prstGeom prst="rect">
+            <a:avLst/>
+          </a:prstGeom>
+          <a:solidFill>
+            <a:srgbClr val="1A2634"/>
+          </a:solidFill>
+          <a:ln/>
+        </p:spPr>
+      </p:sp>
+      <p:sp>
+        <p:nvSpPr>
+          <p:cNvPr id="18" name="Text 16"/>
+          <p:cNvSpPr/>
+          <p:nvPr/>
+        </p:nvSpPr>
+        <p:spPr>
+          <a:xfrm>
+            <a:off x="8636000" y="5397500"/>
+            <a:ext cx="1016000" cy="508000"/>
+          </a:xfrm>
+          <a:prstGeom prst="rect">
+            <a:avLst/>
+          </a:prstGeom>
+          <a:noFill/>
+          <a:ln/>
+        </p:spPr>
+        <p:txBody>
+          <a:bodyPr wrap="none" lIns="0" tIns="0" rIns="0" bIns="0" rtlCol="0" anchor="t"/>
+          <a:lstStyle/>
+          <a:p>
+            <a:pPr algn="l">
+              <a:lnSpc>
+                <a:spcPct val="120000"/>
+              </a:lnSpc>
+            </a:pPr>
+            <a:r>
+              <a:rPr lang="en-US" sz="3200" dirty="0">
+                <a:solidFill>
+                  <a:srgbClr val="F5A623"/>
+                </a:solidFill>
+                <a:latin typeface="Liter" pitchFamily="34" charset="0"/>
+                <a:ea typeface="Liter" pitchFamily="34" charset="-122"/>
+                <a:cs typeface="Liter" pitchFamily="34" charset="-120"/>
+              </a:rPr>
+              <a:t>04</a:t>
+            </a:r>
+            <a:endParaRPr lang="en-US" sz="3200" dirty="0"/>
+          </a:p>
+        </p:txBody>
+      </p:sp>
+      <p:sp>
+        <p:nvSpPr>
+          <p:cNvPr id="19" name="Text 17"/>
+          <p:cNvSpPr/>
+          <p:nvPr/>
+        </p:nvSpPr>
+        <p:spPr>
+          <a:xfrm>
+            <a:off x="8636000" y="5969000"/>
+            <a:ext cx="6540500" cy="355600"/>
+          </a:xfrm>
+          <a:prstGeom prst="rect">
+            <a:avLst/>
+          </a:prstGeom>
+          <a:noFill/>
+          <a:ln/>
+        </p:spPr>
+        <p:txBody>
+          <a:bodyPr wrap="none" lIns="0" tIns="0" rIns="0" bIns="0" rtlCol="0" anchor="ctr"/>
+          <a:lstStyle/>
+          <a:p>
+            <a:pPr algn="l">
+              <a:lnSpc>
+                <a:spcPct val="120000"/>
+              </a:lnSpc>
+            </a:pPr>
+            <a:r>
+              <a:rPr lang="en-US" sz="2000" dirty="0">
+                <a:solidFill>
+                  <a:srgbClr val="F0F2F5"/>
+                </a:solidFill>
+                <a:latin typeface="Liter" pitchFamily="34" charset="0"/>
+                <a:ea typeface="Liter" pitchFamily="34" charset="-122"/>
+                <a:cs typeface="Liter" pitchFamily="34" charset="-120"/>
+              </a:rPr>
+              <a:t>Where Assumptions Matter</a:t>
+            </a:r>
+            <a:endParaRPr lang="en-US" sz="2000" dirty="0"/>
+          </a:p>
+        </p:txBody>
+      </p:sp>
+      <p:sp>
+        <p:nvSpPr>
+          <p:cNvPr id="20" name="Text 18"/>
+          <p:cNvSpPr/>
+          <p:nvPr/>
+        </p:nvSpPr>
+        <p:spPr>
+          <a:xfrm>
+            <a:off x="8636000" y="6413500"/>
+            <a:ext cx="6540500" cy="1714500"/>
+          </a:xfrm>
+          <a:prstGeom prst="rect">
+            <a:avLst/>
+          </a:prstGeom>
+          <a:noFill/>
+          <a:ln/>
+        </p:spPr>
+        <p:txBody>
+          <a:bodyPr wrap="square" lIns="0" tIns="0" rIns="0" bIns="0" rtlCol="0" anchor="t"/>
+          <a:lstStyle/>
+          <a:p>
+            <a:pPr algn="l">
+              <a:lnSpc>
+                <a:spcPct val="160000"/>
+              </a:lnSpc>
+            </a:pPr>
+            <a:r>
+              <a:rPr lang="en-US" sz="1600" dirty="0">
+                <a:solidFill>
+                  <a:srgbClr val="8B95A5"/>
+                </a:solidFill>
+                <a:latin typeface="Quattrocento Sans" pitchFamily="34" charset="0"/>
+                <a:ea typeface="Quattrocento Sans" pitchFamily="34" charset="-122"/>
+                <a:cs typeface="Quattrocento Sans" pitchFamily="34" charset="-120"/>
+              </a:rPr>
+              <a:t>A stakeholder deliverable would report both as </a:t>
+            </a:r>
+            <a:r>
+              <a:rPr lang="en-US" sz="1600" b="1" dirty="0">
+                <a:solidFill>
+                  <a:srgbClr val="F5A623"/>
+                </a:solidFill>
+                <a:latin typeface="Quattrocento Sans" pitchFamily="34" charset="0"/>
+                <a:ea typeface="Quattrocento Sans" pitchFamily="34" charset="-122"/>
+                <a:cs typeface="Quattrocento Sans" pitchFamily="34" charset="-120"/>
+              </a:rPr>
+              <a:t>Unknown</a:t>
+            </a:r>
+            <a:r>
+              <a:rPr lang="en-US" sz="1600" dirty="0">
+                <a:solidFill>
+                  <a:srgbClr val="8B95A5"/>
+                </a:solidFill>
+                <a:latin typeface="Quattrocento Sans" pitchFamily="34" charset="0"/>
+                <a:ea typeface="Quattrocento Sans" pitchFamily="34" charset="-122"/>
+                <a:cs typeface="Quattrocento Sans" pitchFamily="34" charset="-120"/>
+              </a:rPr>
+              <a:t> — </a:t>
+            </a:r>
+            <a:r>
+              <a:rPr lang="en-US" sz="1600" b="1" dirty="0">
+                <a:solidFill>
+                  <a:srgbClr val="F0F2F5"/>
+                </a:solidFill>
+                <a:latin typeface="Quattrocento Sans" pitchFamily="34" charset="0"/>
+                <a:ea typeface="Quattrocento Sans" pitchFamily="34" charset="-122"/>
+                <a:cs typeface="Quattrocento Sans" pitchFamily="34" charset="-120"/>
+              </a:rPr>
+              <a:t>8 of 9</a:t>
+            </a:r>
+            <a:r>
+              <a:rPr lang="en-US" sz="1600" dirty="0">
+                <a:solidFill>
+                  <a:srgbClr val="8B95A5"/>
+                </a:solidFill>
+                <a:latin typeface="Quattrocento Sans" pitchFamily="34" charset="0"/>
+                <a:ea typeface="Quattrocento Sans" pitchFamily="34" charset="-122"/>
+                <a:cs typeface="Quattrocento Sans" pitchFamily="34" charset="-120"/>
+              </a:rPr>
+              <a:t> employees in the city view. Total, mean, median, the 145% finding and the outlier check stay </a:t>
+            </a:r>
+            <a:r>
+              <a:rPr lang="en-US" sz="1600" b="1" dirty="0">
+                <a:solidFill>
+                  <a:srgbClr val="F0F2F5"/>
+                </a:solidFill>
+                <a:latin typeface="Quattrocento Sans" pitchFamily="34" charset="0"/>
+                <a:ea typeface="Quattrocento Sans" pitchFamily="34" charset="-122"/>
+                <a:cs typeface="Quattrocento Sans" pitchFamily="34" charset="-120"/>
+              </a:rPr>
+              <a:t>identical</a:t>
+            </a:r>
+            <a:r>
+              <a:rPr lang="en-US" sz="1600" dirty="0">
+                <a:solidFill>
+                  <a:srgbClr val="8B95A5"/>
+                </a:solidFill>
+                <a:latin typeface="Quattrocento Sans" pitchFamily="34" charset="0"/>
+                <a:ea typeface="Quattrocento Sans" pitchFamily="34" charset="-122"/>
+                <a:cs typeface="Quattrocento Sans" pitchFamily="34" charset="-120"/>
+              </a:rPr>
+              <a:t> either way.</a:t>
+            </a:r>
+            <a:endParaRPr lang="en-US" sz="1600" dirty="0"/>
+          </a:p>
+        </p:txBody>
+      </p:sp>
+    </p:spTree>
+  </p:cSld>
+  <p:clrMapOvr>
+    <a:masterClrMapping/>
+  </p:clrMapOvr>
 </p:sld>
 </file>
 
@@ -12858,7 +13822,7 @@
                 <a:ea typeface="Liter" pitchFamily="34" charset="-122"/>
                 <a:cs typeface="Liter" pitchFamily="34" charset="-120"/>
               </a:rPr>
-              <a:t>Data Quality Issues &amp; Resolutions</a:t>
+              <a:t>7 Data Defects + 1 Format Issue</a:t>
             </a:r>
             <a:endParaRPr lang="en-US" sz="3000" dirty="0"/>
           </a:p>
@@ -13459,7 +14423,7 @@
                           <a:ea typeface="Quattrocento Sans" pitchFamily="34" charset="-122"/>
                           <a:cs typeface="Quattrocento Sans" pitchFamily="34" charset="-120"/>
                         </a:rPr>
-                        <a:t>Filled with placeholder, corrected to 'Jamal'</a:t>
+                        <a:t>Filled with assumed placeholder ‘Jamal’</a:t>
                       </a:r>
                       <a:endParaRPr lang="en-US" sz="1600" dirty="0">
                         <a:latin typeface="Quattrocento Sans" charset="0"/>
@@ -14259,7 +15223,7 @@
                           <a:ea typeface="Quattrocento Sans" pitchFamily="34" charset="-122"/>
                           <a:cs typeface="Quattrocento Sans" pitchFamily="34" charset="-120"/>
                         </a:rPr>
-                        <a:t>Filled with mode (most frequent city)</a:t>
+                        <a:t>Assumed Kisumu — mode not unique (3-way tie)</a:t>
                       </a:r>
                       <a:endParaRPr lang="en-US" sz="1600" dirty="0">
                         <a:latin typeface="Quattrocento Sans" charset="0"/>

</xml_diff>

<commit_message>
Clarify that cleanup row IDs refer to the raw export
The cleaned CSV drops the duplicate row and renumbers the rest, so raw ID 5 (Diana) is ID 4 there and raw ID 9 is ID 8. The cleanup tables in the README, PDF and deck all cite raw IDs, so a reader opening the cleaned file would look up the wrong person. Add a one-line note at each table; the PDF stays at 5 pages and the deck at 16 slides.
</commit_message>
<xml_diff>
--- a/reports/Employee Salary & Headcount Dashboard.pptx
+++ b/reports/Employee Salary & Headcount Dashboard.pptx
@@ -3394,6 +3394,245 @@
 
 <file path=ppt/slides/slide10.xml><?xml version="1.0" encoding="utf-8"?>
 <p:sld xmlns:a="http://schemas.openxmlformats.org/drawingml/2006/main" xmlns:r="http://schemas.openxmlformats.org/officeDocument/2006/relationships" xmlns:p="http://schemas.openxmlformats.org/presentationml/2006/main">
+  <p:cSld name="Slide 9">
+    <p:spTree>
+      <p:nvGrpSpPr>
+        <p:cNvPr id="1" name=""/>
+        <p:cNvGrpSpPr/>
+        <p:nvPr/>
+      </p:nvGrpSpPr>
+      <p:grpSpPr>
+        <a:xfrm>
+          <a:off x="0" y="0"/>
+          <a:ext cx="0" cy="0"/>
+          <a:chOff x="0" y="0"/>
+          <a:chExt cx="0" cy="0"/>
+        </a:xfrm>
+      </p:grpSpPr>
+      <p:pic>
+        <p:nvPicPr>
+          <p:cNvPr id="2" name="Image 0" descr="https://kimi-img.moonshot.cn/pub/slides/okc/m77sgby2vvfiu/mnt/agents/output/employee-dashboard/images/4_57_808_Graphs_Charts_Dark_Royalty.png">    </p:cNvPr>
+          <p:cNvPicPr>
+            <a:picLocks noChangeAspect="1"/>
+          </p:cNvPicPr>
+          <p:nvPr/>
+        </p:nvPicPr>
+        <p:blipFill>
+          <a:blip r:embed="rId1"/>
+          <a:srcRect l="20719" r="20719" t="0" b="0"/>
+          <a:stretch/>
+        </p:blipFill>
+        <p:spPr>
+          <a:xfrm>
+            <a:off x="0" y="0"/>
+            <a:ext cx="16256000" cy="9144000"/>
+          </a:xfrm>
+          <a:prstGeom prst="rect">
+            <a:avLst/>
+          </a:prstGeom>
+        </p:spPr>
+      </p:pic>
+      <p:sp>
+        <p:nvSpPr>
+          <p:cNvPr id="3" name="Shape 0"/>
+          <p:cNvSpPr/>
+          <p:nvPr/>
+        </p:nvSpPr>
+        <p:spPr>
+          <a:xfrm>
+            <a:off x="0" y="0"/>
+            <a:ext cx="16256000" cy="9144000"/>
+          </a:xfrm>
+          <a:prstGeom prst="rect">
+            <a:avLst/>
+          </a:prstGeom>
+          <a:gradFill rotWithShape="1" flip="none">
+            <a:gsLst>
+              <a:gs pos="0">
+                <a:srgbClr val="0F1923">
+                  <a:alpha val="91000"/>
+                </a:srgbClr>
+              </a:gs>
+              <a:gs pos="60000">
+                <a:srgbClr val="0F1923">
+                  <a:alpha val="75000"/>
+                </a:srgbClr>
+              </a:gs>
+              <a:gs pos="100000">
+                <a:srgbClr val="0F1923">
+                  <a:alpha val="38000"/>
+                </a:srgbClr>
+              </a:gs>
+            </a:gsLst>
+            <a:lin ang="0" scaled="1"/>
+          </a:gradFill>
+          <a:ln w="12700">
+            <a:solidFill>
+              <a:srgbClr val="FFFFFF">
+                <a:alpha val="0"/>
+              </a:srgbClr>
+            </a:solidFill>
+            <a:prstDash val="solid"/>
+          </a:ln>
+        </p:spPr>
+      </p:sp>
+      <p:sp>
+        <p:nvSpPr>
+          <p:cNvPr id="4" name="Text 1"/>
+          <p:cNvSpPr/>
+          <p:nvPr/>
+        </p:nvSpPr>
+        <p:spPr>
+          <a:xfrm>
+            <a:off x="762000" y="2032000"/>
+            <a:ext cx="5080000" cy="2032000"/>
+          </a:xfrm>
+          <a:prstGeom prst="rect">
+            <a:avLst/>
+          </a:prstGeom>
+          <a:noFill/>
+          <a:ln/>
+        </p:spPr>
+        <p:txBody>
+          <a:bodyPr wrap="none" lIns="0" tIns="0" rIns="0" bIns="0" rtlCol="0" anchor="t"/>
+          <a:lstStyle/>
+          <a:p>
+            <a:pPr algn="l">
+              <a:lnSpc>
+                <a:spcPct val="120000"/>
+              </a:lnSpc>
+            </a:pPr>
+            <a:r>
+              <a:rPr lang="en-US" sz="12000" dirty="0">
+                <a:solidFill>
+                  <a:srgbClr val="F5A623"/>
+                </a:solidFill>
+                <a:latin typeface="Liter" pitchFamily="34" charset="0"/>
+                <a:ea typeface="Liter" pitchFamily="34" charset="-122"/>
+                <a:cs typeface="Liter" pitchFamily="34" charset="-120"/>
+              </a:rPr>
+              <a:t>04</a:t>
+            </a:r>
+            <a:endParaRPr lang="en-US" sz="12000" dirty="0"/>
+          </a:p>
+        </p:txBody>
+      </p:sp>
+      <p:sp>
+        <p:nvSpPr>
+          <p:cNvPr id="5" name="Text 2"/>
+          <p:cNvSpPr/>
+          <p:nvPr/>
+        </p:nvSpPr>
+        <p:spPr>
+          <a:xfrm>
+            <a:off x="762000" y="4191000"/>
+            <a:ext cx="7620000" cy="762000"/>
+          </a:xfrm>
+          <a:prstGeom prst="rect">
+            <a:avLst/>
+          </a:prstGeom>
+          <a:noFill/>
+          <a:ln/>
+        </p:spPr>
+        <p:txBody>
+          <a:bodyPr wrap="none" lIns="0" tIns="0" rIns="0" bIns="0" rtlCol="0" anchor="ctr"/>
+          <a:lstStyle/>
+          <a:p>
+            <a:pPr algn="l">
+              <a:lnSpc>
+                <a:spcPct val="120000"/>
+              </a:lnSpc>
+            </a:pPr>
+            <a:r>
+              <a:rPr lang="en-US" sz="4400" spc="300" kern="0" dirty="0">
+                <a:solidFill>
+                  <a:srgbClr val="F0F2F5"/>
+                </a:solidFill>
+                <a:latin typeface="Liter" pitchFamily="34" charset="0"/>
+                <a:ea typeface="Liter" pitchFamily="34" charset="-122"/>
+                <a:cs typeface="Liter" pitchFamily="34" charset="-120"/>
+              </a:rPr>
+              <a:t>SALARY ANALYSIS</a:t>
+            </a:r>
+            <a:endParaRPr lang="en-US" sz="4400" dirty="0"/>
+          </a:p>
+        </p:txBody>
+      </p:sp>
+      <p:sp>
+        <p:nvSpPr>
+          <p:cNvPr id="6" name="Shape 3"/>
+          <p:cNvSpPr/>
+          <p:nvPr/>
+        </p:nvSpPr>
+        <p:spPr>
+          <a:xfrm>
+            <a:off x="762000" y="5143500"/>
+            <a:ext cx="1016000" cy="38100"/>
+          </a:xfrm>
+          <a:prstGeom prst="rect">
+            <a:avLst/>
+          </a:prstGeom>
+          <a:solidFill>
+            <a:srgbClr val="F5A623"/>
+          </a:solidFill>
+          <a:ln/>
+        </p:spPr>
+      </p:sp>
+      <p:sp>
+        <p:nvSpPr>
+          <p:cNvPr id="7" name="Text 4"/>
+          <p:cNvSpPr/>
+          <p:nvPr/>
+        </p:nvSpPr>
+        <p:spPr>
+          <a:xfrm>
+            <a:off x="762000" y="5397500"/>
+            <a:ext cx="8890000" cy="444500"/>
+          </a:xfrm>
+          <a:prstGeom prst="rect">
+            <a:avLst/>
+          </a:prstGeom>
+          <a:noFill/>
+          <a:ln/>
+        </p:spPr>
+        <p:txBody>
+          <a:bodyPr wrap="none" lIns="0" tIns="0" rIns="0" bIns="0" rtlCol="0" anchor="ctr"/>
+          <a:lstStyle/>
+          <a:p>
+            <a:pPr algn="l">
+              <a:lnSpc>
+                <a:spcPct val="120000"/>
+              </a:lnSpc>
+            </a:pPr>
+            <a:r>
+              <a:rPr lang="en-US" sz="2000" dirty="0">
+                <a:solidFill>
+                  <a:srgbClr val="8B95A5"/>
+                </a:solidFill>
+                <a:latin typeface="Quattrocento Sans" pitchFamily="34" charset="0"/>
+                <a:ea typeface="Quattrocento Sans" pitchFamily="34" charset="-122"/>
+                <a:cs typeface="Quattrocento Sans" pitchFamily="34" charset="-120"/>
+              </a:rPr>
+              <a:t>Deep dive into compensation patterns across cities and individuals</a:t>
+            </a:r>
+            <a:endParaRPr lang="en-US" sz="2000" dirty="0"/>
+          </a:p>
+        </p:txBody>
+      </p:sp>
+    </p:spTree>
+  </p:cSld>
+  <p:clrMapOvr>
+    <a:masterClrMapping/>
+  </p:clrMapOvr>
+  <p:transition>
+    <p:fade/>
+    <p:spd val="med"/>
+  </p:transition>
+</p:sld>
+</file>
+
+<file path=ppt/slides/slide11.xml><?xml version="1.0" encoding="utf-8"?>
+<p:sld xmlns:a="http://schemas.openxmlformats.org/drawingml/2006/main" xmlns:r="http://schemas.openxmlformats.org/officeDocument/2006/relationships" xmlns:p="http://schemas.openxmlformats.org/presentationml/2006/main">
   <p:cSld name="Slide 10">
     <p:bg>
       <p:bgPr>
@@ -4171,7 +4410,7 @@
 </p:sld>
 </file>
 
-<file path=ppt/slides/slide11.xml><?xml version="1.0" encoding="utf-8"?>
+<file path=ppt/slides/slide12.xml><?xml version="1.0" encoding="utf-8"?>
 <p:sld xmlns:a="http://schemas.openxmlformats.org/drawingml/2006/main" xmlns:r="http://schemas.openxmlformats.org/officeDocument/2006/relationships" xmlns:p="http://schemas.openxmlformats.org/presentationml/2006/main">
   <p:cSld name="Slide 11">
     <p:bg>
@@ -7703,7 +7942,7 @@
 </p:sld>
 </file>
 
-<file path=ppt/slides/slide12.xml><?xml version="1.0" encoding="utf-8"?>
+<file path=ppt/slides/slide13.xml><?xml version="1.0" encoding="utf-8"?>
 <p:sld xmlns:a="http://schemas.openxmlformats.org/drawingml/2006/main" xmlns:r="http://schemas.openxmlformats.org/officeDocument/2006/relationships" xmlns:p="http://schemas.openxmlformats.org/presentationml/2006/main">
   <p:cSld name="Slide 12">
     <p:spTree>
@@ -7942,7 +8181,7 @@
 </p:sld>
 </file>
 
-<file path=ppt/slides/slide13.xml><?xml version="1.0" encoding="utf-8"?>
+<file path=ppt/slides/slide14.xml><?xml version="1.0" encoding="utf-8"?>
 <p:sld xmlns:a="http://schemas.openxmlformats.org/drawingml/2006/main" xmlns:r="http://schemas.openxmlformats.org/officeDocument/2006/relationships" xmlns:p="http://schemas.openxmlformats.org/presentationml/2006/main">
   <p:cSld name="Slide 13">
     <p:bg>
@@ -8429,7 +8668,7 @@
 </p:sld>
 </file>
 
-<file path=ppt/slides/slide14.xml><?xml version="1.0" encoding="utf-8"?>
+<file path=ppt/slides/slide15.xml><?xml version="1.0" encoding="utf-8"?>
 <p:sld xmlns:a="http://schemas.openxmlformats.org/drawingml/2006/main" xmlns:r="http://schemas.openxmlformats.org/officeDocument/2006/relationships" xmlns:p="http://schemas.openxmlformats.org/presentationml/2006/main">
   <p:cSld name="Slide 14">
     <p:bg>
@@ -9491,7 +9730,7 @@
 </p:sld>
 </file>
 
-<file path=ppt/slides/slide15.xml><?xml version="1.0" encoding="utf-8"?>
+<file path=ppt/slides/slide16.xml><?xml version="1.0" encoding="utf-8"?>
 <p:sld xmlns:a="http://schemas.openxmlformats.org/drawingml/2006/main" xmlns:r="http://schemas.openxmlformats.org/officeDocument/2006/relationships" xmlns:p="http://schemas.openxmlformats.org/presentationml/2006/main">
   <p:cSld name="Slide 15">
     <p:spTree>
@@ -9784,969 +10023,6 @@
     <p:fade/>
     <p:spd val="med"/>
   </p:transition>
-</p:sld>
-</file>
-
-<file path=ppt/slides/slide16.xml><?xml version="1.0" encoding="utf-8"?>
-<p:sld xmlns:a="http://schemas.openxmlformats.org/drawingml/2006/main" xmlns:p="http://schemas.openxmlformats.org/presentationml/2006/main" xmlns:r="http://schemas.openxmlformats.org/officeDocument/2006/relationships">
-  <p:cSld>
-    <p:bg>
-      <p:bgPr>
-        <a:solidFill>
-          <a:srgbClr val="0F1923"/>
-        </a:solidFill>
-      </p:bgPr>
-    </p:bg>
-    <p:spTree>
-      <p:nvGrpSpPr>
-        <p:cNvPr id="1" name=""/>
-        <p:cNvGrpSpPr/>
-        <p:nvPr/>
-      </p:nvGrpSpPr>
-      <p:grpSpPr/>
-      <p:sp>
-        <p:nvSpPr>
-          <p:cNvPr id="2" name="Text 0"/>
-          <p:cNvSpPr/>
-          <p:nvPr/>
-        </p:nvSpPr>
-        <p:spPr>
-          <a:xfrm>
-            <a:off x="13208000" y="8636000"/>
-            <a:ext cx="2540000" cy="254000"/>
-          </a:xfrm>
-          <a:prstGeom prst="rect">
-            <a:avLst/>
-          </a:prstGeom>
-          <a:noFill/>
-          <a:ln/>
-        </p:spPr>
-        <p:txBody>
-          <a:bodyPr wrap="none" lIns="0" tIns="0" rIns="0" bIns="0" rtlCol="0" anchor="ctr"/>
-          <a:lstStyle/>
-          <a:p>
-            <a:pPr algn="r">
-              <a:lnSpc>
-                <a:spcPct val="120000"/>
-              </a:lnSpc>
-            </a:pPr>
-            <a:r>
-              <a:rPr lang="en-US" sz="1200" spc="200" kern="0" dirty="0">
-                <a:solidFill>
-                  <a:srgbClr val="8B95A5"/>
-                </a:solidFill>
-                <a:latin typeface="Liter" pitchFamily="34" charset="0"/>
-                <a:ea typeface="Liter" pitchFamily="34" charset="-122"/>
-                <a:cs typeface="Liter" pitchFamily="34" charset="-120"/>
-              </a:rPr>
-              <a:t>DATA CLEANING</a:t>
-            </a:r>
-            <a:endParaRPr lang="en-US" sz="1200" dirty="0"/>
-          </a:p>
-        </p:txBody>
-      </p:sp>
-      <p:sp>
-        <p:nvSpPr>
-          <p:cNvPr id="3" name="Text 1"/>
-          <p:cNvSpPr/>
-          <p:nvPr/>
-        </p:nvSpPr>
-        <p:spPr>
-          <a:xfrm>
-            <a:off x="762000" y="571500"/>
-            <a:ext cx="8890000" cy="533400"/>
-          </a:xfrm>
-          <a:prstGeom prst="rect">
-            <a:avLst/>
-          </a:prstGeom>
-          <a:noFill/>
-          <a:ln/>
-        </p:spPr>
-        <p:txBody>
-          <a:bodyPr wrap="none" lIns="0" tIns="0" rIns="0" bIns="0" rtlCol="0" anchor="ctr"/>
-          <a:lstStyle/>
-          <a:p>
-            <a:pPr algn="l">
-              <a:lnSpc>
-                <a:spcPct val="120000"/>
-              </a:lnSpc>
-            </a:pPr>
-            <a:r>
-              <a:rPr lang="en-US" sz="3000" dirty="0">
-                <a:solidFill>
-                  <a:srgbClr val="F0F2F5"/>
-                </a:solidFill>
-                <a:latin typeface="Liter" pitchFamily="34" charset="0"/>
-                <a:ea typeface="Liter" pitchFamily="34" charset="-122"/>
-                <a:cs typeface="Liter" pitchFamily="34" charset="-120"/>
-              </a:rPr>
-              <a:t>Cleaning Impact &amp; Honest Scope</a:t>
-            </a:r>
-            <a:endParaRPr lang="en-US" sz="3000" dirty="0"/>
-          </a:p>
-        </p:txBody>
-      </p:sp>
-      <p:sp>
-        <p:nvSpPr>
-          <p:cNvPr id="4" name="Shape 2"/>
-          <p:cNvSpPr/>
-          <p:nvPr/>
-        </p:nvSpPr>
-        <p:spPr>
-          <a:xfrm>
-            <a:off x="762000" y="1181100"/>
-            <a:ext cx="762000" cy="38100"/>
-          </a:xfrm>
-          <a:prstGeom prst="rect">
-            <a:avLst/>
-          </a:prstGeom>
-          <a:solidFill>
-            <a:srgbClr val="F5A623"/>
-          </a:solidFill>
-          <a:ln/>
-        </p:spPr>
-      </p:sp>
-      <p:sp>
-        <p:nvSpPr>
-          <p:cNvPr id="5" name="Shape 3"/>
-          <p:cNvSpPr/>
-          <p:nvPr/>
-        </p:nvSpPr>
-        <p:spPr>
-          <a:xfrm>
-            <a:off x="762000" y="1587500"/>
-            <a:ext cx="7175500" cy="3238500"/>
-          </a:xfrm>
-          <a:prstGeom prst="rect">
-            <a:avLst/>
-          </a:prstGeom>
-          <a:solidFill>
-            <a:srgbClr val="1A2634"/>
-          </a:solidFill>
-          <a:ln/>
-        </p:spPr>
-      </p:sp>
-      <p:sp>
-        <p:nvSpPr>
-          <p:cNvPr id="6" name="Text 4"/>
-          <p:cNvSpPr/>
-          <p:nvPr/>
-        </p:nvSpPr>
-        <p:spPr>
-          <a:xfrm>
-            <a:off x="1079500" y="1778000"/>
-            <a:ext cx="1016000" cy="508000"/>
-          </a:xfrm>
-          <a:prstGeom prst="rect">
-            <a:avLst/>
-          </a:prstGeom>
-          <a:noFill/>
-          <a:ln/>
-        </p:spPr>
-        <p:txBody>
-          <a:bodyPr wrap="none" lIns="0" tIns="0" rIns="0" bIns="0" rtlCol="0" anchor="t"/>
-          <a:lstStyle/>
-          <a:p>
-            <a:pPr algn="l">
-              <a:lnSpc>
-                <a:spcPct val="120000"/>
-              </a:lnSpc>
-            </a:pPr>
-            <a:r>
-              <a:rPr lang="en-US" sz="3200" dirty="0">
-                <a:solidFill>
-                  <a:srgbClr val="F5A623"/>
-                </a:solidFill>
-                <a:latin typeface="Liter" pitchFamily="34" charset="0"/>
-                <a:ea typeface="Liter" pitchFamily="34" charset="-122"/>
-                <a:cs typeface="Liter" pitchFamily="34" charset="-120"/>
-              </a:rPr>
-              <a:t>01</a:t>
-            </a:r>
-            <a:endParaRPr lang="en-US" sz="3200" dirty="0"/>
-          </a:p>
-        </p:txBody>
-      </p:sp>
-      <p:sp>
-        <p:nvSpPr>
-          <p:cNvPr id="7" name="Text 5"/>
-          <p:cNvSpPr/>
-          <p:nvPr/>
-        </p:nvSpPr>
-        <p:spPr>
-          <a:xfrm>
-            <a:off x="1079500" y="2349500"/>
-            <a:ext cx="6540500" cy="355600"/>
-          </a:xfrm>
-          <a:prstGeom prst="rect">
-            <a:avLst/>
-          </a:prstGeom>
-          <a:noFill/>
-          <a:ln/>
-        </p:spPr>
-        <p:txBody>
-          <a:bodyPr wrap="none" lIns="0" tIns="0" rIns="0" bIns="0" rtlCol="0" anchor="ctr"/>
-          <a:lstStyle/>
-          <a:p>
-            <a:pPr algn="l">
-              <a:lnSpc>
-                <a:spcPct val="120000"/>
-              </a:lnSpc>
-            </a:pPr>
-            <a:r>
-              <a:rPr lang="en-US" sz="2000" dirty="0">
-                <a:solidFill>
-                  <a:srgbClr val="F0F2F5"/>
-                </a:solidFill>
-                <a:latin typeface="Liter" pitchFamily="34" charset="0"/>
-                <a:ea typeface="Liter" pitchFamily="34" charset="-122"/>
-                <a:cs typeface="Liter" pitchFamily="34" charset="-120"/>
-              </a:rPr>
-              <a:t>The 145% Finding</a:t>
-            </a:r>
-            <a:endParaRPr lang="en-US" sz="2000" dirty="0"/>
-          </a:p>
-        </p:txBody>
-      </p:sp>
-      <p:sp>
-        <p:nvSpPr>
-          <p:cNvPr id="8" name="Text 6"/>
-          <p:cNvSpPr/>
-          <p:nvPr/>
-        </p:nvSpPr>
-        <p:spPr>
-          <a:xfrm>
-            <a:off x="1079500" y="2794000"/>
-            <a:ext cx="6540500" cy="1714500"/>
-          </a:xfrm>
-          <a:prstGeom prst="rect">
-            <a:avLst/>
-          </a:prstGeom>
-          <a:noFill/>
-          <a:ln/>
-        </p:spPr>
-        <p:txBody>
-          <a:bodyPr wrap="square" lIns="0" tIns="0" rIns="0" bIns="0" rtlCol="0" anchor="t"/>
-          <a:lstStyle/>
-          <a:p>
-            <a:pPr algn="l">
-              <a:lnSpc>
-                <a:spcPct val="160000"/>
-              </a:lnSpc>
-            </a:pPr>
-            <a:r>
-              <a:rPr lang="en-US" sz="1600" dirty="0">
-                <a:solidFill>
-                  <a:srgbClr val="8B95A5"/>
-                </a:solidFill>
-                <a:latin typeface="Quattrocento Sans" pitchFamily="34" charset="0"/>
-                <a:ea typeface="Quattrocento Sans" pitchFamily="34" charset="-122"/>
-                <a:cs typeface="Quattrocento Sans" pitchFamily="34" charset="-120"/>
-              </a:rPr>
-              <a:t>Computed on the raw export, mean salary reads </a:t>
-            </a:r>
-            <a:r>
-              <a:rPr lang="en-US" sz="1600" b="1" dirty="0">
-                <a:solidFill>
-                  <a:srgbClr val="F5A623"/>
-                </a:solidFill>
-                <a:latin typeface="Quattrocento Sans" pitchFamily="34" charset="0"/>
-                <a:ea typeface="Quattrocento Sans" pitchFamily="34" charset="-122"/>
-                <a:cs typeface="Quattrocento Sans" pitchFamily="34" charset="-120"/>
-              </a:rPr>
-              <a:t>KES 151,111</a:t>
-            </a:r>
-            <a:r>
-              <a:rPr lang="en-US" sz="1600" dirty="0">
-                <a:solidFill>
-                  <a:srgbClr val="8B95A5"/>
-                </a:solidFill>
-                <a:latin typeface="Quattrocento Sans" pitchFamily="34" charset="0"/>
-                <a:ea typeface="Quattrocento Sans" pitchFamily="34" charset="-122"/>
-                <a:cs typeface="Quattrocento Sans" pitchFamily="34" charset="-120"/>
-              </a:rPr>
-              <a:t>; once cleaned it is </a:t>
-            </a:r>
-            <a:r>
-              <a:rPr lang="en-US" sz="1600" b="1" dirty="0">
-                <a:solidFill>
-                  <a:srgbClr val="F0F2F5"/>
-                </a:solidFill>
-                <a:latin typeface="Quattrocento Sans" pitchFamily="34" charset="0"/>
-                <a:ea typeface="Quattrocento Sans" pitchFamily="34" charset="-122"/>
-                <a:cs typeface="Quattrocento Sans" pitchFamily="34" charset="-120"/>
-              </a:rPr>
-              <a:t>KES 61,611</a:t>
-            </a:r>
-            <a:r>
-              <a:rPr lang="en-US" sz="1600" dirty="0">
-                <a:solidFill>
-                  <a:srgbClr val="8B95A5"/>
-                </a:solidFill>
-                <a:latin typeface="Quattrocento Sans" pitchFamily="34" charset="0"/>
-                <a:ea typeface="Quattrocento Sans" pitchFamily="34" charset="-122"/>
-                <a:cs typeface="Quattrocento Sans" pitchFamily="34" charset="-120"/>
-              </a:rPr>
-              <a:t> — an </a:t>
-            </a:r>
-            <a:r>
-              <a:rPr lang="en-US" sz="1600" b="1" dirty="0">
-                <a:solidFill>
-                  <a:srgbClr val="F5A623"/>
-                </a:solidFill>
-                <a:latin typeface="Quattrocento Sans" pitchFamily="34" charset="0"/>
-                <a:ea typeface="Quattrocento Sans" pitchFamily="34" charset="-122"/>
-                <a:cs typeface="Quattrocento Sans" pitchFamily="34" charset="-120"/>
-              </a:rPr>
-              <a:t>inflation of 145%</a:t>
-            </a:r>
-            <a:r>
-              <a:rPr lang="en-US" sz="1600" dirty="0">
-                <a:solidFill>
-                  <a:srgbClr val="8B95A5"/>
-                </a:solidFill>
-                <a:latin typeface="Quattrocento Sans" pitchFamily="34" charset="0"/>
-                <a:ea typeface="Quattrocento Sans" pitchFamily="34" charset="-122"/>
-                <a:cs typeface="Quattrocento Sans" pitchFamily="34" charset="-120"/>
-              </a:rPr>
-              <a:t>, caused by one 900,000 typo and a duplicated row.</a:t>
-            </a:r>
-            <a:endParaRPr lang="en-US" sz="1600" dirty="0"/>
-          </a:p>
-        </p:txBody>
-      </p:sp>
-      <p:sp>
-        <p:nvSpPr>
-          <p:cNvPr id="9" name="Shape 7"/>
-          <p:cNvSpPr/>
-          <p:nvPr/>
-        </p:nvSpPr>
-        <p:spPr>
-          <a:xfrm>
-            <a:off x="8318500" y="1587500"/>
-            <a:ext cx="7175500" cy="3238500"/>
-          </a:xfrm>
-          <a:prstGeom prst="rect">
-            <a:avLst/>
-          </a:prstGeom>
-          <a:solidFill>
-            <a:srgbClr val="1A2634"/>
-          </a:solidFill>
-          <a:ln/>
-        </p:spPr>
-      </p:sp>
-      <p:sp>
-        <p:nvSpPr>
-          <p:cNvPr id="10" name="Text 8"/>
-          <p:cNvSpPr/>
-          <p:nvPr/>
-        </p:nvSpPr>
-        <p:spPr>
-          <a:xfrm>
-            <a:off x="8636000" y="1778000"/>
-            <a:ext cx="1016000" cy="508000"/>
-          </a:xfrm>
-          <a:prstGeom prst="rect">
-            <a:avLst/>
-          </a:prstGeom>
-          <a:noFill/>
-          <a:ln/>
-        </p:spPr>
-        <p:txBody>
-          <a:bodyPr wrap="none" lIns="0" tIns="0" rIns="0" bIns="0" rtlCol="0" anchor="t"/>
-          <a:lstStyle/>
-          <a:p>
-            <a:pPr algn="l">
-              <a:lnSpc>
-                <a:spcPct val="120000"/>
-              </a:lnSpc>
-            </a:pPr>
-            <a:r>
-              <a:rPr lang="en-US" sz="3200" dirty="0">
-                <a:solidFill>
-                  <a:srgbClr val="F5A623"/>
-                </a:solidFill>
-                <a:latin typeface="Liter" pitchFamily="34" charset="0"/>
-                <a:ea typeface="Liter" pitchFamily="34" charset="-122"/>
-                <a:cs typeface="Liter" pitchFamily="34" charset="-120"/>
-              </a:rPr>
-              <a:t>02</a:t>
-            </a:r>
-            <a:endParaRPr lang="en-US" sz="3200" dirty="0"/>
-          </a:p>
-        </p:txBody>
-      </p:sp>
-      <p:sp>
-        <p:nvSpPr>
-          <p:cNvPr id="11" name="Text 9"/>
-          <p:cNvSpPr/>
-          <p:nvPr/>
-        </p:nvSpPr>
-        <p:spPr>
-          <a:xfrm>
-            <a:off x="8636000" y="2349500"/>
-            <a:ext cx="6540500" cy="355600"/>
-          </a:xfrm>
-          <a:prstGeom prst="rect">
-            <a:avLst/>
-          </a:prstGeom>
-          <a:noFill/>
-          <a:ln/>
-        </p:spPr>
-        <p:txBody>
-          <a:bodyPr wrap="none" lIns="0" tIns="0" rIns="0" bIns="0" rtlCol="0" anchor="ctr"/>
-          <a:lstStyle/>
-          <a:p>
-            <a:pPr algn="l">
-              <a:lnSpc>
-                <a:spcPct val="120000"/>
-              </a:lnSpc>
-            </a:pPr>
-            <a:r>
-              <a:rPr lang="en-US" sz="2000" dirty="0">
-                <a:solidFill>
-                  <a:srgbClr val="F0F2F5"/>
-                </a:solidFill>
-                <a:latin typeface="Liter" pitchFamily="34" charset="0"/>
-                <a:ea typeface="Liter" pitchFamily="34" charset="-122"/>
-                <a:cs typeface="Liter" pitchFamily="34" charset="-120"/>
-              </a:rPr>
-              <a:t>Diana’s City Is Assumed</a:t>
-            </a:r>
-            <a:endParaRPr lang="en-US" sz="2000" dirty="0"/>
-          </a:p>
-        </p:txBody>
-      </p:sp>
-      <p:sp>
-        <p:nvSpPr>
-          <p:cNvPr id="12" name="Text 10"/>
-          <p:cNvSpPr/>
-          <p:nvPr/>
-        </p:nvSpPr>
-        <p:spPr>
-          <a:xfrm>
-            <a:off x="8636000" y="2794000"/>
-            <a:ext cx="6540500" cy="1714500"/>
-          </a:xfrm>
-          <a:prstGeom prst="rect">
-            <a:avLst/>
-          </a:prstGeom>
-          <a:noFill/>
-          <a:ln/>
-        </p:spPr>
-        <p:txBody>
-          <a:bodyPr wrap="square" lIns="0" tIns="0" rIns="0" bIns="0" rtlCol="0" anchor="t"/>
-          <a:lstStyle/>
-          <a:p>
-            <a:pPr algn="l">
-              <a:lnSpc>
-                <a:spcPct val="160000"/>
-              </a:lnSpc>
-            </a:pPr>
-            <a:r>
-              <a:rPr lang="en-US" sz="1600" dirty="0">
-                <a:solidFill>
-                  <a:srgbClr val="2DD4BF"/>
-                </a:solidFill>
-                <a:latin typeface="Quattrocento Sans" pitchFamily="34" charset="0"/>
-                <a:ea typeface="Quattrocento Sans" pitchFamily="34" charset="-122"/>
-                <a:cs typeface="Quattrocento Sans" pitchFamily="34" charset="-120"/>
-              </a:rPr>
-              <a:t>Kisumu</a:t>
-            </a:r>
-            <a:r>
-              <a:rPr lang="en-US" sz="1600" dirty="0">
-                <a:solidFill>
-                  <a:srgbClr val="8B95A5"/>
-                </a:solidFill>
-                <a:latin typeface="Quattrocento Sans" pitchFamily="34" charset="0"/>
-                <a:ea typeface="Quattrocento Sans" pitchFamily="34" charset="-122"/>
-                <a:cs typeface="Quattrocento Sans" pitchFamily="34" charset="-120"/>
-              </a:rPr>
-              <a:t> was assumed, not recovered. Location cannot be derived from age, salary or join date, and the </a:t>
-            </a:r>
-            <a:r>
-              <a:rPr lang="en-US" sz="1600" b="1" dirty="0">
-                <a:solidFill>
-                  <a:srgbClr val="F0F2F5"/>
-                </a:solidFill>
-                <a:latin typeface="Quattrocento Sans" pitchFamily="34" charset="0"/>
-                <a:ea typeface="Quattrocento Sans" pitchFamily="34" charset="-122"/>
-                <a:cs typeface="Quattrocento Sans" pitchFamily="34" charset="-120"/>
-              </a:rPr>
-              <a:t>mode is not unique</a:t>
-            </a:r>
-            <a:r>
-              <a:rPr lang="en-US" sz="1600" dirty="0">
-                <a:solidFill>
-                  <a:srgbClr val="8B95A5"/>
-                </a:solidFill>
-                <a:latin typeface="Quattrocento Sans" pitchFamily="34" charset="0"/>
-                <a:ea typeface="Quattrocento Sans" pitchFamily="34" charset="-122"/>
-                <a:cs typeface="Quattrocento Sans" pitchFamily="34" charset="-120"/>
-              </a:rPr>
-              <a:t> (3-way tie). </a:t>
-            </a:r>
-            <a:r>
-              <a:rPr lang="en-US" sz="1600" b="1" dirty="0">
-                <a:solidFill>
-                  <a:srgbClr val="F0F2F5"/>
-                </a:solidFill>
-                <a:latin typeface="Quattrocento Sans" pitchFamily="34" charset="0"/>
-                <a:ea typeface="Quattrocento Sans" pitchFamily="34" charset="-122"/>
-                <a:cs typeface="Quattrocento Sans" pitchFamily="34" charset="-120"/>
-              </a:rPr>
-              <a:t>KES 63,500</a:t>
-            </a:r>
-            <a:r>
-              <a:rPr lang="en-US" sz="1600" dirty="0">
-                <a:solidFill>
-                  <a:srgbClr val="8B95A5"/>
-                </a:solidFill>
-                <a:latin typeface="Quattrocento Sans" pitchFamily="34" charset="0"/>
-                <a:ea typeface="Quattrocento Sans" pitchFamily="34" charset="-122"/>
-                <a:cs typeface="Quattrocento Sans" pitchFamily="34" charset="-120"/>
-              </a:rPr>
-              <a:t> with it vs </a:t>
-            </a:r>
-            <a:r>
-              <a:rPr lang="en-US" sz="1600" b="1" dirty="0">
-                <a:solidFill>
-                  <a:srgbClr val="F0F2F5"/>
-                </a:solidFill>
-                <a:latin typeface="Quattrocento Sans" pitchFamily="34" charset="0"/>
-                <a:ea typeface="Quattrocento Sans" pitchFamily="34" charset="-122"/>
-                <a:cs typeface="Quattrocento Sans" pitchFamily="34" charset="-120"/>
-              </a:rPr>
-              <a:t>KES 60,250</a:t>
-            </a:r>
-            <a:r>
-              <a:rPr lang="en-US" sz="1600" dirty="0">
-                <a:solidFill>
-                  <a:srgbClr val="8B95A5"/>
-                </a:solidFill>
-                <a:latin typeface="Quattrocento Sans" pitchFamily="34" charset="0"/>
-                <a:ea typeface="Quattrocento Sans" pitchFamily="34" charset="-122"/>
-                <a:cs typeface="Quattrocento Sans" pitchFamily="34" charset="-120"/>
-              </a:rPr>
-              <a:t> without.</a:t>
-            </a:r>
-            <a:endParaRPr lang="en-US" sz="1600" dirty="0"/>
-          </a:p>
-        </p:txBody>
-      </p:sp>
-      <p:sp>
-        <p:nvSpPr>
-          <p:cNvPr id="13" name="Shape 11"/>
-          <p:cNvSpPr/>
-          <p:nvPr/>
-        </p:nvSpPr>
-        <p:spPr>
-          <a:xfrm>
-            <a:off x="762000" y="5207000"/>
-            <a:ext cx="7175500" cy="3238500"/>
-          </a:xfrm>
-          <a:prstGeom prst="rect">
-            <a:avLst/>
-          </a:prstGeom>
-          <a:solidFill>
-            <a:srgbClr val="1A2634"/>
-          </a:solidFill>
-          <a:ln/>
-        </p:spPr>
-      </p:sp>
-      <p:sp>
-        <p:nvSpPr>
-          <p:cNvPr id="14" name="Text 12"/>
-          <p:cNvSpPr/>
-          <p:nvPr/>
-        </p:nvSpPr>
-        <p:spPr>
-          <a:xfrm>
-            <a:off x="1079500" y="5397500"/>
-            <a:ext cx="1016000" cy="508000"/>
-          </a:xfrm>
-          <a:prstGeom prst="rect">
-            <a:avLst/>
-          </a:prstGeom>
-          <a:noFill/>
-          <a:ln/>
-        </p:spPr>
-        <p:txBody>
-          <a:bodyPr wrap="none" lIns="0" tIns="0" rIns="0" bIns="0" rtlCol="0" anchor="t"/>
-          <a:lstStyle/>
-          <a:p>
-            <a:pPr algn="l">
-              <a:lnSpc>
-                <a:spcPct val="120000"/>
-              </a:lnSpc>
-            </a:pPr>
-            <a:r>
-              <a:rPr lang="en-US" sz="3200" dirty="0">
-                <a:solidFill>
-                  <a:srgbClr val="F5A623"/>
-                </a:solidFill>
-                <a:latin typeface="Liter" pitchFamily="34" charset="0"/>
-                <a:ea typeface="Liter" pitchFamily="34" charset="-122"/>
-                <a:cs typeface="Liter" pitchFamily="34" charset="-120"/>
-              </a:rPr>
-              <a:t>03</a:t>
-            </a:r>
-            <a:endParaRPr lang="en-US" sz="3200" dirty="0"/>
-          </a:p>
-        </p:txBody>
-      </p:sp>
-      <p:sp>
-        <p:nvSpPr>
-          <p:cNvPr id="15" name="Text 13"/>
-          <p:cNvSpPr/>
-          <p:nvPr/>
-        </p:nvSpPr>
-        <p:spPr>
-          <a:xfrm>
-            <a:off x="1079500" y="5969000"/>
-            <a:ext cx="6540500" cy="355600"/>
-          </a:xfrm>
-          <a:prstGeom prst="rect">
-            <a:avLst/>
-          </a:prstGeom>
-          <a:noFill/>
-          <a:ln/>
-        </p:spPr>
-        <p:txBody>
-          <a:bodyPr wrap="none" lIns="0" tIns="0" rIns="0" bIns="0" rtlCol="0" anchor="ctr"/>
-          <a:lstStyle/>
-          <a:p>
-            <a:pPr algn="l">
-              <a:lnSpc>
-                <a:spcPct val="120000"/>
-              </a:lnSpc>
-            </a:pPr>
-            <a:r>
-              <a:rPr lang="en-US" sz="2000" dirty="0">
-                <a:solidFill>
-                  <a:srgbClr val="F0F2F5"/>
-                </a:solidFill>
-                <a:latin typeface="Liter" pitchFamily="34" charset="0"/>
-                <a:ea typeface="Liter" pitchFamily="34" charset="-122"/>
-                <a:cs typeface="Liter" pitchFamily="34" charset="-120"/>
-              </a:rPr>
-              <a:t>ID 9’s Name Is a Placeholder</a:t>
-            </a:r>
-            <a:endParaRPr lang="en-US" sz="2000" dirty="0"/>
-          </a:p>
-        </p:txBody>
-      </p:sp>
-      <p:sp>
-        <p:nvSpPr>
-          <p:cNvPr id="16" name="Text 14"/>
-          <p:cNvSpPr/>
-          <p:nvPr/>
-        </p:nvSpPr>
-        <p:spPr>
-          <a:xfrm>
-            <a:off x="1079500" y="6413500"/>
-            <a:ext cx="6540500" cy="1714500"/>
-          </a:xfrm>
-          <a:prstGeom prst="rect">
-            <a:avLst/>
-          </a:prstGeom>
-          <a:noFill/>
-          <a:ln/>
-        </p:spPr>
-        <p:txBody>
-          <a:bodyPr wrap="square" lIns="0" tIns="0" rIns="0" bIns="0" rtlCol="0" anchor="t"/>
-          <a:lstStyle/>
-          <a:p>
-            <a:pPr algn="l">
-              <a:lnSpc>
-                <a:spcPct val="160000"/>
-              </a:lnSpc>
-            </a:pPr>
-            <a:r>
-              <a:rPr lang="en-US" sz="1600" b="1" dirty="0">
-                <a:solidFill>
-                  <a:srgbClr val="F0F2F5"/>
-                </a:solidFill>
-                <a:latin typeface="Quattrocento Sans" pitchFamily="34" charset="0"/>
-                <a:ea typeface="Quattrocento Sans" pitchFamily="34" charset="-122"/>
-                <a:cs typeface="Quattrocento Sans" pitchFamily="34" charset="-120"/>
-              </a:rPr>
-              <a:t>‘Jamal’</a:t>
-            </a:r>
-            <a:r>
-              <a:rPr lang="en-US" sz="1600" dirty="0">
-                <a:solidFill>
-                  <a:srgbClr val="8B95A5"/>
-                </a:solidFill>
-                <a:latin typeface="Quattrocento Sans" pitchFamily="34" charset="0"/>
-                <a:ea typeface="Quattrocento Sans" pitchFamily="34" charset="-122"/>
-                <a:cs typeface="Quattrocento Sans" pitchFamily="34" charset="-120"/>
-              </a:rPr>
-              <a:t> is a placeholder, not a recovery. Names carry </a:t>
-            </a:r>
-            <a:r>
-              <a:rPr lang="en-US" sz="1600" b="1" dirty="0">
-                <a:solidFill>
-                  <a:srgbClr val="F5A623"/>
-                </a:solidFill>
-                <a:latin typeface="Quattrocento Sans" pitchFamily="34" charset="0"/>
-                <a:ea typeface="Quattrocento Sans" pitchFamily="34" charset="-122"/>
-                <a:cs typeface="Quattrocento Sans" pitchFamily="34" charset="-120"/>
-              </a:rPr>
-              <a:t>no analytical weight</a:t>
-            </a:r>
-            <a:r>
-              <a:rPr lang="en-US" sz="1600" dirty="0">
-                <a:solidFill>
-                  <a:srgbClr val="8B95A5"/>
-                </a:solidFill>
-                <a:latin typeface="Quattrocento Sans" pitchFamily="34" charset="0"/>
-                <a:ea typeface="Quattrocento Sans" pitchFamily="34" charset="-122"/>
-                <a:cs typeface="Quattrocento Sans" pitchFamily="34" charset="-120"/>
-              </a:rPr>
-              <a:t> — no calculation touches this field, so the </a:t>
-            </a:r>
-            <a:r>
-              <a:rPr lang="en-US" sz="1600" b="1" dirty="0">
-                <a:solidFill>
-                  <a:srgbClr val="F0F2F5"/>
-                </a:solidFill>
-                <a:latin typeface="Quattrocento Sans" pitchFamily="34" charset="0"/>
-                <a:ea typeface="Quattrocento Sans" pitchFamily="34" charset="-122"/>
-                <a:cs typeface="Quattrocento Sans" pitchFamily="34" charset="-120"/>
-              </a:rPr>
-              <a:t>impact is none</a:t>
-            </a:r>
-            <a:r>
-              <a:rPr lang="en-US" sz="1600" dirty="0">
-                <a:solidFill>
-                  <a:srgbClr val="8B95A5"/>
-                </a:solidFill>
-                <a:latin typeface="Quattrocento Sans" pitchFamily="34" charset="0"/>
-                <a:ea typeface="Quattrocento Sans" pitchFamily="34" charset="-122"/>
-                <a:cs typeface="Quattrocento Sans" pitchFamily="34" charset="-120"/>
-              </a:rPr>
-              <a:t>.</a:t>
-            </a:r>
-            <a:endParaRPr lang="en-US" sz="1600" dirty="0"/>
-          </a:p>
-        </p:txBody>
-      </p:sp>
-      <p:sp>
-        <p:nvSpPr>
-          <p:cNvPr id="17" name="Shape 15"/>
-          <p:cNvSpPr/>
-          <p:nvPr/>
-        </p:nvSpPr>
-        <p:spPr>
-          <a:xfrm>
-            <a:off x="8318500" y="5207000"/>
-            <a:ext cx="7175500" cy="3238500"/>
-          </a:xfrm>
-          <a:prstGeom prst="rect">
-            <a:avLst/>
-          </a:prstGeom>
-          <a:solidFill>
-            <a:srgbClr val="1A2634"/>
-          </a:solidFill>
-          <a:ln/>
-        </p:spPr>
-      </p:sp>
-      <p:sp>
-        <p:nvSpPr>
-          <p:cNvPr id="18" name="Text 16"/>
-          <p:cNvSpPr/>
-          <p:nvPr/>
-        </p:nvSpPr>
-        <p:spPr>
-          <a:xfrm>
-            <a:off x="8636000" y="5397500"/>
-            <a:ext cx="1016000" cy="508000"/>
-          </a:xfrm>
-          <a:prstGeom prst="rect">
-            <a:avLst/>
-          </a:prstGeom>
-          <a:noFill/>
-          <a:ln/>
-        </p:spPr>
-        <p:txBody>
-          <a:bodyPr wrap="none" lIns="0" tIns="0" rIns="0" bIns="0" rtlCol="0" anchor="t"/>
-          <a:lstStyle/>
-          <a:p>
-            <a:pPr algn="l">
-              <a:lnSpc>
-                <a:spcPct val="120000"/>
-              </a:lnSpc>
-            </a:pPr>
-            <a:r>
-              <a:rPr lang="en-US" sz="3200" dirty="0">
-                <a:solidFill>
-                  <a:srgbClr val="F5A623"/>
-                </a:solidFill>
-                <a:latin typeface="Liter" pitchFamily="34" charset="0"/>
-                <a:ea typeface="Liter" pitchFamily="34" charset="-122"/>
-                <a:cs typeface="Liter" pitchFamily="34" charset="-120"/>
-              </a:rPr>
-              <a:t>04</a:t>
-            </a:r>
-            <a:endParaRPr lang="en-US" sz="3200" dirty="0"/>
-          </a:p>
-        </p:txBody>
-      </p:sp>
-      <p:sp>
-        <p:nvSpPr>
-          <p:cNvPr id="19" name="Text 17"/>
-          <p:cNvSpPr/>
-          <p:nvPr/>
-        </p:nvSpPr>
-        <p:spPr>
-          <a:xfrm>
-            <a:off x="8636000" y="5969000"/>
-            <a:ext cx="6540500" cy="355600"/>
-          </a:xfrm>
-          <a:prstGeom prst="rect">
-            <a:avLst/>
-          </a:prstGeom>
-          <a:noFill/>
-          <a:ln/>
-        </p:spPr>
-        <p:txBody>
-          <a:bodyPr wrap="none" lIns="0" tIns="0" rIns="0" bIns="0" rtlCol="0" anchor="ctr"/>
-          <a:lstStyle/>
-          <a:p>
-            <a:pPr algn="l">
-              <a:lnSpc>
-                <a:spcPct val="120000"/>
-              </a:lnSpc>
-            </a:pPr>
-            <a:r>
-              <a:rPr lang="en-US" sz="2000" dirty="0">
-                <a:solidFill>
-                  <a:srgbClr val="F0F2F5"/>
-                </a:solidFill>
-                <a:latin typeface="Liter" pitchFamily="34" charset="0"/>
-                <a:ea typeface="Liter" pitchFamily="34" charset="-122"/>
-                <a:cs typeface="Liter" pitchFamily="34" charset="-120"/>
-              </a:rPr>
-              <a:t>Where Assumptions Matter</a:t>
-            </a:r>
-            <a:endParaRPr lang="en-US" sz="2000" dirty="0"/>
-          </a:p>
-        </p:txBody>
-      </p:sp>
-      <p:sp>
-        <p:nvSpPr>
-          <p:cNvPr id="20" name="Text 18"/>
-          <p:cNvSpPr/>
-          <p:nvPr/>
-        </p:nvSpPr>
-        <p:spPr>
-          <a:xfrm>
-            <a:off x="8636000" y="6413500"/>
-            <a:ext cx="6540500" cy="1714500"/>
-          </a:xfrm>
-          <a:prstGeom prst="rect">
-            <a:avLst/>
-          </a:prstGeom>
-          <a:noFill/>
-          <a:ln/>
-        </p:spPr>
-        <p:txBody>
-          <a:bodyPr wrap="square" lIns="0" tIns="0" rIns="0" bIns="0" rtlCol="0" anchor="t"/>
-          <a:lstStyle/>
-          <a:p>
-            <a:pPr algn="l">
-              <a:lnSpc>
-                <a:spcPct val="160000"/>
-              </a:lnSpc>
-            </a:pPr>
-            <a:r>
-              <a:rPr lang="en-US" sz="1600" dirty="0">
-                <a:solidFill>
-                  <a:srgbClr val="8B95A5"/>
-                </a:solidFill>
-                <a:latin typeface="Quattrocento Sans" pitchFamily="34" charset="0"/>
-                <a:ea typeface="Quattrocento Sans" pitchFamily="34" charset="-122"/>
-                <a:cs typeface="Quattrocento Sans" pitchFamily="34" charset="-120"/>
-              </a:rPr>
-              <a:t>A stakeholder deliverable would report both as </a:t>
-            </a:r>
-            <a:r>
-              <a:rPr lang="en-US" sz="1600" b="1" dirty="0">
-                <a:solidFill>
-                  <a:srgbClr val="F5A623"/>
-                </a:solidFill>
-                <a:latin typeface="Quattrocento Sans" pitchFamily="34" charset="0"/>
-                <a:ea typeface="Quattrocento Sans" pitchFamily="34" charset="-122"/>
-                <a:cs typeface="Quattrocento Sans" pitchFamily="34" charset="-120"/>
-              </a:rPr>
-              <a:t>Unknown</a:t>
-            </a:r>
-            <a:r>
-              <a:rPr lang="en-US" sz="1600" dirty="0">
-                <a:solidFill>
-                  <a:srgbClr val="8B95A5"/>
-                </a:solidFill>
-                <a:latin typeface="Quattrocento Sans" pitchFamily="34" charset="0"/>
-                <a:ea typeface="Quattrocento Sans" pitchFamily="34" charset="-122"/>
-                <a:cs typeface="Quattrocento Sans" pitchFamily="34" charset="-120"/>
-              </a:rPr>
-              <a:t> — </a:t>
-            </a:r>
-            <a:r>
-              <a:rPr lang="en-US" sz="1600" b="1" dirty="0">
-                <a:solidFill>
-                  <a:srgbClr val="F0F2F5"/>
-                </a:solidFill>
-                <a:latin typeface="Quattrocento Sans" pitchFamily="34" charset="0"/>
-                <a:ea typeface="Quattrocento Sans" pitchFamily="34" charset="-122"/>
-                <a:cs typeface="Quattrocento Sans" pitchFamily="34" charset="-120"/>
-              </a:rPr>
-              <a:t>8 of 9</a:t>
-            </a:r>
-            <a:r>
-              <a:rPr lang="en-US" sz="1600" dirty="0">
-                <a:solidFill>
-                  <a:srgbClr val="8B95A5"/>
-                </a:solidFill>
-                <a:latin typeface="Quattrocento Sans" pitchFamily="34" charset="0"/>
-                <a:ea typeface="Quattrocento Sans" pitchFamily="34" charset="-122"/>
-                <a:cs typeface="Quattrocento Sans" pitchFamily="34" charset="-120"/>
-              </a:rPr>
-              <a:t> employees in the city view. Total, mean, median, the 145% finding and the outlier check stay </a:t>
-            </a:r>
-            <a:r>
-              <a:rPr lang="en-US" sz="1600" b="1" dirty="0">
-                <a:solidFill>
-                  <a:srgbClr val="F0F2F5"/>
-                </a:solidFill>
-                <a:latin typeface="Quattrocento Sans" pitchFamily="34" charset="0"/>
-                <a:ea typeface="Quattrocento Sans" pitchFamily="34" charset="-122"/>
-                <a:cs typeface="Quattrocento Sans" pitchFamily="34" charset="-120"/>
-              </a:rPr>
-              <a:t>identical</a:t>
-            </a:r>
-            <a:r>
-              <a:rPr lang="en-US" sz="1600" dirty="0">
-                <a:solidFill>
-                  <a:srgbClr val="8B95A5"/>
-                </a:solidFill>
-                <a:latin typeface="Quattrocento Sans" pitchFamily="34" charset="0"/>
-                <a:ea typeface="Quattrocento Sans" pitchFamily="34" charset="-122"/>
-                <a:cs typeface="Quattrocento Sans" pitchFamily="34" charset="-120"/>
-              </a:rPr>
-              <a:t> either way.</a:t>
-            </a:r>
-            <a:endParaRPr lang="en-US" sz="1600" dirty="0"/>
-          </a:p>
-        </p:txBody>
-      </p:sp>
-    </p:spTree>
-  </p:cSld>
-  <p:clrMapOvr>
-    <a:masterClrMapping/>
-  </p:clrMapOvr>
 </p:sld>
 </file>
 
@@ -15692,6 +14968,985 @@
 </file>
 
 <file path=ppt/slides/slide7.xml><?xml version="1.0" encoding="utf-8"?>
+<p:sld xmlns:a="http://schemas.openxmlformats.org/drawingml/2006/main" xmlns:p="http://schemas.openxmlformats.org/presentationml/2006/main" xmlns:r="http://schemas.openxmlformats.org/officeDocument/2006/relationships">
+  <p:cSld>
+    <p:bg>
+      <p:bgPr>
+        <a:solidFill>
+          <a:srgbClr val="0F1923"/>
+        </a:solidFill>
+      </p:bgPr>
+    </p:bg>
+    <p:spTree>
+      <p:nvGrpSpPr>
+        <p:cNvPr id="1" name=""/>
+        <p:cNvGrpSpPr/>
+        <p:nvPr/>
+      </p:nvGrpSpPr>
+      <p:grpSpPr/>
+      <p:sp>
+        <p:nvSpPr>
+          <p:cNvPr id="2" name="Text 0"/>
+          <p:cNvSpPr/>
+          <p:nvPr/>
+        </p:nvSpPr>
+        <p:spPr>
+          <a:xfrm>
+            <a:off x="13208000" y="8636000"/>
+            <a:ext cx="2540000" cy="254000"/>
+          </a:xfrm>
+          <a:prstGeom prst="rect">
+            <a:avLst/>
+          </a:prstGeom>
+          <a:noFill/>
+          <a:ln/>
+        </p:spPr>
+        <p:txBody>
+          <a:bodyPr wrap="none" lIns="0" tIns="0" rIns="0" bIns="0" rtlCol="0" anchor="ctr"/>
+          <a:lstStyle/>
+          <a:p>
+            <a:pPr algn="r">
+              <a:lnSpc>
+                <a:spcPct val="120000"/>
+              </a:lnSpc>
+            </a:pPr>
+            <a:r>
+              <a:rPr lang="en-US" sz="1200" spc="200" kern="0" dirty="0">
+                <a:solidFill>
+                  <a:srgbClr val="8B95A5"/>
+                </a:solidFill>
+                <a:latin typeface="Liter" pitchFamily="34" charset="0"/>
+                <a:ea typeface="Liter" pitchFamily="34" charset="-122"/>
+                <a:cs typeface="Liter" pitchFamily="34" charset="-120"/>
+              </a:rPr>
+              <a:t>DATA CLEANING</a:t>
+            </a:r>
+            <a:endParaRPr lang="en-US" sz="1200" dirty="0"/>
+          </a:p>
+        </p:txBody>
+      </p:sp>
+      <p:sp>
+        <p:nvSpPr>
+          <p:cNvPr id="3" name="Text 1"/>
+          <p:cNvSpPr/>
+          <p:nvPr/>
+        </p:nvSpPr>
+        <p:spPr>
+          <a:xfrm>
+            <a:off x="762000" y="571500"/>
+            <a:ext cx="8890000" cy="533400"/>
+          </a:xfrm>
+          <a:prstGeom prst="rect">
+            <a:avLst/>
+          </a:prstGeom>
+          <a:noFill/>
+          <a:ln/>
+        </p:spPr>
+        <p:txBody>
+          <a:bodyPr wrap="none" lIns="0" tIns="0" rIns="0" bIns="0" rtlCol="0" anchor="ctr"/>
+          <a:lstStyle/>
+          <a:p>
+            <a:pPr algn="l">
+              <a:lnSpc>
+                <a:spcPct val="120000"/>
+              </a:lnSpc>
+            </a:pPr>
+            <a:r>
+              <a:rPr lang="en-US" sz="3000" dirty="0">
+                <a:solidFill>
+                  <a:srgbClr val="F0F2F5"/>
+                </a:solidFill>
+                <a:latin typeface="Liter" pitchFamily="34" charset="0"/>
+                <a:ea typeface="Liter" pitchFamily="34" charset="-122"/>
+                <a:cs typeface="Liter" pitchFamily="34" charset="-120"/>
+              </a:rPr>
+              <a:t>Cleaning Impact &amp; Honest Scope</a:t>
+            </a:r>
+            <a:endParaRPr lang="en-US" sz="3000" dirty="0"/>
+          </a:p>
+        </p:txBody>
+      </p:sp>
+      <p:sp>
+        <p:nvSpPr>
+          <p:cNvPr id="4" name="Shape 2"/>
+          <p:cNvSpPr/>
+          <p:nvPr/>
+        </p:nvSpPr>
+        <p:spPr>
+          <a:xfrm>
+            <a:off x="762000" y="1181100"/>
+            <a:ext cx="762000" cy="38100"/>
+          </a:xfrm>
+          <a:prstGeom prst="rect">
+            <a:avLst/>
+          </a:prstGeom>
+          <a:solidFill>
+            <a:srgbClr val="F5A623"/>
+          </a:solidFill>
+          <a:ln/>
+        </p:spPr>
+        <p:txBody>
+          <a:bodyPr/>
+          <a:p/>
+        </p:txBody>
+      </p:sp>
+      <p:sp>
+        <p:nvSpPr>
+          <p:cNvPr id="5" name="Shape 3"/>
+          <p:cNvSpPr/>
+          <p:nvPr/>
+        </p:nvSpPr>
+        <p:spPr>
+          <a:xfrm>
+            <a:off x="762000" y="1587500"/>
+            <a:ext cx="7175500" cy="3238500"/>
+          </a:xfrm>
+          <a:prstGeom prst="rect">
+            <a:avLst/>
+          </a:prstGeom>
+          <a:solidFill>
+            <a:srgbClr val="1A2634"/>
+          </a:solidFill>
+          <a:ln/>
+        </p:spPr>
+        <p:txBody>
+          <a:bodyPr/>
+          <a:p/>
+        </p:txBody>
+      </p:sp>
+      <p:sp>
+        <p:nvSpPr>
+          <p:cNvPr id="6" name="Text 4"/>
+          <p:cNvSpPr/>
+          <p:nvPr/>
+        </p:nvSpPr>
+        <p:spPr>
+          <a:xfrm>
+            <a:off x="1079500" y="1778000"/>
+            <a:ext cx="1016000" cy="508000"/>
+          </a:xfrm>
+          <a:prstGeom prst="rect">
+            <a:avLst/>
+          </a:prstGeom>
+          <a:noFill/>
+          <a:ln/>
+        </p:spPr>
+        <p:txBody>
+          <a:bodyPr wrap="none" lIns="0" tIns="0" rIns="0" bIns="0" rtlCol="0" anchor="t"/>
+          <a:lstStyle/>
+          <a:p>
+            <a:pPr algn="l">
+              <a:lnSpc>
+                <a:spcPct val="120000"/>
+              </a:lnSpc>
+            </a:pPr>
+            <a:r>
+              <a:rPr lang="en-US" sz="3200" dirty="0">
+                <a:solidFill>
+                  <a:srgbClr val="F5A623"/>
+                </a:solidFill>
+                <a:latin typeface="Liter" pitchFamily="34" charset="0"/>
+                <a:ea typeface="Liter" pitchFamily="34" charset="-122"/>
+                <a:cs typeface="Liter" pitchFamily="34" charset="-120"/>
+              </a:rPr>
+              <a:t>01</a:t>
+            </a:r>
+            <a:endParaRPr lang="en-US" sz="3200" dirty="0"/>
+          </a:p>
+        </p:txBody>
+      </p:sp>
+      <p:sp>
+        <p:nvSpPr>
+          <p:cNvPr id="7" name="Text 5"/>
+          <p:cNvSpPr/>
+          <p:nvPr/>
+        </p:nvSpPr>
+        <p:spPr>
+          <a:xfrm>
+            <a:off x="1079500" y="2349500"/>
+            <a:ext cx="6540500" cy="355600"/>
+          </a:xfrm>
+          <a:prstGeom prst="rect">
+            <a:avLst/>
+          </a:prstGeom>
+          <a:noFill/>
+          <a:ln/>
+        </p:spPr>
+        <p:txBody>
+          <a:bodyPr wrap="none" lIns="0" tIns="0" rIns="0" bIns="0" rtlCol="0" anchor="ctr"/>
+          <a:lstStyle/>
+          <a:p>
+            <a:pPr algn="l">
+              <a:lnSpc>
+                <a:spcPct val="120000"/>
+              </a:lnSpc>
+            </a:pPr>
+            <a:r>
+              <a:rPr lang="en-US" sz="2000" dirty="0">
+                <a:solidFill>
+                  <a:srgbClr val="F0F2F5"/>
+                </a:solidFill>
+                <a:latin typeface="Liter" pitchFamily="34" charset="0"/>
+                <a:ea typeface="Liter" pitchFamily="34" charset="-122"/>
+                <a:cs typeface="Liter" pitchFamily="34" charset="-120"/>
+              </a:rPr>
+              <a:t>The 145% Finding</a:t>
+            </a:r>
+            <a:endParaRPr lang="en-US" sz="2000" dirty="0"/>
+          </a:p>
+        </p:txBody>
+      </p:sp>
+      <p:sp>
+        <p:nvSpPr>
+          <p:cNvPr id="8" name="Text 6"/>
+          <p:cNvSpPr/>
+          <p:nvPr/>
+        </p:nvSpPr>
+        <p:spPr>
+          <a:xfrm>
+            <a:off x="1079500" y="2794000"/>
+            <a:ext cx="6540500" cy="1714500"/>
+          </a:xfrm>
+          <a:prstGeom prst="rect">
+            <a:avLst/>
+          </a:prstGeom>
+          <a:noFill/>
+          <a:ln/>
+        </p:spPr>
+        <p:txBody>
+          <a:bodyPr wrap="square" lIns="0" tIns="0" rIns="0" bIns="0" rtlCol="0" anchor="t"/>
+          <a:lstStyle/>
+          <a:p>
+            <a:pPr algn="l">
+              <a:lnSpc>
+                <a:spcPct val="160000"/>
+              </a:lnSpc>
+            </a:pPr>
+            <a:r>
+              <a:rPr lang="en-US" sz="1600" dirty="0">
+                <a:solidFill>
+                  <a:srgbClr val="8B95A5"/>
+                </a:solidFill>
+                <a:latin typeface="Quattrocento Sans" pitchFamily="34" charset="0"/>
+                <a:ea typeface="Quattrocento Sans" pitchFamily="34" charset="-122"/>
+                <a:cs typeface="Quattrocento Sans" pitchFamily="34" charset="-120"/>
+              </a:rPr>
+              <a:t>Computed on the raw export, mean salary reads </a:t>
+            </a:r>
+            <a:r>
+              <a:rPr lang="en-US" sz="1600" b="1" dirty="0">
+                <a:solidFill>
+                  <a:srgbClr val="F5A623"/>
+                </a:solidFill>
+                <a:latin typeface="Quattrocento Sans" pitchFamily="34" charset="0"/>
+                <a:ea typeface="Quattrocento Sans" pitchFamily="34" charset="-122"/>
+                <a:cs typeface="Quattrocento Sans" pitchFamily="34" charset="-120"/>
+              </a:rPr>
+              <a:t>KES 151,111</a:t>
+            </a:r>
+            <a:r>
+              <a:rPr lang="en-US" sz="1600" dirty="0">
+                <a:solidFill>
+                  <a:srgbClr val="8B95A5"/>
+                </a:solidFill>
+                <a:latin typeface="Quattrocento Sans" pitchFamily="34" charset="0"/>
+                <a:ea typeface="Quattrocento Sans" pitchFamily="34" charset="-122"/>
+                <a:cs typeface="Quattrocento Sans" pitchFamily="34" charset="-120"/>
+              </a:rPr>
+              <a:t>; once cleaned it is </a:t>
+            </a:r>
+            <a:r>
+              <a:rPr lang="en-US" sz="1600" b="1" dirty="0">
+                <a:solidFill>
+                  <a:srgbClr val="F0F2F5"/>
+                </a:solidFill>
+                <a:latin typeface="Quattrocento Sans" pitchFamily="34" charset="0"/>
+                <a:ea typeface="Quattrocento Sans" pitchFamily="34" charset="-122"/>
+                <a:cs typeface="Quattrocento Sans" pitchFamily="34" charset="-120"/>
+              </a:rPr>
+              <a:t>KES 61,611</a:t>
+            </a:r>
+            <a:r>
+              <a:rPr lang="en-US" sz="1600" dirty="0">
+                <a:solidFill>
+                  <a:srgbClr val="8B95A5"/>
+                </a:solidFill>
+                <a:latin typeface="Quattrocento Sans" pitchFamily="34" charset="0"/>
+                <a:ea typeface="Quattrocento Sans" pitchFamily="34" charset="-122"/>
+                <a:cs typeface="Quattrocento Sans" pitchFamily="34" charset="-120"/>
+              </a:rPr>
+              <a:t> — an </a:t>
+            </a:r>
+            <a:r>
+              <a:rPr lang="en-US" sz="1600" b="1" dirty="0">
+                <a:solidFill>
+                  <a:srgbClr val="F5A623"/>
+                </a:solidFill>
+                <a:latin typeface="Quattrocento Sans" pitchFamily="34" charset="0"/>
+                <a:ea typeface="Quattrocento Sans" pitchFamily="34" charset="-122"/>
+                <a:cs typeface="Quattrocento Sans" pitchFamily="34" charset="-120"/>
+              </a:rPr>
+              <a:t>inflation of 145%</a:t>
+            </a:r>
+            <a:r>
+              <a:rPr lang="en-US" sz="1600" dirty="0">
+                <a:solidFill>
+                  <a:srgbClr val="8B95A5"/>
+                </a:solidFill>
+                <a:latin typeface="Quattrocento Sans" pitchFamily="34" charset="0"/>
+                <a:ea typeface="Quattrocento Sans" pitchFamily="34" charset="-122"/>
+                <a:cs typeface="Quattrocento Sans" pitchFamily="34" charset="-120"/>
+              </a:rPr>
+              <a:t>, caused by one 900,000 typo and a duplicated row.</a:t>
+            </a:r>
+            <a:endParaRPr lang="en-US" sz="1600" dirty="0"/>
+          </a:p>
+        </p:txBody>
+      </p:sp>
+      <p:sp>
+        <p:nvSpPr>
+          <p:cNvPr id="9" name="Shape 7"/>
+          <p:cNvSpPr/>
+          <p:nvPr/>
+        </p:nvSpPr>
+        <p:spPr>
+          <a:xfrm>
+            <a:off x="8318500" y="1587500"/>
+            <a:ext cx="7175500" cy="3238500"/>
+          </a:xfrm>
+          <a:prstGeom prst="rect">
+            <a:avLst/>
+          </a:prstGeom>
+          <a:solidFill>
+            <a:srgbClr val="1A2634"/>
+          </a:solidFill>
+          <a:ln/>
+        </p:spPr>
+        <p:txBody>
+          <a:bodyPr/>
+          <a:p/>
+        </p:txBody>
+      </p:sp>
+      <p:sp>
+        <p:nvSpPr>
+          <p:cNvPr id="10" name="Text 8"/>
+          <p:cNvSpPr/>
+          <p:nvPr/>
+        </p:nvSpPr>
+        <p:spPr>
+          <a:xfrm>
+            <a:off x="8636000" y="1778000"/>
+            <a:ext cx="1016000" cy="508000"/>
+          </a:xfrm>
+          <a:prstGeom prst="rect">
+            <a:avLst/>
+          </a:prstGeom>
+          <a:noFill/>
+          <a:ln/>
+        </p:spPr>
+        <p:txBody>
+          <a:bodyPr wrap="none" lIns="0" tIns="0" rIns="0" bIns="0" rtlCol="0" anchor="t"/>
+          <a:lstStyle/>
+          <a:p>
+            <a:pPr algn="l">
+              <a:lnSpc>
+                <a:spcPct val="120000"/>
+              </a:lnSpc>
+            </a:pPr>
+            <a:r>
+              <a:rPr lang="en-US" sz="3200" dirty="0">
+                <a:solidFill>
+                  <a:srgbClr val="F5A623"/>
+                </a:solidFill>
+                <a:latin typeface="Liter" pitchFamily="34" charset="0"/>
+                <a:ea typeface="Liter" pitchFamily="34" charset="-122"/>
+                <a:cs typeface="Liter" pitchFamily="34" charset="-120"/>
+              </a:rPr>
+              <a:t>02</a:t>
+            </a:r>
+            <a:endParaRPr lang="en-US" sz="3200" dirty="0"/>
+          </a:p>
+        </p:txBody>
+      </p:sp>
+      <p:sp>
+        <p:nvSpPr>
+          <p:cNvPr id="11" name="Text 9"/>
+          <p:cNvSpPr/>
+          <p:nvPr/>
+        </p:nvSpPr>
+        <p:spPr>
+          <a:xfrm>
+            <a:off x="8636000" y="2349500"/>
+            <a:ext cx="6540500" cy="355600"/>
+          </a:xfrm>
+          <a:prstGeom prst="rect">
+            <a:avLst/>
+          </a:prstGeom>
+          <a:noFill/>
+          <a:ln/>
+        </p:spPr>
+        <p:txBody>
+          <a:bodyPr wrap="none" lIns="0" tIns="0" rIns="0" bIns="0" rtlCol="0" anchor="ctr"/>
+          <a:lstStyle/>
+          <a:p>
+            <a:pPr algn="l">
+              <a:lnSpc>
+                <a:spcPct val="120000"/>
+              </a:lnSpc>
+            </a:pPr>
+            <a:r>
+              <a:rPr lang="en-US" sz="2000" dirty="0">
+                <a:solidFill>
+                  <a:srgbClr val="F0F2F5"/>
+                </a:solidFill>
+                <a:latin typeface="Liter" pitchFamily="34" charset="0"/>
+                <a:ea typeface="Liter" pitchFamily="34" charset="-122"/>
+                <a:cs typeface="Liter" pitchFamily="34" charset="-120"/>
+              </a:rPr>
+              <a:t>Diana’s City Is Assumed</a:t>
+            </a:r>
+            <a:endParaRPr lang="en-US" sz="2000" dirty="0"/>
+          </a:p>
+        </p:txBody>
+      </p:sp>
+      <p:sp>
+        <p:nvSpPr>
+          <p:cNvPr id="12" name="Text 10"/>
+          <p:cNvSpPr/>
+          <p:nvPr/>
+        </p:nvSpPr>
+        <p:spPr>
+          <a:xfrm>
+            <a:off x="8636000" y="2794000"/>
+            <a:ext cx="6540500" cy="1714500"/>
+          </a:xfrm>
+          <a:prstGeom prst="rect">
+            <a:avLst/>
+          </a:prstGeom>
+          <a:noFill/>
+          <a:ln/>
+        </p:spPr>
+        <p:txBody>
+          <a:bodyPr wrap="square" lIns="0" tIns="0" rIns="0" bIns="0" rtlCol="0" anchor="t"/>
+          <a:lstStyle/>
+          <a:p>
+            <a:pPr algn="l">
+              <a:lnSpc>
+                <a:spcPct val="160000"/>
+              </a:lnSpc>
+            </a:pPr>
+            <a:r>
+              <a:rPr lang="en-US" sz="1600" dirty="0">
+                <a:solidFill>
+                  <a:srgbClr val="2DD4BF"/>
+                </a:solidFill>
+                <a:latin typeface="Quattrocento Sans" pitchFamily="34" charset="0"/>
+                <a:ea typeface="Quattrocento Sans" pitchFamily="34" charset="-122"/>
+                <a:cs typeface="Quattrocento Sans" pitchFamily="34" charset="-120"/>
+              </a:rPr>
+              <a:t>Kisumu</a:t>
+            </a:r>
+            <a:r>
+              <a:rPr lang="en-US" sz="1600" dirty="0">
+                <a:solidFill>
+                  <a:srgbClr val="8B95A5"/>
+                </a:solidFill>
+                <a:latin typeface="Quattrocento Sans" pitchFamily="34" charset="0"/>
+                <a:ea typeface="Quattrocento Sans" pitchFamily="34" charset="-122"/>
+                <a:cs typeface="Quattrocento Sans" pitchFamily="34" charset="-120"/>
+              </a:rPr>
+              <a:t> was assumed, not recovered. Location cannot be derived from age, salary or join date, and the </a:t>
+            </a:r>
+            <a:r>
+              <a:rPr lang="en-US" sz="1600" b="1" dirty="0">
+                <a:solidFill>
+                  <a:srgbClr val="F0F2F5"/>
+                </a:solidFill>
+                <a:latin typeface="Quattrocento Sans" pitchFamily="34" charset="0"/>
+                <a:ea typeface="Quattrocento Sans" pitchFamily="34" charset="-122"/>
+                <a:cs typeface="Quattrocento Sans" pitchFamily="34" charset="-120"/>
+              </a:rPr>
+              <a:t>mode is not unique</a:t>
+            </a:r>
+            <a:r>
+              <a:rPr lang="en-US" sz="1600" dirty="0">
+                <a:solidFill>
+                  <a:srgbClr val="8B95A5"/>
+                </a:solidFill>
+                <a:latin typeface="Quattrocento Sans" pitchFamily="34" charset="0"/>
+                <a:ea typeface="Quattrocento Sans" pitchFamily="34" charset="-122"/>
+                <a:cs typeface="Quattrocento Sans" pitchFamily="34" charset="-120"/>
+              </a:rPr>
+              <a:t> (3-way tie). </a:t>
+            </a:r>
+            <a:r>
+              <a:rPr lang="en-US" sz="1600" b="1" dirty="0">
+                <a:solidFill>
+                  <a:srgbClr val="F0F2F5"/>
+                </a:solidFill>
+                <a:latin typeface="Quattrocento Sans" pitchFamily="34" charset="0"/>
+                <a:ea typeface="Quattrocento Sans" pitchFamily="34" charset="-122"/>
+                <a:cs typeface="Quattrocento Sans" pitchFamily="34" charset="-120"/>
+              </a:rPr>
+              <a:t>KES 63,500</a:t>
+            </a:r>
+            <a:r>
+              <a:rPr lang="en-US" sz="1600" dirty="0">
+                <a:solidFill>
+                  <a:srgbClr val="8B95A5"/>
+                </a:solidFill>
+                <a:latin typeface="Quattrocento Sans" pitchFamily="34" charset="0"/>
+                <a:ea typeface="Quattrocento Sans" pitchFamily="34" charset="-122"/>
+                <a:cs typeface="Quattrocento Sans" pitchFamily="34" charset="-120"/>
+              </a:rPr>
+              <a:t> with it vs </a:t>
+            </a:r>
+            <a:r>
+              <a:rPr lang="en-US" sz="1600" b="1" dirty="0">
+                <a:solidFill>
+                  <a:srgbClr val="F0F2F5"/>
+                </a:solidFill>
+                <a:latin typeface="Quattrocento Sans" pitchFamily="34" charset="0"/>
+                <a:ea typeface="Quattrocento Sans" pitchFamily="34" charset="-122"/>
+                <a:cs typeface="Quattrocento Sans" pitchFamily="34" charset="-120"/>
+              </a:rPr>
+              <a:t>KES 60,250</a:t>
+            </a:r>
+            <a:r>
+              <a:rPr lang="en-US" sz="1600" dirty="0">
+                <a:solidFill>
+                  <a:srgbClr val="8B95A5"/>
+                </a:solidFill>
+                <a:latin typeface="Quattrocento Sans" pitchFamily="34" charset="0"/>
+                <a:ea typeface="Quattrocento Sans" pitchFamily="34" charset="-122"/>
+                <a:cs typeface="Quattrocento Sans" pitchFamily="34" charset="-120"/>
+              </a:rPr>
+              <a:t> without.</a:t>
+            </a:r>
+            <a:endParaRPr lang="en-US" sz="1600" dirty="0"/>
+          </a:p>
+        </p:txBody>
+      </p:sp>
+      <p:sp>
+        <p:nvSpPr>
+          <p:cNvPr id="13" name="Shape 11"/>
+          <p:cNvSpPr/>
+          <p:nvPr/>
+        </p:nvSpPr>
+        <p:spPr>
+          <a:xfrm>
+            <a:off x="762000" y="5207000"/>
+            <a:ext cx="7175500" cy="3238500"/>
+          </a:xfrm>
+          <a:prstGeom prst="rect">
+            <a:avLst/>
+          </a:prstGeom>
+          <a:solidFill>
+            <a:srgbClr val="1A2634"/>
+          </a:solidFill>
+          <a:ln/>
+        </p:spPr>
+        <p:txBody>
+          <a:bodyPr/>
+          <a:p/>
+        </p:txBody>
+      </p:sp>
+      <p:sp>
+        <p:nvSpPr>
+          <p:cNvPr id="14" name="Text 12"/>
+          <p:cNvSpPr/>
+          <p:nvPr/>
+        </p:nvSpPr>
+        <p:spPr>
+          <a:xfrm>
+            <a:off x="1079500" y="5397500"/>
+            <a:ext cx="1016000" cy="508000"/>
+          </a:xfrm>
+          <a:prstGeom prst="rect">
+            <a:avLst/>
+          </a:prstGeom>
+          <a:noFill/>
+          <a:ln/>
+        </p:spPr>
+        <p:txBody>
+          <a:bodyPr wrap="none" lIns="0" tIns="0" rIns="0" bIns="0" rtlCol="0" anchor="t"/>
+          <a:lstStyle/>
+          <a:p>
+            <a:pPr algn="l">
+              <a:lnSpc>
+                <a:spcPct val="120000"/>
+              </a:lnSpc>
+            </a:pPr>
+            <a:r>
+              <a:rPr lang="en-US" sz="3200" dirty="0">
+                <a:solidFill>
+                  <a:srgbClr val="F5A623"/>
+                </a:solidFill>
+                <a:latin typeface="Liter" pitchFamily="34" charset="0"/>
+                <a:ea typeface="Liter" pitchFamily="34" charset="-122"/>
+                <a:cs typeface="Liter" pitchFamily="34" charset="-120"/>
+              </a:rPr>
+              <a:t>03</a:t>
+            </a:r>
+            <a:endParaRPr lang="en-US" sz="3200" dirty="0"/>
+          </a:p>
+        </p:txBody>
+      </p:sp>
+      <p:sp>
+        <p:nvSpPr>
+          <p:cNvPr id="15" name="Text 13"/>
+          <p:cNvSpPr/>
+          <p:nvPr/>
+        </p:nvSpPr>
+        <p:spPr>
+          <a:xfrm>
+            <a:off x="1079500" y="5969000"/>
+            <a:ext cx="6540500" cy="355600"/>
+          </a:xfrm>
+          <a:prstGeom prst="rect">
+            <a:avLst/>
+          </a:prstGeom>
+          <a:noFill/>
+          <a:ln/>
+        </p:spPr>
+        <p:txBody>
+          <a:bodyPr wrap="none" lIns="0" tIns="0" rIns="0" bIns="0" rtlCol="0" anchor="ctr"/>
+          <a:lstStyle/>
+          <a:p>
+            <a:pPr algn="l">
+              <a:lnSpc>
+                <a:spcPct val="120000"/>
+              </a:lnSpc>
+            </a:pPr>
+            <a:r>
+              <a:rPr lang="en-US" sz="2000" dirty="0">
+                <a:solidFill>
+                  <a:srgbClr val="F0F2F5"/>
+                </a:solidFill>
+                <a:latin typeface="Liter" pitchFamily="34" charset="0"/>
+                <a:ea typeface="Liter" pitchFamily="34" charset="-122"/>
+                <a:cs typeface="Liter" pitchFamily="34" charset="-120"/>
+              </a:rPr>
+              <a:t>ID 9’s Name Is a Placeholder</a:t>
+            </a:r>
+            <a:endParaRPr lang="en-US" sz="2000" dirty="0"/>
+          </a:p>
+        </p:txBody>
+      </p:sp>
+      <p:sp>
+        <p:nvSpPr>
+          <p:cNvPr id="16" name="Text 14"/>
+          <p:cNvSpPr/>
+          <p:nvPr/>
+        </p:nvSpPr>
+        <p:spPr>
+          <a:xfrm>
+            <a:off x="1079500" y="6413500"/>
+            <a:ext cx="6540500" cy="1714500"/>
+          </a:xfrm>
+          <a:prstGeom prst="rect">
+            <a:avLst/>
+          </a:prstGeom>
+          <a:noFill/>
+          <a:ln/>
+        </p:spPr>
+        <p:txBody>
+          <a:bodyPr wrap="square" lIns="0" tIns="0" rIns="0" bIns="0" rtlCol="0" anchor="t"/>
+          <a:lstStyle/>
+          <a:p>
+            <a:pPr algn="l">
+              <a:lnSpc>
+                <a:spcPct val="160000"/>
+              </a:lnSpc>
+            </a:pPr>
+            <a:r>
+              <a:rPr lang="en-US" sz="1600" b="1" dirty="0">
+                <a:solidFill>
+                  <a:srgbClr val="F0F2F5"/>
+                </a:solidFill>
+                <a:latin typeface="Quattrocento Sans" pitchFamily="34" charset="0"/>
+                <a:ea typeface="Quattrocento Sans" pitchFamily="34" charset="-122"/>
+                <a:cs typeface="Quattrocento Sans" pitchFamily="34" charset="-120"/>
+              </a:rPr>
+              <a:t>‘Jamal’</a:t>
+            </a:r>
+            <a:r>
+              <a:rPr lang="en-US" sz="1600" dirty="0">
+                <a:solidFill>
+                  <a:srgbClr val="8B95A5"/>
+                </a:solidFill>
+                <a:latin typeface="Quattrocento Sans" pitchFamily="34" charset="0"/>
+                <a:ea typeface="Quattrocento Sans" pitchFamily="34" charset="-122"/>
+                <a:cs typeface="Quattrocento Sans" pitchFamily="34" charset="-120"/>
+              </a:rPr>
+              <a:t> is a placeholder, not a recovery. Names carry </a:t>
+            </a:r>
+            <a:r>
+              <a:rPr lang="en-US" sz="1600" b="1" dirty="0">
+                <a:solidFill>
+                  <a:srgbClr val="F5A623"/>
+                </a:solidFill>
+                <a:latin typeface="Quattrocento Sans" pitchFamily="34" charset="0"/>
+                <a:ea typeface="Quattrocento Sans" pitchFamily="34" charset="-122"/>
+                <a:cs typeface="Quattrocento Sans" pitchFamily="34" charset="-120"/>
+              </a:rPr>
+              <a:t>no analytical weight</a:t>
+            </a:r>
+            <a:r>
+              <a:rPr lang="en-US" sz="1600" dirty="0">
+                <a:solidFill>
+                  <a:srgbClr val="8B95A5"/>
+                </a:solidFill>
+                <a:latin typeface="Quattrocento Sans" pitchFamily="34" charset="0"/>
+                <a:ea typeface="Quattrocento Sans" pitchFamily="34" charset="-122"/>
+                <a:cs typeface="Quattrocento Sans" pitchFamily="34" charset="-120"/>
+              </a:rPr>
+              <a:t> — no calculation touches this field, so the </a:t>
+            </a:r>
+            <a:r>
+              <a:rPr lang="en-US" sz="1600" b="1" dirty="0">
+                <a:solidFill>
+                  <a:srgbClr val="F0F2F5"/>
+                </a:solidFill>
+                <a:latin typeface="Quattrocento Sans" pitchFamily="34" charset="0"/>
+                <a:ea typeface="Quattrocento Sans" pitchFamily="34" charset="-122"/>
+                <a:cs typeface="Quattrocento Sans" pitchFamily="34" charset="-120"/>
+              </a:rPr>
+              <a:t>impact is none</a:t>
+            </a:r>
+            <a:r>
+              <a:rPr lang="en-US" sz="1600" dirty="0">
+                <a:solidFill>
+                  <a:srgbClr val="8B95A5"/>
+                </a:solidFill>
+                <a:latin typeface="Quattrocento Sans" pitchFamily="34" charset="0"/>
+                <a:ea typeface="Quattrocento Sans" pitchFamily="34" charset="-122"/>
+                <a:cs typeface="Quattrocento Sans" pitchFamily="34" charset="-120"/>
+              </a:rPr>
+              <a:t>. Row IDs refer to the raw export; the cleaned file renumbers rows after the duplicate is dropped.</a:t>
+            </a:r>
+            <a:endParaRPr lang="en-US" sz="1600" dirty="0"/>
+          </a:p>
+        </p:txBody>
+      </p:sp>
+      <p:sp>
+        <p:nvSpPr>
+          <p:cNvPr id="17" name="Shape 15"/>
+          <p:cNvSpPr/>
+          <p:nvPr/>
+        </p:nvSpPr>
+        <p:spPr>
+          <a:xfrm>
+            <a:off x="8318500" y="5207000"/>
+            <a:ext cx="7175500" cy="3238500"/>
+          </a:xfrm>
+          <a:prstGeom prst="rect">
+            <a:avLst/>
+          </a:prstGeom>
+          <a:solidFill>
+            <a:srgbClr val="1A2634"/>
+          </a:solidFill>
+          <a:ln/>
+        </p:spPr>
+      </p:sp>
+      <p:sp>
+        <p:nvSpPr>
+          <p:cNvPr id="18" name="Text 16"/>
+          <p:cNvSpPr/>
+          <p:nvPr/>
+        </p:nvSpPr>
+        <p:spPr>
+          <a:xfrm>
+            <a:off x="8636000" y="5397500"/>
+            <a:ext cx="1016000" cy="508000"/>
+          </a:xfrm>
+          <a:prstGeom prst="rect">
+            <a:avLst/>
+          </a:prstGeom>
+          <a:noFill/>
+          <a:ln/>
+        </p:spPr>
+        <p:txBody>
+          <a:bodyPr wrap="none" lIns="0" tIns="0" rIns="0" bIns="0" rtlCol="0" anchor="t"/>
+          <a:lstStyle/>
+          <a:p>
+            <a:pPr algn="l">
+              <a:lnSpc>
+                <a:spcPct val="120000"/>
+              </a:lnSpc>
+            </a:pPr>
+            <a:r>
+              <a:rPr lang="en-US" sz="3200" dirty="0">
+                <a:solidFill>
+                  <a:srgbClr val="F5A623"/>
+                </a:solidFill>
+                <a:latin typeface="Liter" pitchFamily="34" charset="0"/>
+                <a:ea typeface="Liter" pitchFamily="34" charset="-122"/>
+                <a:cs typeface="Liter" pitchFamily="34" charset="-120"/>
+              </a:rPr>
+              <a:t>04</a:t>
+            </a:r>
+            <a:endParaRPr lang="en-US" sz="3200" dirty="0"/>
+          </a:p>
+        </p:txBody>
+      </p:sp>
+      <p:sp>
+        <p:nvSpPr>
+          <p:cNvPr id="19" name="Text 17"/>
+          <p:cNvSpPr/>
+          <p:nvPr/>
+        </p:nvSpPr>
+        <p:spPr>
+          <a:xfrm>
+            <a:off x="8636000" y="5969000"/>
+            <a:ext cx="6540500" cy="355600"/>
+          </a:xfrm>
+          <a:prstGeom prst="rect">
+            <a:avLst/>
+          </a:prstGeom>
+          <a:noFill/>
+          <a:ln/>
+        </p:spPr>
+        <p:txBody>
+          <a:bodyPr wrap="none" lIns="0" tIns="0" rIns="0" bIns="0" rtlCol="0" anchor="ctr"/>
+          <a:lstStyle/>
+          <a:p>
+            <a:pPr algn="l">
+              <a:lnSpc>
+                <a:spcPct val="120000"/>
+              </a:lnSpc>
+            </a:pPr>
+            <a:r>
+              <a:rPr lang="en-US" sz="2000" dirty="0">
+                <a:solidFill>
+                  <a:srgbClr val="F0F2F5"/>
+                </a:solidFill>
+                <a:latin typeface="Liter" pitchFamily="34" charset="0"/>
+                <a:ea typeface="Liter" pitchFamily="34" charset="-122"/>
+                <a:cs typeface="Liter" pitchFamily="34" charset="-120"/>
+              </a:rPr>
+              <a:t>Where Assumptions Matter</a:t>
+            </a:r>
+            <a:endParaRPr lang="en-US" sz="2000" dirty="0"/>
+          </a:p>
+        </p:txBody>
+      </p:sp>
+      <p:sp>
+        <p:nvSpPr>
+          <p:cNvPr id="20" name="Text 18"/>
+          <p:cNvSpPr/>
+          <p:nvPr/>
+        </p:nvSpPr>
+        <p:spPr>
+          <a:xfrm>
+            <a:off x="8636000" y="6413500"/>
+            <a:ext cx="6540500" cy="1714500"/>
+          </a:xfrm>
+          <a:prstGeom prst="rect">
+            <a:avLst/>
+          </a:prstGeom>
+          <a:noFill/>
+          <a:ln/>
+        </p:spPr>
+        <p:txBody>
+          <a:bodyPr wrap="square" lIns="0" tIns="0" rIns="0" bIns="0" rtlCol="0" anchor="t"/>
+          <a:lstStyle/>
+          <a:p>
+            <a:pPr algn="l">
+              <a:lnSpc>
+                <a:spcPct val="160000"/>
+              </a:lnSpc>
+            </a:pPr>
+            <a:r>
+              <a:rPr lang="en-US" sz="1600" dirty="0">
+                <a:solidFill>
+                  <a:srgbClr val="8B95A5"/>
+                </a:solidFill>
+                <a:latin typeface="Quattrocento Sans" pitchFamily="34" charset="0"/>
+                <a:ea typeface="Quattrocento Sans" pitchFamily="34" charset="-122"/>
+                <a:cs typeface="Quattrocento Sans" pitchFamily="34" charset="-120"/>
+              </a:rPr>
+              <a:t>A stakeholder deliverable would report both as </a:t>
+            </a:r>
+            <a:r>
+              <a:rPr lang="en-US" sz="1600" b="1" dirty="0">
+                <a:solidFill>
+                  <a:srgbClr val="F5A623"/>
+                </a:solidFill>
+                <a:latin typeface="Quattrocento Sans" pitchFamily="34" charset="0"/>
+                <a:ea typeface="Quattrocento Sans" pitchFamily="34" charset="-122"/>
+                <a:cs typeface="Quattrocento Sans" pitchFamily="34" charset="-120"/>
+              </a:rPr>
+              <a:t>Unknown</a:t>
+            </a:r>
+            <a:r>
+              <a:rPr lang="en-US" sz="1600" dirty="0">
+                <a:solidFill>
+                  <a:srgbClr val="8B95A5"/>
+                </a:solidFill>
+                <a:latin typeface="Quattrocento Sans" pitchFamily="34" charset="0"/>
+                <a:ea typeface="Quattrocento Sans" pitchFamily="34" charset="-122"/>
+                <a:cs typeface="Quattrocento Sans" pitchFamily="34" charset="-120"/>
+              </a:rPr>
+              <a:t> — </a:t>
+            </a:r>
+            <a:r>
+              <a:rPr lang="en-US" sz="1600" b="1" dirty="0">
+                <a:solidFill>
+                  <a:srgbClr val="F0F2F5"/>
+                </a:solidFill>
+                <a:latin typeface="Quattrocento Sans" pitchFamily="34" charset="0"/>
+                <a:ea typeface="Quattrocento Sans" pitchFamily="34" charset="-122"/>
+                <a:cs typeface="Quattrocento Sans" pitchFamily="34" charset="-120"/>
+              </a:rPr>
+              <a:t>8 of 9</a:t>
+            </a:r>
+            <a:r>
+              <a:rPr lang="en-US" sz="1600" dirty="0">
+                <a:solidFill>
+                  <a:srgbClr val="8B95A5"/>
+                </a:solidFill>
+                <a:latin typeface="Quattrocento Sans" pitchFamily="34" charset="0"/>
+                <a:ea typeface="Quattrocento Sans" pitchFamily="34" charset="-122"/>
+                <a:cs typeface="Quattrocento Sans" pitchFamily="34" charset="-120"/>
+              </a:rPr>
+              <a:t> employees in the city view. Total, mean, median, the 145% finding and the outlier check stay </a:t>
+            </a:r>
+            <a:r>
+              <a:rPr lang="en-US" sz="1600" b="1" dirty="0">
+                <a:solidFill>
+                  <a:srgbClr val="F0F2F5"/>
+                </a:solidFill>
+                <a:latin typeface="Quattrocento Sans" pitchFamily="34" charset="0"/>
+                <a:ea typeface="Quattrocento Sans" pitchFamily="34" charset="-122"/>
+                <a:cs typeface="Quattrocento Sans" pitchFamily="34" charset="-120"/>
+              </a:rPr>
+              <a:t>identical</a:t>
+            </a:r>
+            <a:r>
+              <a:rPr lang="en-US" sz="1600" dirty="0">
+                <a:solidFill>
+                  <a:srgbClr val="8B95A5"/>
+                </a:solidFill>
+                <a:latin typeface="Quattrocento Sans" pitchFamily="34" charset="0"/>
+                <a:ea typeface="Quattrocento Sans" pitchFamily="34" charset="-122"/>
+                <a:cs typeface="Quattrocento Sans" pitchFamily="34" charset="-120"/>
+              </a:rPr>
+              <a:t> either way.</a:t>
+            </a:r>
+            <a:endParaRPr lang="en-US" sz="1600" dirty="0"/>
+          </a:p>
+        </p:txBody>
+      </p:sp>
+    </p:spTree>
+  </p:cSld>
+  <p:clrMapOvr>
+    <a:masterClrMapping/>
+  </p:clrMapOvr>
+</p:sld>
+</file>
+
+<file path=ppt/slides/slide8.xml><?xml version="1.0" encoding="utf-8"?>
 <p:sld xmlns:a="http://schemas.openxmlformats.org/drawingml/2006/main" xmlns:r="http://schemas.openxmlformats.org/officeDocument/2006/relationships" xmlns:p="http://schemas.openxmlformats.org/presentationml/2006/main">
   <p:cSld name="Slide 7">
     <p:spTree>
@@ -15930,7 +16185,7 @@
 </p:sld>
 </file>
 
-<file path=ppt/slides/slide8.xml><?xml version="1.0" encoding="utf-8"?>
+<file path=ppt/slides/slide9.xml><?xml version="1.0" encoding="utf-8"?>
 <p:sld xmlns:a="http://schemas.openxmlformats.org/drawingml/2006/main" xmlns:r="http://schemas.openxmlformats.org/officeDocument/2006/relationships" xmlns:p="http://schemas.openxmlformats.org/presentationml/2006/main">
   <p:cSld name="Slide 8">
     <p:bg>
@@ -17410,245 +17665,6 @@
           </a:graphicData>
         </a:graphic>
       </p:graphicFrame>
-    </p:spTree>
-  </p:cSld>
-  <p:clrMapOvr>
-    <a:masterClrMapping/>
-  </p:clrMapOvr>
-  <p:transition>
-    <p:fade/>
-    <p:spd val="med"/>
-  </p:transition>
-</p:sld>
-</file>
-
-<file path=ppt/slides/slide9.xml><?xml version="1.0" encoding="utf-8"?>
-<p:sld xmlns:a="http://schemas.openxmlformats.org/drawingml/2006/main" xmlns:r="http://schemas.openxmlformats.org/officeDocument/2006/relationships" xmlns:p="http://schemas.openxmlformats.org/presentationml/2006/main">
-  <p:cSld name="Slide 9">
-    <p:spTree>
-      <p:nvGrpSpPr>
-        <p:cNvPr id="1" name=""/>
-        <p:cNvGrpSpPr/>
-        <p:nvPr/>
-      </p:nvGrpSpPr>
-      <p:grpSpPr>
-        <a:xfrm>
-          <a:off x="0" y="0"/>
-          <a:ext cx="0" cy="0"/>
-          <a:chOff x="0" y="0"/>
-          <a:chExt cx="0" cy="0"/>
-        </a:xfrm>
-      </p:grpSpPr>
-      <p:pic>
-        <p:nvPicPr>
-          <p:cNvPr id="2" name="Image 0" descr="https://kimi-img.moonshot.cn/pub/slides/okc/m77sgby2vvfiu/mnt/agents/output/employee-dashboard/images/4_57_808_Graphs_Charts_Dark_Royalty.png">    </p:cNvPr>
-          <p:cNvPicPr>
-            <a:picLocks noChangeAspect="1"/>
-          </p:cNvPicPr>
-          <p:nvPr/>
-        </p:nvPicPr>
-        <p:blipFill>
-          <a:blip r:embed="rId1"/>
-          <a:srcRect l="20719" r="20719" t="0" b="0"/>
-          <a:stretch/>
-        </p:blipFill>
-        <p:spPr>
-          <a:xfrm>
-            <a:off x="0" y="0"/>
-            <a:ext cx="16256000" cy="9144000"/>
-          </a:xfrm>
-          <a:prstGeom prst="rect">
-            <a:avLst/>
-          </a:prstGeom>
-        </p:spPr>
-      </p:pic>
-      <p:sp>
-        <p:nvSpPr>
-          <p:cNvPr id="3" name="Shape 0"/>
-          <p:cNvSpPr/>
-          <p:nvPr/>
-        </p:nvSpPr>
-        <p:spPr>
-          <a:xfrm>
-            <a:off x="0" y="0"/>
-            <a:ext cx="16256000" cy="9144000"/>
-          </a:xfrm>
-          <a:prstGeom prst="rect">
-            <a:avLst/>
-          </a:prstGeom>
-          <a:gradFill rotWithShape="1" flip="none">
-            <a:gsLst>
-              <a:gs pos="0">
-                <a:srgbClr val="0F1923">
-                  <a:alpha val="91000"/>
-                </a:srgbClr>
-              </a:gs>
-              <a:gs pos="60000">
-                <a:srgbClr val="0F1923">
-                  <a:alpha val="75000"/>
-                </a:srgbClr>
-              </a:gs>
-              <a:gs pos="100000">
-                <a:srgbClr val="0F1923">
-                  <a:alpha val="38000"/>
-                </a:srgbClr>
-              </a:gs>
-            </a:gsLst>
-            <a:lin ang="0" scaled="1"/>
-          </a:gradFill>
-          <a:ln w="12700">
-            <a:solidFill>
-              <a:srgbClr val="FFFFFF">
-                <a:alpha val="0"/>
-              </a:srgbClr>
-            </a:solidFill>
-            <a:prstDash val="solid"/>
-          </a:ln>
-        </p:spPr>
-      </p:sp>
-      <p:sp>
-        <p:nvSpPr>
-          <p:cNvPr id="4" name="Text 1"/>
-          <p:cNvSpPr/>
-          <p:nvPr/>
-        </p:nvSpPr>
-        <p:spPr>
-          <a:xfrm>
-            <a:off x="762000" y="2032000"/>
-            <a:ext cx="5080000" cy="2032000"/>
-          </a:xfrm>
-          <a:prstGeom prst="rect">
-            <a:avLst/>
-          </a:prstGeom>
-          <a:noFill/>
-          <a:ln/>
-        </p:spPr>
-        <p:txBody>
-          <a:bodyPr wrap="none" lIns="0" tIns="0" rIns="0" bIns="0" rtlCol="0" anchor="t"/>
-          <a:lstStyle/>
-          <a:p>
-            <a:pPr algn="l">
-              <a:lnSpc>
-                <a:spcPct val="120000"/>
-              </a:lnSpc>
-            </a:pPr>
-            <a:r>
-              <a:rPr lang="en-US" sz="12000" dirty="0">
-                <a:solidFill>
-                  <a:srgbClr val="F5A623"/>
-                </a:solidFill>
-                <a:latin typeface="Liter" pitchFamily="34" charset="0"/>
-                <a:ea typeface="Liter" pitchFamily="34" charset="-122"/>
-                <a:cs typeface="Liter" pitchFamily="34" charset="-120"/>
-              </a:rPr>
-              <a:t>04</a:t>
-            </a:r>
-            <a:endParaRPr lang="en-US" sz="12000" dirty="0"/>
-          </a:p>
-        </p:txBody>
-      </p:sp>
-      <p:sp>
-        <p:nvSpPr>
-          <p:cNvPr id="5" name="Text 2"/>
-          <p:cNvSpPr/>
-          <p:nvPr/>
-        </p:nvSpPr>
-        <p:spPr>
-          <a:xfrm>
-            <a:off x="762000" y="4191000"/>
-            <a:ext cx="7620000" cy="762000"/>
-          </a:xfrm>
-          <a:prstGeom prst="rect">
-            <a:avLst/>
-          </a:prstGeom>
-          <a:noFill/>
-          <a:ln/>
-        </p:spPr>
-        <p:txBody>
-          <a:bodyPr wrap="none" lIns="0" tIns="0" rIns="0" bIns="0" rtlCol="0" anchor="ctr"/>
-          <a:lstStyle/>
-          <a:p>
-            <a:pPr algn="l">
-              <a:lnSpc>
-                <a:spcPct val="120000"/>
-              </a:lnSpc>
-            </a:pPr>
-            <a:r>
-              <a:rPr lang="en-US" sz="4400" spc="300" kern="0" dirty="0">
-                <a:solidFill>
-                  <a:srgbClr val="F0F2F5"/>
-                </a:solidFill>
-                <a:latin typeface="Liter" pitchFamily="34" charset="0"/>
-                <a:ea typeface="Liter" pitchFamily="34" charset="-122"/>
-                <a:cs typeface="Liter" pitchFamily="34" charset="-120"/>
-              </a:rPr>
-              <a:t>SALARY ANALYSIS</a:t>
-            </a:r>
-            <a:endParaRPr lang="en-US" sz="4400" dirty="0"/>
-          </a:p>
-        </p:txBody>
-      </p:sp>
-      <p:sp>
-        <p:nvSpPr>
-          <p:cNvPr id="6" name="Shape 3"/>
-          <p:cNvSpPr/>
-          <p:nvPr/>
-        </p:nvSpPr>
-        <p:spPr>
-          <a:xfrm>
-            <a:off x="762000" y="5143500"/>
-            <a:ext cx="1016000" cy="38100"/>
-          </a:xfrm>
-          <a:prstGeom prst="rect">
-            <a:avLst/>
-          </a:prstGeom>
-          <a:solidFill>
-            <a:srgbClr val="F5A623"/>
-          </a:solidFill>
-          <a:ln/>
-        </p:spPr>
-      </p:sp>
-      <p:sp>
-        <p:nvSpPr>
-          <p:cNvPr id="7" name="Text 4"/>
-          <p:cNvSpPr/>
-          <p:nvPr/>
-        </p:nvSpPr>
-        <p:spPr>
-          <a:xfrm>
-            <a:off x="762000" y="5397500"/>
-            <a:ext cx="8890000" cy="444500"/>
-          </a:xfrm>
-          <a:prstGeom prst="rect">
-            <a:avLst/>
-          </a:prstGeom>
-          <a:noFill/>
-          <a:ln/>
-        </p:spPr>
-        <p:txBody>
-          <a:bodyPr wrap="none" lIns="0" tIns="0" rIns="0" bIns="0" rtlCol="0" anchor="ctr"/>
-          <a:lstStyle/>
-          <a:p>
-            <a:pPr algn="l">
-              <a:lnSpc>
-                <a:spcPct val="120000"/>
-              </a:lnSpc>
-            </a:pPr>
-            <a:r>
-              <a:rPr lang="en-US" sz="2000" dirty="0">
-                <a:solidFill>
-                  <a:srgbClr val="8B95A5"/>
-                </a:solidFill>
-                <a:latin typeface="Quattrocento Sans" pitchFamily="34" charset="0"/>
-                <a:ea typeface="Quattrocento Sans" pitchFamily="34" charset="-122"/>
-                <a:cs typeface="Quattrocento Sans" pitchFamily="34" charset="-120"/>
-              </a:rPr>
-              <a:t>Deep dive into compensation patterns across cities and individuals</a:t>
-            </a:r>
-            <a:endParaRPr lang="en-US" sz="2000" dirty="0"/>
-          </a:p>
-        </p:txBody>
-      </p:sp>
     </p:spTree>
   </p:cSld>
   <p:clrMapOvr>

</xml_diff>

<commit_message>
Move the README and the slide deck to the ten-employee snapshot
The README now publishes 11 raw rows in / 10 clean rows out, 8 defects,
a total of 631,000, a mean of 63,100 and a median of 61,000. The two
ten-fold digit slips are described as a rule rather than a one-off patch,
along with the rule's honest limit: it cannot tell a genuine high salary
from a typo, which is why it is a repair and not a cap.

The deck gains the tenth employee throughout - a new row in both the
data-quality table and the salary ranking, refreshed chart data for city
totals, city averages, headcount and hiring by month, and the 117% cleaning
finding.

The Diana assumption is no longer described as a non-unique mode, because
after de-duplication it is not one. It is disclosed as a placeholder, and
the headcount figure is now published with its qualifier.
</commit_message>
<xml_diff>
--- a/reports/Employee Salary & Headcount Dashboard.pptx
+++ b/reports/Employee Salary & Headcount Dashboard.pptx
@@ -98,29 +98,27 @@
             <c:showLeaderLines val="0"/>
           </c:dLbls>
           <c:cat>
-            <c:multiLvlStrRef>
+            <c:strRef>
               <c:f>Sheet1!$A$2:$A$6</c:f>
-              <c:multiLvlStrCache>
+              <c:strCache>
                 <c:ptCount val="5"/>
-                <c:lvl>
-                  <c:pt idx="0">
-                    <c:v>Nairobi</c:v>
-                  </c:pt>
-                  <c:pt idx="1">
-                    <c:v>Mombasa</c:v>
-                  </c:pt>
-                  <c:pt idx="2">
-                    <c:v>Kisumu</c:v>
-                  </c:pt>
-                  <c:pt idx="3">
-                    <c:v>Nakuru</c:v>
-                  </c:pt>
-                  <c:pt idx="4">
-                    <c:v>Eldoret</c:v>
-                  </c:pt>
-                </c:lvl>
-              </c:multiLvlStrCache>
-            </c:multiLvlStrRef>
+                <c:pt idx="0">
+                  <c:v>Nairobi</c:v>
+                </c:pt>
+                <c:pt idx="1">
+                  <c:v>Mombasa</c:v>
+                </c:pt>
+                <c:pt idx="2">
+                  <c:v>Kisumu</c:v>
+                </c:pt>
+                <c:pt idx="3">
+                  <c:v>Nakuru</c:v>
+                </c:pt>
+                <c:pt idx="4">
+                  <c:v>Eldoret</c:v>
+                </c:pt>
+              </c:strCache>
+            </c:strRef>
           </c:cat>
           <c:val>
             <c:numRef>
@@ -135,7 +133,7 @@
                   <c:v>120000</c:v>
                 </c:pt>
                 <c:pt idx="2">
-                  <c:v>190500</c:v>
+                  <c:v>267000</c:v>
                 </c:pt>
                 <c:pt idx="3">
                   <c:v>48000</c:v>
@@ -348,29 +346,27 @@
             <c:showLeaderLines val="0"/>
           </c:dLbls>
           <c:cat>
-            <c:multiLvlStrRef>
+            <c:strRef>
               <c:f>Sheet1!$A$2:$A$6</c:f>
-              <c:multiLvlStrCache>
+              <c:strCache>
                 <c:ptCount val="5"/>
-                <c:lvl>
-                  <c:pt idx="0">
-                    <c:v>Nairobi</c:v>
-                  </c:pt>
-                  <c:pt idx="1">
-                    <c:v>Kisumu</c:v>
-                  </c:pt>
-                  <c:pt idx="2">
-                    <c:v>Mombasa</c:v>
-                  </c:pt>
-                  <c:pt idx="3">
-                    <c:v>Eldoret</c:v>
-                  </c:pt>
-                  <c:pt idx="4">
-                    <c:v>Nakuru</c:v>
-                  </c:pt>
-                </c:lvl>
-              </c:multiLvlStrCache>
-            </c:multiLvlStrRef>
+                <c:pt idx="0">
+                  <c:v>Nairobi</c:v>
+                </c:pt>
+                <c:pt idx="1">
+                  <c:v>Kisumu</c:v>
+                </c:pt>
+                <c:pt idx="2">
+                  <c:v>Mombasa</c:v>
+                </c:pt>
+                <c:pt idx="3">
+                  <c:v>Eldoret</c:v>
+                </c:pt>
+                <c:pt idx="4">
+                  <c:v>Nakuru</c:v>
+                </c:pt>
+              </c:strCache>
+            </c:strRef>
           </c:cat>
           <c:val>
             <c:numRef>
@@ -382,7 +378,7 @@
                   <c:v>72500</c:v>
                 </c:pt>
                 <c:pt idx="1">
-                  <c:v>63500</c:v>
+                  <c:v>66750</c:v>
                 </c:pt>
                 <c:pt idx="2">
                   <c:v>60000</c:v>
@@ -801,9 +797,10 @@
             <c:numRef>
               <c:f>Sheet1!$B$2:$B$6</c:f>
               <c:numCache>
+                <c:formatCode>General</c:formatCode>
                 <c:ptCount val="5"/>
                 <c:pt idx="0">
-                  <c:v>3</c:v>
+                  <c:v>4</c:v>
                 </c:pt>
                 <c:pt idx="1">
                   <c:v>2</c:v>
@@ -924,29 +921,27 @@
             <c:showLeaderLines val="0"/>
           </c:dLbls>
           <c:cat>
-            <c:multiLvlStrRef>
+            <c:strRef>
               <c:f>Sheet1!$A$2:$A$6</c:f>
-              <c:multiLvlStrCache>
+              <c:strCache>
                 <c:ptCount val="5"/>
-                <c:lvl>
-                  <c:pt idx="0">
-                    <c:v>Jan</c:v>
-                  </c:pt>
-                  <c:pt idx="1">
-                    <c:v>Feb</c:v>
-                  </c:pt>
-                  <c:pt idx="2">
-                    <c:v>Mar</c:v>
-                  </c:pt>
-                  <c:pt idx="3">
-                    <c:v>Apr</c:v>
-                  </c:pt>
-                  <c:pt idx="4">
-                    <c:v>May</c:v>
-                  </c:pt>
-                </c:lvl>
-              </c:multiLvlStrCache>
-            </c:multiLvlStrRef>
+                <c:pt idx="0">
+                  <c:v>Jan</c:v>
+                </c:pt>
+                <c:pt idx="1">
+                  <c:v>Feb</c:v>
+                </c:pt>
+                <c:pt idx="2">
+                  <c:v>Mar</c:v>
+                </c:pt>
+                <c:pt idx="3">
+                  <c:v>Apr</c:v>
+                </c:pt>
+                <c:pt idx="4">
+                  <c:v>May</c:v>
+                </c:pt>
+              </c:strCache>
+            </c:strRef>
           </c:cat>
           <c:val>
             <c:numRef>
@@ -967,7 +962,7 @@
                   <c:v>2</c:v>
                 </c:pt>
                 <c:pt idx="4">
-                  <c:v>2</c:v>
+                  <c:v>3</c:v>
                 </c:pt>
               </c:numCache>
             </c:numRef>
@@ -4592,8 +4587,8 @@
           </p:nvPr>
         </p:nvGraphicFramePr>
         <p:xfrm>
-          <a:off x="762000" y="1968500"/>
-          <a:ext cx="14732000" cy="6350000"/>
+          <a:off x="762000" y="1783080"/>
+          <a:ext cx="14732000" cy="6303873"/>
         </p:xfrm>
         <a:graphic>
           <a:graphicData uri="http://schemas.openxmlformats.org/drawingml/2006/table">
@@ -4606,7 +4601,7 @@
                 <a:gridCol w="3241040"/>
                 <a:gridCol w="3683000"/>
               </a:tblGrid>
-              <a:tr h="635000">
+              <a:tr h="634593">
                 <a:tc>
                   <a:txBody>
                     <a:bodyPr/>
@@ -4938,7 +4933,7 @@
                   </a:tcPr>
                 </a:tc>
               </a:tr>
-              <a:tr h="635000">
+              <a:tr h="566928">
                 <a:tc>
                   <a:txBody>
                     <a:bodyPr/>
@@ -5218,7 +5213,7 @@
                           <a:ea typeface="Quattrocento Sans" pitchFamily="34" charset="-122"/>
                           <a:cs typeface="Quattrocento Sans" pitchFamily="34" charset="-120"/>
                         </a:rPr>
-                        <a:t>+46.1%</a:t>
+                        <a:t>+42.6%</a:t>
                       </a:r>
                       <a:endParaRPr lang="en-US" sz="1600" dirty="0">
                         <a:latin typeface="Quattrocento Sans" charset="0"/>
@@ -5270,7 +5265,7 @@
                   </a:tcPr>
                 </a:tc>
               </a:tr>
-              <a:tr h="635000">
+              <a:tr h="566928">
                 <a:tc>
                   <a:txBody>
                     <a:bodyPr/>
@@ -5287,6 +5282,338 @@
                           <a:cs typeface="Quattrocento Sans" pitchFamily="34" charset="-120"/>
                         </a:rPr>
                         <a:t>2</a:t>
+                      </a:r>
+                      <a:endParaRPr lang="en-US" sz="1600" dirty="0">
+                        <a:latin typeface="Quattrocento Sans" charset="0"/>
+                        <a:ea typeface="Quattrocento Sans" charset="0"/>
+                        <a:cs typeface="Quattrocento Sans" charset="0"/>
+                      </a:endParaRPr>
+                    </a:p>
+                  </a:txBody>
+                  <a:tcPr marL="54864" marR="54864" marT="0" marB="0" anchor="ctr">
+                    <a:lnL w="12700" cap="flat" cmpd="sng" algn="ctr">
+                      <a:solidFill>
+                        <a:srgbClr val="2A3544"/>
+                      </a:solidFill>
+                      <a:prstDash val="solid"/>
+                      <a:round/>
+                      <a:headEnd type="none" w="med" len="med"/>
+                      <a:tailEnd type="none" w="med" len="med"/>
+                    </a:lnL>
+                    <a:lnR w="12700" cap="flat" cmpd="sng" algn="ctr">
+                      <a:solidFill>
+                        <a:srgbClr val="2A3544"/>
+                      </a:solidFill>
+                      <a:prstDash val="solid"/>
+                      <a:round/>
+                      <a:headEnd type="none" w="med" len="med"/>
+                      <a:tailEnd type="none" w="med" len="med"/>
+                    </a:lnR>
+                    <a:lnT w="12700" cap="flat" cmpd="sng" algn="ctr">
+                      <a:solidFill>
+                        <a:srgbClr val="2A3544"/>
+                      </a:solidFill>
+                      <a:prstDash val="solid"/>
+                      <a:round/>
+                      <a:headEnd type="none" w="med" len="med"/>
+                      <a:tailEnd type="none" w="med" len="med"/>
+                    </a:lnT>
+                    <a:lnB w="12700" cap="flat" cmpd="sng" algn="ctr">
+                      <a:solidFill>
+                        <a:srgbClr val="2A3544"/>
+                      </a:solidFill>
+                      <a:prstDash val="solid"/>
+                      <a:round/>
+                      <a:headEnd type="none" w="med" len="med"/>
+                      <a:tailEnd type="none" w="med" len="med"/>
+                    </a:lnB>
+                    <a:solidFill>
+                      <a:srgbClr val="0F1923"/>
+                    </a:solidFill>
+                  </a:tcPr>
+                </a:tc>
+                <a:tc>
+                  <a:txBody>
+                    <a:bodyPr/>
+                    <a:lstStyle/>
+                    <a:p>
+                      <a:pPr algn="ctr"/>
+                      <a:r>
+                        <a:rPr lang="en-US" sz="1600" dirty="0">
+                          <a:solidFill>
+                            <a:srgbClr val="F0F2F5"/>
+                          </a:solidFill>
+                          <a:latin typeface="Quattrocento Sans" pitchFamily="34" charset="0"/>
+                          <a:ea typeface="Quattrocento Sans" pitchFamily="34" charset="-122"/>
+                          <a:cs typeface="Quattrocento Sans" pitchFamily="34" charset="-120"/>
+                        </a:rPr>
+                        <a:t>Kirauti</a:t>
+                      </a:r>
+                      <a:endParaRPr lang="en-US" sz="1600" dirty="0">
+                        <a:latin typeface="Quattrocento Sans" charset="0"/>
+                        <a:ea typeface="Quattrocento Sans" charset="0"/>
+                        <a:cs typeface="Quattrocento Sans" charset="0"/>
+                      </a:endParaRPr>
+                    </a:p>
+                  </a:txBody>
+                  <a:tcPr marL="54864" marR="54864" marT="0" marB="0" anchor="ctr">
+                    <a:lnL w="12700" cap="flat" cmpd="sng" algn="ctr">
+                      <a:solidFill>
+                        <a:srgbClr val="2A3544"/>
+                      </a:solidFill>
+                      <a:prstDash val="solid"/>
+                      <a:round/>
+                      <a:headEnd type="none" w="med" len="med"/>
+                      <a:tailEnd type="none" w="med" len="med"/>
+                    </a:lnL>
+                    <a:lnR w="12700" cap="flat" cmpd="sng" algn="ctr">
+                      <a:solidFill>
+                        <a:srgbClr val="2A3544"/>
+                      </a:solidFill>
+                      <a:prstDash val="solid"/>
+                      <a:round/>
+                      <a:headEnd type="none" w="med" len="med"/>
+                      <a:tailEnd type="none" w="med" len="med"/>
+                    </a:lnR>
+                    <a:lnT w="12700" cap="flat" cmpd="sng" algn="ctr">
+                      <a:solidFill>
+                        <a:srgbClr val="2A3544"/>
+                      </a:solidFill>
+                      <a:prstDash val="solid"/>
+                      <a:round/>
+                      <a:headEnd type="none" w="med" len="med"/>
+                      <a:tailEnd type="none" w="med" len="med"/>
+                    </a:lnT>
+                    <a:lnB w="12700" cap="flat" cmpd="sng" algn="ctr">
+                      <a:solidFill>
+                        <a:srgbClr val="2A3544"/>
+                      </a:solidFill>
+                      <a:prstDash val="solid"/>
+                      <a:round/>
+                      <a:headEnd type="none" w="med" len="med"/>
+                      <a:tailEnd type="none" w="med" len="med"/>
+                    </a:lnB>
+                    <a:solidFill>
+                      <a:srgbClr val="0F1923"/>
+                    </a:solidFill>
+                  </a:tcPr>
+                </a:tc>
+                <a:tc>
+                  <a:txBody>
+                    <a:bodyPr/>
+                    <a:lstStyle/>
+                    <a:p>
+                      <a:pPr algn="ctr"/>
+                      <a:r>
+                        <a:rPr lang="en-US" sz="1600" dirty="0">
+                          <a:solidFill>
+                            <a:srgbClr val="F0F2F5"/>
+                          </a:solidFill>
+                          <a:latin typeface="Quattrocento Sans" pitchFamily="34" charset="0"/>
+                          <a:ea typeface="Quattrocento Sans" pitchFamily="34" charset="-122"/>
+                          <a:cs typeface="Quattrocento Sans" pitchFamily="34" charset="-120"/>
+                        </a:rPr>
+                        <a:t>Kisumu</a:t>
+                      </a:r>
+                      <a:endParaRPr lang="en-US" sz="1600" dirty="0">
+                        <a:latin typeface="Quattrocento Sans" charset="0"/>
+                        <a:ea typeface="Quattrocento Sans" charset="0"/>
+                        <a:cs typeface="Quattrocento Sans" charset="0"/>
+                      </a:endParaRPr>
+                    </a:p>
+                  </a:txBody>
+                  <a:tcPr marL="54864" marR="54864" marT="0" marB="0" anchor="ctr">
+                    <a:lnL w="12700" cap="flat" cmpd="sng" algn="ctr">
+                      <a:solidFill>
+                        <a:srgbClr val="2A3544"/>
+                      </a:solidFill>
+                      <a:prstDash val="solid"/>
+                      <a:round/>
+                      <a:headEnd type="none" w="med" len="med"/>
+                      <a:tailEnd type="none" w="med" len="med"/>
+                    </a:lnL>
+                    <a:lnR w="12700" cap="flat" cmpd="sng" algn="ctr">
+                      <a:solidFill>
+                        <a:srgbClr val="2A3544"/>
+                      </a:solidFill>
+                      <a:prstDash val="solid"/>
+                      <a:round/>
+                      <a:headEnd type="none" w="med" len="med"/>
+                      <a:tailEnd type="none" w="med" len="med"/>
+                    </a:lnR>
+                    <a:lnT w="12700" cap="flat" cmpd="sng" algn="ctr">
+                      <a:solidFill>
+                        <a:srgbClr val="2A3544"/>
+                      </a:solidFill>
+                      <a:prstDash val="solid"/>
+                      <a:round/>
+                      <a:headEnd type="none" w="med" len="med"/>
+                      <a:tailEnd type="none" w="med" len="med"/>
+                    </a:lnT>
+                    <a:lnB w="12700" cap="flat" cmpd="sng" algn="ctr">
+                      <a:solidFill>
+                        <a:srgbClr val="2A3544"/>
+                      </a:solidFill>
+                      <a:prstDash val="solid"/>
+                      <a:round/>
+                      <a:headEnd type="none" w="med" len="med"/>
+                      <a:tailEnd type="none" w="med" len="med"/>
+                    </a:lnB>
+                    <a:solidFill>
+                      <a:srgbClr val="0F1923"/>
+                    </a:solidFill>
+                  </a:tcPr>
+                </a:tc>
+                <a:tc>
+                  <a:txBody>
+                    <a:bodyPr/>
+                    <a:lstStyle/>
+                    <a:p>
+                      <a:pPr algn="ctr"/>
+                      <a:r>
+                        <a:rPr lang="en-US" sz="1600" b="1" dirty="0">
+                          <a:solidFill>
+                            <a:srgbClr val="F0F2F5"/>
+                          </a:solidFill>
+                          <a:latin typeface="Quattrocento Sans" pitchFamily="34" charset="0"/>
+                          <a:ea typeface="Quattrocento Sans" pitchFamily="34" charset="-122"/>
+                          <a:cs typeface="Quattrocento Sans" pitchFamily="34" charset="-120"/>
+                        </a:rPr>
+                        <a:t>75,000</a:t>
+                      </a:r>
+                      <a:endParaRPr lang="en-US" sz="1600" dirty="0">
+                        <a:latin typeface="Quattrocento Sans" charset="0"/>
+                        <a:ea typeface="Quattrocento Sans" charset="0"/>
+                        <a:cs typeface="Quattrocento Sans" charset="0"/>
+                      </a:endParaRPr>
+                    </a:p>
+                  </a:txBody>
+                  <a:tcPr marL="54864" marR="54864" marT="0" marB="0" anchor="ctr">
+                    <a:lnL w="12700" cap="flat" cmpd="sng" algn="ctr">
+                      <a:solidFill>
+                        <a:srgbClr val="2A3544"/>
+                      </a:solidFill>
+                      <a:prstDash val="solid"/>
+                      <a:round/>
+                      <a:headEnd type="none" w="med" len="med"/>
+                      <a:tailEnd type="none" w="med" len="med"/>
+                    </a:lnL>
+                    <a:lnR w="12700" cap="flat" cmpd="sng" algn="ctr">
+                      <a:solidFill>
+                        <a:srgbClr val="2A3544"/>
+                      </a:solidFill>
+                      <a:prstDash val="solid"/>
+                      <a:round/>
+                      <a:headEnd type="none" w="med" len="med"/>
+                      <a:tailEnd type="none" w="med" len="med"/>
+                    </a:lnR>
+                    <a:lnT w="12700" cap="flat" cmpd="sng" algn="ctr">
+                      <a:solidFill>
+                        <a:srgbClr val="2A3544"/>
+                      </a:solidFill>
+                      <a:prstDash val="solid"/>
+                      <a:round/>
+                      <a:headEnd type="none" w="med" len="med"/>
+                      <a:tailEnd type="none" w="med" len="med"/>
+                    </a:lnT>
+                    <a:lnB w="12700" cap="flat" cmpd="sng" algn="ctr">
+                      <a:solidFill>
+                        <a:srgbClr val="2A3544"/>
+                      </a:solidFill>
+                      <a:prstDash val="solid"/>
+                      <a:round/>
+                      <a:headEnd type="none" w="med" len="med"/>
+                      <a:tailEnd type="none" w="med" len="med"/>
+                    </a:lnB>
+                    <a:solidFill>
+                      <a:srgbClr val="0F1923"/>
+                    </a:solidFill>
+                  </a:tcPr>
+                </a:tc>
+                <a:tc>
+                  <a:txBody>
+                    <a:bodyPr/>
+                    <a:lstStyle/>
+                    <a:p>
+                      <a:pPr algn="ctr"/>
+                      <a:r>
+                        <a:rPr lang="en-US" sz="1600" dirty="0">
+                          <a:solidFill>
+                            <a:srgbClr val="2DD4BF"/>
+                          </a:solidFill>
+                          <a:latin typeface="Quattrocento Sans" pitchFamily="34" charset="0"/>
+                          <a:ea typeface="Quattrocento Sans" pitchFamily="34" charset="-122"/>
+                          <a:cs typeface="Quattrocento Sans" pitchFamily="34" charset="-120"/>
+                        </a:rPr>
+                        <a:t>+18.9%</a:t>
+                      </a:r>
+                      <a:endParaRPr lang="en-US" sz="1600" dirty="0">
+                        <a:latin typeface="Quattrocento Sans" charset="0"/>
+                        <a:ea typeface="Quattrocento Sans" charset="0"/>
+                        <a:cs typeface="Quattrocento Sans" charset="0"/>
+                      </a:endParaRPr>
+                    </a:p>
+                  </a:txBody>
+                  <a:tcPr marL="54864" marR="54864" marT="0" marB="0" anchor="ctr">
+                    <a:lnL w="12700" cap="flat" cmpd="sng" algn="ctr">
+                      <a:solidFill>
+                        <a:srgbClr val="2A3544"/>
+                      </a:solidFill>
+                      <a:prstDash val="solid"/>
+                      <a:round/>
+                      <a:headEnd type="none" w="med" len="med"/>
+                      <a:tailEnd type="none" w="med" len="med"/>
+                    </a:lnL>
+                    <a:lnR w="12700" cap="flat" cmpd="sng" algn="ctr">
+                      <a:solidFill>
+                        <a:srgbClr val="2A3544"/>
+                      </a:solidFill>
+                      <a:prstDash val="solid"/>
+                      <a:round/>
+                      <a:headEnd type="none" w="med" len="med"/>
+                      <a:tailEnd type="none" w="med" len="med"/>
+                    </a:lnR>
+                    <a:lnT w="12700" cap="flat" cmpd="sng" algn="ctr">
+                      <a:solidFill>
+                        <a:srgbClr val="2A3544"/>
+                      </a:solidFill>
+                      <a:prstDash val="solid"/>
+                      <a:round/>
+                      <a:headEnd type="none" w="med" len="med"/>
+                      <a:tailEnd type="none" w="med" len="med"/>
+                    </a:lnT>
+                    <a:lnB w="12700" cap="flat" cmpd="sng" algn="ctr">
+                      <a:solidFill>
+                        <a:srgbClr val="2A3544"/>
+                      </a:solidFill>
+                      <a:prstDash val="solid"/>
+                      <a:round/>
+                      <a:headEnd type="none" w="med" len="med"/>
+                      <a:tailEnd type="none" w="med" len="med"/>
+                    </a:lnB>
+                    <a:solidFill>
+                      <a:srgbClr val="0F1923"/>
+                    </a:solidFill>
+                  </a:tcPr>
+                </a:tc>
+              </a:tr>
+              <a:tr h="566928">
+                <a:tc>
+                  <a:txBody>
+                    <a:bodyPr/>
+                    <a:lstStyle/>
+                    <a:p>
+                      <a:pPr algn="ctr"/>
+                      <a:r>
+                        <a:rPr lang="en-US" sz="1600" dirty="0">
+                          <a:solidFill>
+                            <a:srgbClr val="F5A623"/>
+                          </a:solidFill>
+                          <a:latin typeface="Quattrocento Sans" pitchFamily="34" charset="0"/>
+                          <a:ea typeface="Quattrocento Sans" pitchFamily="34" charset="-122"/>
+                          <a:cs typeface="Quattrocento Sans" pitchFamily="34" charset="-120"/>
+                        </a:rPr>
+                        <a:t>3</a:t>
                       </a:r>
                       <a:endParaRPr lang="en-US" sz="1600" dirty="0">
                         <a:latin typeface="Quattrocento Sans" charset="0"/>
@@ -5550,7 +5877,7 @@
                           <a:ea typeface="Quattrocento Sans" pitchFamily="34" charset="-122"/>
                           <a:cs typeface="Quattrocento Sans" pitchFamily="34" charset="-120"/>
                         </a:rPr>
-                        <a:t>+13.6%</a:t>
+                        <a:t>+10.9%</a:t>
                       </a:r>
                       <a:endParaRPr lang="en-US" sz="1600" dirty="0">
                         <a:latin typeface="Quattrocento Sans" charset="0"/>
@@ -5602,7 +5929,7 @@
                   </a:tcPr>
                 </a:tc>
               </a:tr>
-              <a:tr h="635000">
+              <a:tr h="566928">
                 <a:tc>
                   <a:txBody>
                     <a:bodyPr/>
@@ -5618,7 +5945,7 @@
                           <a:ea typeface="Quattrocento Sans" pitchFamily="34" charset="-122"/>
                           <a:cs typeface="Quattrocento Sans" pitchFamily="34" charset="-120"/>
                         </a:rPr>
-                        <a:t>3</a:t>
+                        <a:t>4</a:t>
                       </a:r>
                       <a:endParaRPr lang="en-US" sz="1600" dirty="0">
                         <a:latin typeface="Quattrocento Sans" charset="0"/>
@@ -5882,7 +6209,7 @@
                           <a:ea typeface="Quattrocento Sans" pitchFamily="34" charset="-122"/>
                           <a:cs typeface="Quattrocento Sans" pitchFamily="34" charset="-120"/>
                         </a:rPr>
-                        <a:t>+0.6%</a:t>
+                        <a:t>-1.7%</a:t>
                       </a:r>
                       <a:endParaRPr lang="en-US" sz="1600" dirty="0">
                         <a:latin typeface="Quattrocento Sans" charset="0"/>
@@ -5934,7 +6261,7 @@
                   </a:tcPr>
                 </a:tc>
               </a:tr>
-              <a:tr h="635000">
+              <a:tr h="566928">
                 <a:tc>
                   <a:txBody>
                     <a:bodyPr/>
@@ -5950,7 +6277,7 @@
                           <a:ea typeface="Quattrocento Sans" pitchFamily="34" charset="-122"/>
                           <a:cs typeface="Quattrocento Sans" pitchFamily="34" charset="-120"/>
                         </a:rPr>
-                        <a:t>4</a:t>
+                        <a:t>5</a:t>
                       </a:r>
                       <a:endParaRPr lang="en-US" sz="1600" dirty="0">
                         <a:latin typeface="Quattrocento Sans" charset="0"/>
@@ -6016,7 +6343,7 @@
                           <a:ea typeface="Quattrocento Sans" pitchFamily="34" charset="-122"/>
                           <a:cs typeface="Quattrocento Sans" pitchFamily="34" charset="-120"/>
                         </a:rPr>
-                        <a:t>Jamal</a:t>
+                        <a:t>Charlie</a:t>
                       </a:r>
                       <a:endParaRPr lang="en-US" sz="1600" dirty="0">
                         <a:latin typeface="Quattrocento Sans" charset="0"/>
@@ -6214,7 +6541,7 @@
                           <a:ea typeface="Quattrocento Sans" pitchFamily="34" charset="-122"/>
                           <a:cs typeface="Quattrocento Sans" pitchFamily="34" charset="-120"/>
                         </a:rPr>
-                        <a:t>-1.0%</a:t>
+                        <a:t>-3.3%</a:t>
                       </a:r>
                       <a:endParaRPr lang="en-US" sz="1600" dirty="0">
                         <a:latin typeface="Quattrocento Sans" charset="0"/>
@@ -6266,7 +6593,7 @@
                   </a:tcPr>
                 </a:tc>
               </a:tr>
-              <a:tr h="635000">
+              <a:tr h="566928">
                 <a:tc>
                   <a:txBody>
                     <a:bodyPr/>
@@ -6282,7 +6609,7 @@
                           <a:ea typeface="Quattrocento Sans" pitchFamily="34" charset="-122"/>
                           <a:cs typeface="Quattrocento Sans" pitchFamily="34" charset="-120"/>
                         </a:rPr>
-                        <a:t>5</a:t>
+                        <a:t>6</a:t>
                       </a:r>
                       <a:endParaRPr lang="en-US" sz="1600" dirty="0">
                         <a:latin typeface="Quattrocento Sans" charset="0"/>
@@ -6348,7 +6675,7 @@
                           <a:ea typeface="Quattrocento Sans" pitchFamily="34" charset="-122"/>
                           <a:cs typeface="Quattrocento Sans" pitchFamily="34" charset="-120"/>
                         </a:rPr>
-                        <a:t>Charlie</a:t>
+                        <a:t>Jamal</a:t>
                       </a:r>
                       <a:endParaRPr lang="en-US" sz="1600" dirty="0">
                         <a:latin typeface="Quattrocento Sans" charset="0"/>
@@ -6480,7 +6807,7 @@
                           <a:ea typeface="Quattrocento Sans" pitchFamily="34" charset="-122"/>
                           <a:cs typeface="Quattrocento Sans" pitchFamily="34" charset="-120"/>
                         </a:rPr>
-                        <a:t>59,500</a:t>
+                        <a:t>61,000</a:t>
                       </a:r>
                       <a:endParaRPr lang="en-US" sz="1600" dirty="0">
                         <a:latin typeface="Quattrocento Sans" charset="0"/>
@@ -6546,7 +6873,7 @@
                           <a:ea typeface="Quattrocento Sans" pitchFamily="34" charset="-122"/>
                           <a:cs typeface="Quattrocento Sans" pitchFamily="34" charset="-120"/>
                         </a:rPr>
-                        <a:t>-3.4%</a:t>
+                        <a:t>-3.3%</a:t>
                       </a:r>
                       <a:endParaRPr lang="en-US" sz="1600" dirty="0">
                         <a:latin typeface="Quattrocento Sans" charset="0"/>
@@ -6598,7 +6925,7 @@
                   </a:tcPr>
                 </a:tc>
               </a:tr>
-              <a:tr h="635000">
+              <a:tr h="566928">
                 <a:tc>
                   <a:txBody>
                     <a:bodyPr/>
@@ -6614,7 +6941,7 @@
                           <a:ea typeface="Quattrocento Sans" pitchFamily="34" charset="-122"/>
                           <a:cs typeface="Quattrocento Sans" pitchFamily="34" charset="-120"/>
                         </a:rPr>
-                        <a:t>6</a:t>
+                        <a:t>7</a:t>
                       </a:r>
                       <a:endParaRPr lang="en-US" sz="1600" dirty="0">
                         <a:latin typeface="Quattrocento Sans" charset="0"/>
@@ -6878,7 +7205,7 @@
                           <a:ea typeface="Quattrocento Sans" pitchFamily="34" charset="-122"/>
                           <a:cs typeface="Quattrocento Sans" pitchFamily="34" charset="-120"/>
                         </a:rPr>
-                        <a:t>-5.9%</a:t>
+                        <a:t>-8.1%</a:t>
                       </a:r>
                       <a:endParaRPr lang="en-US" sz="1600" dirty="0">
                         <a:latin typeface="Quattrocento Sans" charset="0"/>
@@ -6930,7 +7257,7 @@
                   </a:tcPr>
                 </a:tc>
               </a:tr>
-              <a:tr h="635000">
+              <a:tr h="566928">
                 <a:tc>
                   <a:txBody>
                     <a:bodyPr/>
@@ -6946,7 +7273,7 @@
                           <a:ea typeface="Quattrocento Sans" pitchFamily="34" charset="-122"/>
                           <a:cs typeface="Quattrocento Sans" pitchFamily="34" charset="-120"/>
                         </a:rPr>
-                        <a:t>7</a:t>
+                        <a:t>8</a:t>
                       </a:r>
                       <a:endParaRPr lang="en-US" sz="1600" dirty="0">
                         <a:latin typeface="Quattrocento Sans" charset="0"/>
@@ -7210,7 +7537,7 @@
                           <a:ea typeface="Quattrocento Sans" pitchFamily="34" charset="-122"/>
                           <a:cs typeface="Quattrocento Sans" pitchFamily="34" charset="-120"/>
                         </a:rPr>
-                        <a:t>-10.7%</a:t>
+                        <a:t>-12.8%</a:t>
                       </a:r>
                       <a:endParaRPr lang="en-US" sz="1600" dirty="0">
                         <a:latin typeface="Quattrocento Sans" charset="0"/>
@@ -7262,7 +7589,7 @@
                   </a:tcPr>
                 </a:tc>
               </a:tr>
-              <a:tr h="635000">
+              <a:tr h="566928">
                 <a:tc>
                   <a:txBody>
                     <a:bodyPr/>
@@ -7278,7 +7605,7 @@
                           <a:ea typeface="Quattrocento Sans" pitchFamily="34" charset="-122"/>
                           <a:cs typeface="Quattrocento Sans" pitchFamily="34" charset="-120"/>
                         </a:rPr>
-                        <a:t>8</a:t>
+                        <a:t>9</a:t>
                       </a:r>
                       <a:endParaRPr lang="en-US" sz="1600" dirty="0">
                         <a:latin typeface="Quattrocento Sans" charset="0"/>
@@ -7542,7 +7869,7 @@
                           <a:ea typeface="Quattrocento Sans" pitchFamily="34" charset="-122"/>
                           <a:cs typeface="Quattrocento Sans" pitchFamily="34" charset="-120"/>
                         </a:rPr>
-                        <a:t>-17.2%</a:t>
+                        <a:t>-19.2%</a:t>
                       </a:r>
                       <a:endParaRPr lang="en-US" sz="1600" dirty="0">
                         <a:latin typeface="Quattrocento Sans" charset="0"/>
@@ -7594,7 +7921,7 @@
                   </a:tcPr>
                 </a:tc>
               </a:tr>
-              <a:tr h="635000">
+              <a:tr h="566928">
                 <a:tc>
                   <a:txBody>
                     <a:bodyPr/>
@@ -7610,7 +7937,7 @@
                           <a:ea typeface="Quattrocento Sans" pitchFamily="34" charset="-122"/>
                           <a:cs typeface="Quattrocento Sans" pitchFamily="34" charset="-120"/>
                         </a:rPr>
-                        <a:t>9</a:t>
+                        <a:t>10</a:t>
                       </a:r>
                       <a:endParaRPr lang="en-US" sz="1600" dirty="0">
                         <a:latin typeface="Quattrocento Sans" charset="0"/>
@@ -7874,7 +8201,7 @@
                           <a:ea typeface="Quattrocento Sans" pitchFamily="34" charset="-122"/>
                           <a:cs typeface="Quattrocento Sans" pitchFamily="34" charset="-120"/>
                         </a:rPr>
-                        <a:t>-22.1%</a:t>
+                        <a:t>-23.9%</a:t>
                       </a:r>
                       <a:endParaRPr lang="en-US" sz="1600" dirty="0">
                         <a:latin typeface="Quattrocento Sans" charset="0"/>
@@ -8634,7 +8961,7 @@
                 <a:ea typeface="Quattrocento Sans" pitchFamily="34" charset="-122"/>
                 <a:cs typeface="Quattrocento Sans" pitchFamily="34" charset="-120"/>
               </a:rPr>
-              <a:t>two new hires every month except January</a:t>
+              <a:t>one hire in January, then two a month, and three in May</a:t>
             </a:r>
             <a:pPr algn="l">
               <a:lnSpc>
@@ -8650,7 +8977,7 @@
                 <a:ea typeface="Quattrocento Sans" pitchFamily="34" charset="-122"/>
                 <a:cs typeface="Quattrocento Sans" pitchFamily="34" charset="-120"/>
               </a:rPr>
-              <a:t>. Kisumu has the largest team (3 employees), followed by Nairobi and Mombasa (2 each).</a:t>
+              <a:t>. Kisumu has the largest team (4 employees, one city assumed), followed by Nairobi and Mombasa (2 each).</a:t>
             </a:r>
             <a:endParaRPr lang="en-US" sz="1600" dirty="0"/>
           </a:p>
@@ -8979,7 +9306,7 @@
                 <a:ea typeface="Quattrocento Sans" pitchFamily="34" charset="-122"/>
                 <a:cs typeface="Quattrocento Sans" pitchFamily="34" charset="-120"/>
               </a:rPr>
-              <a:t>, driven by one senior hire. </a:t>
+              <a:t>, driven by one senior hire — without that one person it falls to KES 55,000, below the company mean. </a:t>
             </a:r>
             <a:pPr algn="l">
               <a:lnSpc>
@@ -9250,7 +9577,7 @@
                 <a:ea typeface="Quattrocento Sans" pitchFamily="34" charset="-122"/>
                 <a:cs typeface="Quattrocento Sans" pitchFamily="34" charset="-120"/>
               </a:rPr>
-              <a:t>3 employees</a:t>
+              <a:t>4 employees</a:t>
             </a:r>
             <a:pPr algn="l">
               <a:lnSpc>
@@ -9266,7 +9593,7 @@
                 <a:ea typeface="Quattrocento Sans" pitchFamily="34" charset="-122"/>
                 <a:cs typeface="Quattrocento Sans" pitchFamily="34" charset="-120"/>
               </a:rPr>
-              <a:t>. Nairobi and Mombasa each have </a:t>
+              <a:t> (one of them an assumed city). Nairobi and Mombasa each have </a:t>
             </a:r>
             <a:pPr algn="l">
               <a:lnSpc>
@@ -9489,7 +9816,7 @@
                 <a:ea typeface="Quattrocento Sans" pitchFamily="34" charset="-122"/>
                 <a:cs typeface="Quattrocento Sans" pitchFamily="34" charset="-120"/>
               </a:rPr>
-              <a:t>two new hires every month except January</a:t>
+              <a:t>one hire in January, then two a month, and three in May</a:t>
             </a:r>
             <a:pPr algn="l">
               <a:lnSpc>
@@ -9664,7 +9991,7 @@
                 <a:ea typeface="Quattrocento Sans" pitchFamily="34" charset="-122"/>
                 <a:cs typeface="Quattrocento Sans" pitchFamily="34" charset="-120"/>
               </a:rPr>
-              <a:t>KES 554,500</a:t>
+              <a:t>KES 631,000</a:t>
             </a:r>
             <a:pPr algn="l">
               <a:lnSpc>
@@ -9696,7 +10023,7 @@
                 <a:ea typeface="Quattrocento Sans" pitchFamily="34" charset="-122"/>
                 <a:cs typeface="Quattrocento Sans" pitchFamily="34" charset="-120"/>
               </a:rPr>
-              <a:t>KES 61,611</a:t>
+              <a:t>KES 63,100</a:t>
             </a:r>
             <a:pPr algn="l">
               <a:lnSpc>
@@ -9712,7 +10039,7 @@
                 <a:ea typeface="Quattrocento Sans" pitchFamily="34" charset="-122"/>
                 <a:cs typeface="Quattrocento Sans" pitchFamily="34" charset="-120"/>
               </a:rPr>
-              <a:t> per employee. Payroll ramped from KES 55,000 in January to KES 554,500 by May as headcount grew from 1 to 9.</a:t>
+              <a:t> per employee. Payroll ramped from KES 55,000 in January to KES 631,000 by May as headcount grew from 1 to 10.</a:t>
             </a:r>
             <a:endParaRPr lang="en-US" sz="1600" dirty="0"/>
           </a:p>
@@ -11605,7 +11932,7 @@
                 <a:ea typeface="Quattrocento Sans" pitchFamily="34" charset="-122"/>
                 <a:cs typeface="Quattrocento Sans" pitchFamily="34" charset="-120"/>
               </a:rPr>
-              <a:t>Remove duplicates, handle nulls, fix invalid ages, cap salary outliers</a:t>
+              <a:t>Remove duplicates, handle nulls, fix invalid ages, repair salary digit slips</a:t>
             </a:r>
             <a:endParaRPr lang="en-US" sz="1500" dirty="0"/>
           </a:p>
@@ -12693,7 +13020,7 @@
                 <a:ea typeface="Quattrocento Sans" pitchFamily="34" charset="-122"/>
                 <a:cs typeface="Quattrocento Sans" pitchFamily="34" charset="-120"/>
               </a:rPr>
-              <a:t>9 employees</a:t>
+              <a:t>10 employees</a:t>
             </a:r>
             <a:pPr algn="ctr">
               <a:lnSpc>
@@ -13098,7 +13425,7 @@
                 <a:ea typeface="Liter" pitchFamily="34" charset="-122"/>
                 <a:cs typeface="Liter" pitchFamily="34" charset="-120"/>
               </a:rPr>
-              <a:t>7 Data Defects + 1 Format Issue</a:t>
+              <a:t>8 Data Defects + 1 Format Issue</a:t>
             </a:r>
             <a:endParaRPr lang="en-US" sz="3000" dirty="0"/>
           </a:p>
@@ -13139,8 +13466,8 @@
           </p:nvPr>
         </p:nvGraphicFramePr>
         <p:xfrm>
-          <a:off x="762000" y="1524000"/>
-          <a:ext cx="14732000" cy="6858000"/>
+          <a:off x="762000" y="1417320"/>
+          <a:ext cx="14732000" cy="6995159"/>
         </p:xfrm>
         <a:graphic>
           <a:graphicData uri="http://schemas.openxmlformats.org/drawingml/2006/table">
@@ -13151,7 +13478,7 @@
                 <a:gridCol w="5156200"/>
                 <a:gridCol w="5156200"/>
               </a:tblGrid>
-              <a:tr h="685800">
+              <a:tr h="658368">
                 <a:tc>
                   <a:txBody>
                     <a:bodyPr/>
@@ -13351,7 +13678,7 @@
                   </a:tcPr>
                 </a:tc>
               </a:tr>
-              <a:tr h="771525">
+              <a:tr h="704088">
                 <a:tc>
                   <a:txBody>
                     <a:bodyPr/>
@@ -13551,7 +13878,7 @@
                   </a:tcPr>
                 </a:tc>
               </a:tr>
-              <a:tr h="771525">
+              <a:tr h="704088">
                 <a:tc>
                   <a:txBody>
                     <a:bodyPr/>
@@ -13751,7 +14078,7 @@
                   </a:tcPr>
                 </a:tc>
               </a:tr>
-              <a:tr h="771525">
+              <a:tr h="704088">
                 <a:tc>
                   <a:txBody>
                     <a:bodyPr/>
@@ -13899,7 +14226,7 @@
                           <a:ea typeface="Quattrocento Sans" pitchFamily="34" charset="-122"/>
                           <a:cs typeface="Quattrocento Sans" pitchFamily="34" charset="-120"/>
                         </a:rPr>
-                        <a:t>Filled with median age</a:t>
+                        <a:t>Filled with median age (30)</a:t>
                       </a:r>
                       <a:endParaRPr lang="en-US" sz="1600" dirty="0">
                         <a:latin typeface="Quattrocento Sans" charset="0"/>
@@ -13951,7 +14278,7 @@
                   </a:tcPr>
                 </a:tc>
               </a:tr>
-              <a:tr h="771525">
+              <a:tr h="704088">
                 <a:tc>
                   <a:txBody>
                     <a:bodyPr/>
@@ -14099,7 +14426,7 @@
                           <a:ea typeface="Quattrocento Sans" pitchFamily="34" charset="-122"/>
                           <a:cs typeface="Quattrocento Sans" pitchFamily="34" charset="-120"/>
                         </a:rPr>
-                        <a:t>Reset to missing, re-filled with median</a:t>
+                        <a:t>Reset to missing, re-filled with median (30)</a:t>
                       </a:r>
                       <a:endParaRPr lang="en-US" sz="1600" dirty="0">
                         <a:latin typeface="Quattrocento Sans" charset="0"/>
@@ -14151,7 +14478,7 @@
                   </a:tcPr>
                 </a:tc>
               </a:tr>
-              <a:tr h="771525">
+              <a:tr h="704088">
                 <a:tc>
                   <a:txBody>
                     <a:bodyPr/>
@@ -14299,7 +14626,7 @@
                           <a:ea typeface="Quattrocento Sans" pitchFamily="34" charset="-122"/>
                           <a:cs typeface="Quattrocento Sans" pitchFamily="34" charset="-120"/>
                         </a:rPr>
-                        <a:t>Filled with median salary</a:t>
+                        <a:t>Filled with median salary (61,000)</a:t>
                       </a:r>
                       <a:endParaRPr lang="en-US" sz="1600" dirty="0">
                         <a:latin typeface="Quattrocento Sans" charset="0"/>
@@ -14351,7 +14678,7 @@
                   </a:tcPr>
                 </a:tc>
               </a:tr>
-              <a:tr h="771525">
+              <a:tr h="704088">
                 <a:tc>
                   <a:txBody>
                     <a:bodyPr/>
@@ -14499,7 +14826,7 @@
                           <a:ea typeface="Quattrocento Sans" pitchFamily="34" charset="-122"/>
                           <a:cs typeface="Quattrocento Sans" pitchFamily="34" charset="-120"/>
                         </a:rPr>
-                        <a:t>Assumed Kisumu — mode not unique (3-way tie)</a:t>
+                        <a:t>Assumed Kisumu – a disclosed placeholder, not a recovery</a:t>
                       </a:r>
                       <a:endParaRPr lang="en-US" sz="1600" dirty="0">
                         <a:latin typeface="Quattrocento Sans" charset="0"/>
@@ -14551,7 +14878,7 @@
                   </a:tcPr>
                 </a:tc>
               </a:tr>
-              <a:tr h="771525">
+              <a:tr h="704088">
                 <a:tc>
                   <a:txBody>
                     <a:bodyPr/>
@@ -14567,7 +14894,7 @@
                           <a:ea typeface="Quattrocento Sans" pitchFamily="34" charset="-122"/>
                           <a:cs typeface="Quattrocento Sans" pitchFamily="34" charset="-120"/>
                         </a:rPr>
-                        <a:t>Salary outlier</a:t>
+                        <a:t>Salary digit slip (one digit too many)</a:t>
                       </a:r>
                       <a:endParaRPr lang="en-US" sz="1600" dirty="0">
                         <a:latin typeface="Quattrocento Sans" charset="0"/>
@@ -14633,7 +14960,7 @@
                           <a:ea typeface="Quattrocento Sans" pitchFamily="34" charset="-122"/>
                           <a:cs typeface="Quattrocento Sans" pitchFamily="34" charset="-120"/>
                         </a:rPr>
-                        <a:t>George — salary KES 900,000</a:t>
+                        <a:t>George – salary KES 900,000</a:t>
                       </a:r>
                       <a:endParaRPr lang="en-US" sz="1600" dirty="0">
                         <a:latin typeface="Quattrocento Sans" charset="0"/>
@@ -14699,7 +15026,7 @@
                           <a:ea typeface="Quattrocento Sans" pitchFamily="34" charset="-122"/>
                           <a:cs typeface="Quattrocento Sans" pitchFamily="34" charset="-120"/>
                         </a:rPr>
-                        <a:t>Reviewed against IQR, corrected to KES 90,000</a:t>
+                        <a:t>Repaired to KES 90,000 by undoing one power of ten</a:t>
                       </a:r>
                       <a:endParaRPr lang="en-US" sz="1600" dirty="0">
                         <a:latin typeface="Quattrocento Sans" charset="0"/>
@@ -14751,7 +15078,207 @@
                   </a:tcPr>
                 </a:tc>
               </a:tr>
-              <a:tr h="771525">
+              <a:tr h="704088">
+                <a:tc>
+                  <a:txBody>
+                    <a:bodyPr/>
+                    <a:lstStyle/>
+                    <a:p>
+                      <a:pPr algn="ctr"/>
+                      <a:r>
+                        <a:rPr lang="en-US" sz="1600" dirty="0">
+                          <a:solidFill>
+                            <a:srgbClr val="F0F2F5"/>
+                          </a:solidFill>
+                          <a:latin typeface="Quattrocento Sans" pitchFamily="34" charset="0"/>
+                          <a:ea typeface="Quattrocento Sans" pitchFamily="34" charset="-122"/>
+                          <a:cs typeface="Quattrocento Sans" pitchFamily="34" charset="-120"/>
+                        </a:rPr>
+                        <a:t>Salary digit slip (one digit too few)</a:t>
+                      </a:r>
+                      <a:endParaRPr lang="en-US" sz="1600" dirty="0">
+                        <a:latin typeface="Quattrocento Sans" charset="0"/>
+                        <a:ea typeface="Quattrocento Sans" charset="0"/>
+                        <a:cs typeface="Quattrocento Sans" charset="0"/>
+                      </a:endParaRPr>
+                    </a:p>
+                  </a:txBody>
+                  <a:tcPr marL="54864" marR="54864" marT="0" marB="0" anchor="ctr">
+                    <a:lnL w="12700" cap="flat" cmpd="sng" algn="ctr">
+                      <a:solidFill>
+                        <a:srgbClr val="2A3544"/>
+                      </a:solidFill>
+                      <a:prstDash val="solid"/>
+                      <a:round/>
+                      <a:headEnd type="none" w="med" len="med"/>
+                      <a:tailEnd type="none" w="med" len="med"/>
+                    </a:lnL>
+                    <a:lnR w="12700" cap="flat" cmpd="sng" algn="ctr">
+                      <a:solidFill>
+                        <a:srgbClr val="2A3544"/>
+                      </a:solidFill>
+                      <a:prstDash val="solid"/>
+                      <a:round/>
+                      <a:headEnd type="none" w="med" len="med"/>
+                      <a:tailEnd type="none" w="med" len="med"/>
+                    </a:lnR>
+                    <a:lnT w="12700" cap="flat" cmpd="sng" algn="ctr">
+                      <a:solidFill>
+                        <a:srgbClr val="2A3544"/>
+                      </a:solidFill>
+                      <a:prstDash val="solid"/>
+                      <a:round/>
+                      <a:headEnd type="none" w="med" len="med"/>
+                      <a:tailEnd type="none" w="med" len="med"/>
+                    </a:lnT>
+                    <a:lnB w="12700" cap="flat" cmpd="sng" algn="ctr">
+                      <a:solidFill>
+                        <a:srgbClr val="2A3544"/>
+                      </a:solidFill>
+                      <a:prstDash val="solid"/>
+                      <a:round/>
+                      <a:headEnd type="none" w="med" len="med"/>
+                      <a:tailEnd type="none" w="med" len="med"/>
+                    </a:lnB>
+                    <a:solidFill>
+                      <a:srgbClr val="0F1923"/>
+                    </a:solidFill>
+                  </a:tcPr>
+                </a:tc>
+                <a:tc>
+                  <a:txBody>
+                    <a:bodyPr/>
+                    <a:lstStyle/>
+                    <a:p>
+                      <a:pPr algn="ctr"/>
+                      <a:r>
+                        <a:rPr lang="en-US" sz="1600" dirty="0">
+                          <a:solidFill>
+                            <a:srgbClr val="F0F2F5"/>
+                          </a:solidFill>
+                          <a:latin typeface="Quattrocento Sans" pitchFamily="34" charset="0"/>
+                          <a:ea typeface="Quattrocento Sans" pitchFamily="34" charset="-122"/>
+                          <a:cs typeface="Quattrocento Sans" pitchFamily="34" charset="-120"/>
+                        </a:rPr>
+                        <a:t>Kirauti – salary KES 7,500</a:t>
+                      </a:r>
+                      <a:endParaRPr lang="en-US" sz="1600" dirty="0">
+                        <a:latin typeface="Quattrocento Sans" charset="0"/>
+                        <a:ea typeface="Quattrocento Sans" charset="0"/>
+                        <a:cs typeface="Quattrocento Sans" charset="0"/>
+                      </a:endParaRPr>
+                    </a:p>
+                  </a:txBody>
+                  <a:tcPr marL="54864" marR="54864" marT="0" marB="0" anchor="ctr">
+                    <a:lnL w="12700" cap="flat" cmpd="sng" algn="ctr">
+                      <a:solidFill>
+                        <a:srgbClr val="2A3544"/>
+                      </a:solidFill>
+                      <a:prstDash val="solid"/>
+                      <a:round/>
+                      <a:headEnd type="none" w="med" len="med"/>
+                      <a:tailEnd type="none" w="med" len="med"/>
+                    </a:lnL>
+                    <a:lnR w="12700" cap="flat" cmpd="sng" algn="ctr">
+                      <a:solidFill>
+                        <a:srgbClr val="2A3544"/>
+                      </a:solidFill>
+                      <a:prstDash val="solid"/>
+                      <a:round/>
+                      <a:headEnd type="none" w="med" len="med"/>
+                      <a:tailEnd type="none" w="med" len="med"/>
+                    </a:lnR>
+                    <a:lnT w="12700" cap="flat" cmpd="sng" algn="ctr">
+                      <a:solidFill>
+                        <a:srgbClr val="2A3544"/>
+                      </a:solidFill>
+                      <a:prstDash val="solid"/>
+                      <a:round/>
+                      <a:headEnd type="none" w="med" len="med"/>
+                      <a:tailEnd type="none" w="med" len="med"/>
+                    </a:lnT>
+                    <a:lnB w="12700" cap="flat" cmpd="sng" algn="ctr">
+                      <a:solidFill>
+                        <a:srgbClr val="2A3544"/>
+                      </a:solidFill>
+                      <a:prstDash val="solid"/>
+                      <a:round/>
+                      <a:headEnd type="none" w="med" len="med"/>
+                      <a:tailEnd type="none" w="med" len="med"/>
+                    </a:lnB>
+                    <a:solidFill>
+                      <a:srgbClr val="0F1923"/>
+                    </a:solidFill>
+                  </a:tcPr>
+                </a:tc>
+                <a:tc>
+                  <a:txBody>
+                    <a:bodyPr/>
+                    <a:lstStyle/>
+                    <a:p>
+                      <a:pPr algn="ctr"/>
+                      <a:r>
+                        <a:rPr lang="en-US" sz="1600" dirty="0">
+                          <a:solidFill>
+                            <a:srgbClr val="F0F2F5"/>
+                          </a:solidFill>
+                          <a:latin typeface="Quattrocento Sans" pitchFamily="34" charset="0"/>
+                          <a:ea typeface="Quattrocento Sans" pitchFamily="34" charset="-122"/>
+                          <a:cs typeface="Quattrocento Sans" pitchFamily="34" charset="-120"/>
+                        </a:rPr>
+                        <a:t>Repaired to KES 75,000 by undoing one power of ten</a:t>
+                      </a:r>
+                      <a:endParaRPr lang="en-US" sz="1600" dirty="0">
+                        <a:latin typeface="Quattrocento Sans" charset="0"/>
+                        <a:ea typeface="Quattrocento Sans" charset="0"/>
+                        <a:cs typeface="Quattrocento Sans" charset="0"/>
+                      </a:endParaRPr>
+                    </a:p>
+                  </a:txBody>
+                  <a:tcPr marL="54864" marR="54864" marT="0" marB="0" anchor="ctr">
+                    <a:lnL w="12700" cap="flat" cmpd="sng" algn="ctr">
+                      <a:solidFill>
+                        <a:srgbClr val="2A3544"/>
+                      </a:solidFill>
+                      <a:prstDash val="solid"/>
+                      <a:round/>
+                      <a:headEnd type="none" w="med" len="med"/>
+                      <a:tailEnd type="none" w="med" len="med"/>
+                    </a:lnL>
+                    <a:lnR w="12700" cap="flat" cmpd="sng" algn="ctr">
+                      <a:solidFill>
+                        <a:srgbClr val="2A3544"/>
+                      </a:solidFill>
+                      <a:prstDash val="solid"/>
+                      <a:round/>
+                      <a:headEnd type="none" w="med" len="med"/>
+                      <a:tailEnd type="none" w="med" len="med"/>
+                    </a:lnR>
+                    <a:lnT w="12700" cap="flat" cmpd="sng" algn="ctr">
+                      <a:solidFill>
+                        <a:srgbClr val="2A3544"/>
+                      </a:solidFill>
+                      <a:prstDash val="solid"/>
+                      <a:round/>
+                      <a:headEnd type="none" w="med" len="med"/>
+                      <a:tailEnd type="none" w="med" len="med"/>
+                    </a:lnT>
+                    <a:lnB w="12700" cap="flat" cmpd="sng" algn="ctr">
+                      <a:solidFill>
+                        <a:srgbClr val="2A3544"/>
+                      </a:solidFill>
+                      <a:prstDash val="solid"/>
+                      <a:round/>
+                      <a:headEnd type="none" w="med" len="med"/>
+                      <a:tailEnd type="none" w="med" len="med"/>
+                    </a:lnB>
+                    <a:solidFill>
+                      <a:srgbClr val="0F1923"/>
+                    </a:solidFill>
+                  </a:tcPr>
+                </a:tc>
+              </a:tr>
+              <a:tr h="704088">
                 <a:tc>
                   <a:txBody>
                     <a:bodyPr/>
@@ -15190,7 +15717,7 @@
                 <a:ea typeface="Liter" pitchFamily="34" charset="-122"/>
                 <a:cs typeface="Liter" pitchFamily="34" charset="-120"/>
               </a:rPr>
-              <a:t>The 145% Finding</a:t>
+              <a:t>The 117% Finding</a:t>
             </a:r>
             <a:endParaRPr lang="en-US" sz="2000" dirty="0"/>
           </a:p>
@@ -15242,7 +15769,7 @@
                 <a:ea typeface="Quattrocento Sans" pitchFamily="34" charset="-122"/>
                 <a:cs typeface="Quattrocento Sans" pitchFamily="34" charset="-120"/>
               </a:rPr>
-              <a:t>KES 151,111</a:t>
+              <a:t>KES 136,750</a:t>
             </a:r>
             <a:r>
               <a:rPr lang="en-US" sz="1600" dirty="0">
@@ -15264,7 +15791,7 @@
                 <a:ea typeface="Quattrocento Sans" pitchFamily="34" charset="-122"/>
                 <a:cs typeface="Quattrocento Sans" pitchFamily="34" charset="-120"/>
               </a:rPr>
-              <a:t>KES 61,611</a:t>
+              <a:t>KES 63,100</a:t>
             </a:r>
             <a:r>
               <a:rPr lang="en-US" sz="1600" dirty="0">
@@ -15286,7 +15813,7 @@
                 <a:ea typeface="Quattrocento Sans" pitchFamily="34" charset="-122"/>
                 <a:cs typeface="Quattrocento Sans" pitchFamily="34" charset="-120"/>
               </a:rPr>
-              <a:t>inflation of 145%</a:t>
+              <a:t>inflation of 117%</a:t>
             </a:r>
             <a:r>
               <a:rPr lang="en-US" sz="1600" dirty="0">
@@ -15297,7 +15824,7 @@
                 <a:ea typeface="Quattrocento Sans" pitchFamily="34" charset="-122"/>
                 <a:cs typeface="Quattrocento Sans" pitchFamily="34" charset="-120"/>
               </a:rPr>
-              <a:t>, caused by one 900,000 typo and a duplicated row.</a:t>
+              <a:t>, caused by two ten-fold digit slips and a duplicated row.</a:t>
             </a:r>
             <a:endParaRPr lang="en-US" sz="1600" dirty="0"/>
           </a:p>
@@ -15455,7 +15982,7 @@
                 <a:ea typeface="Quattrocento Sans" pitchFamily="34" charset="-122"/>
                 <a:cs typeface="Quattrocento Sans" pitchFamily="34" charset="-120"/>
               </a:rPr>
-              <a:t> was assumed, not recovered. Location cannot be derived from age, salary or join date, and the </a:t>
+              <a:t> was assumed, not recovered. Location cannot be derived from age, salary or join date, and </a:t>
             </a:r>
             <a:r>
               <a:rPr lang="en-US" sz="1600" b="1" dirty="0">
@@ -15466,7 +15993,7 @@
                 <a:ea typeface="Quattrocento Sans" pitchFamily="34" charset="-122"/>
                 <a:cs typeface="Quattrocento Sans" pitchFamily="34" charset="-120"/>
               </a:rPr>
-              <a:t>mode is not unique</a:t>
+              <a:t>the export holds no evidence for any particular city</a:t>
             </a:r>
             <a:r>
               <a:rPr lang="en-US" sz="1600" dirty="0">
@@ -15477,7 +16004,7 @@
                 <a:ea typeface="Quattrocento Sans" pitchFamily="34" charset="-122"/>
                 <a:cs typeface="Quattrocento Sans" pitchFamily="34" charset="-120"/>
               </a:rPr>
-              <a:t> (3-way tie). </a:t>
+              <a:t>, so the value is a disclosed placeholder. </a:t>
             </a:r>
             <a:r>
               <a:rPr lang="en-US" sz="1600" b="1" dirty="0">
@@ -15488,7 +16015,7 @@
                 <a:ea typeface="Quattrocento Sans" pitchFamily="34" charset="-122"/>
                 <a:cs typeface="Quattrocento Sans" pitchFamily="34" charset="-120"/>
               </a:rPr>
-              <a:t>KES 63,500</a:t>
+              <a:t>KES 66,750</a:t>
             </a:r>
             <a:r>
               <a:rPr lang="en-US" sz="1600" dirty="0">
@@ -15510,7 +16037,7 @@
                 <a:ea typeface="Quattrocento Sans" pitchFamily="34" charset="-122"/>
                 <a:cs typeface="Quattrocento Sans" pitchFamily="34" charset="-120"/>
               </a:rPr>
-              <a:t>KES 60,250</a:t>
+              <a:t>KES 65,667</a:t>
             </a:r>
             <a:r>
               <a:rPr lang="en-US" sz="1600" dirty="0">
@@ -15899,7 +16426,7 @@
                 <a:ea typeface="Quattrocento Sans" pitchFamily="34" charset="-122"/>
                 <a:cs typeface="Quattrocento Sans" pitchFamily="34" charset="-120"/>
               </a:rPr>
-              <a:t>8 of 9</a:t>
+              <a:t>9 of 10</a:t>
             </a:r>
             <a:r>
               <a:rPr lang="en-US" sz="1600" dirty="0">
@@ -15910,7 +16437,7 @@
                 <a:ea typeface="Quattrocento Sans" pitchFamily="34" charset="-122"/>
                 <a:cs typeface="Quattrocento Sans" pitchFamily="34" charset="-120"/>
               </a:rPr>
-              <a:t> employees in the city view. Total, mean, median, the 145% finding and the outlier check stay </a:t>
+              <a:t> employees in the city view. Total, mean, median, the 117% finding and the distribution analysis stay </a:t>
             </a:r>
             <a:r>
               <a:rPr lang="en-US" sz="1600" b="1" dirty="0">
@@ -16616,7 +17143,7 @@
                 <a:ea typeface="Liter" pitchFamily="34" charset="-122"/>
                 <a:cs typeface="Liter" pitchFamily="34" charset="-120"/>
               </a:rPr>
-              <a:t>9</a:t>
+              <a:t>10</a:t>
             </a:r>
             <a:endParaRPr lang="en-US" sz="5200" dirty="0"/>
           </a:p>
@@ -16948,7 +17475,7 @@
                 <a:ea typeface="Liter" pitchFamily="34" charset="-122"/>
                 <a:cs typeface="Liter" pitchFamily="34" charset="-120"/>
               </a:rPr>
-              <a:t>KES 554,500</a:t>
+              <a:t>KES 631,000</a:t>
             </a:r>
             <a:endParaRPr lang="en-US" sz="3600" dirty="0"/>
           </a:p>
@@ -17348,7 +17875,7 @@
                 <a:ea typeface="Liter" pitchFamily="34" charset="-122"/>
                 <a:cs typeface="Liter" pitchFamily="34" charset="-120"/>
               </a:rPr>
-              <a:t>KES 61,611</a:t>
+              <a:t>KES 63,100</a:t>
             </a:r>
             <a:endParaRPr lang="en-US" sz="3600" dirty="0"/>
           </a:p>
@@ -17602,7 +18129,7 @@
                 <a:ea typeface="Liter" pitchFamily="34" charset="-122"/>
                 <a:cs typeface="Liter" pitchFamily="34" charset="-120"/>
               </a:rPr>
-              <a:t>30.3</a:t>
+              <a:t>30.5</a:t>
             </a:r>
             <a:endParaRPr lang="en-US" sz="5200" dirty="0"/>
           </a:p>

</xml_diff>

<commit_message>
Run 2026-10-22 11:30 - 11 rows, total 679,500
</commit_message>
<xml_diff>
--- a/reports/Employee Salary & Headcount Dashboard.pptx
+++ b/reports/Employee Salary & Headcount Dashboard.pptx
@@ -127,13 +127,13 @@
                 <c:formatCode>General</c:formatCode>
                 <c:ptCount val="5"/>
                 <c:pt idx="0">
-                  <c:v>145000</c:v>
+                  <c:v>195000</c:v>
                 </c:pt>
                 <c:pt idx="1">
                   <c:v>120000</c:v>
                 </c:pt>
                 <c:pt idx="2">
-                  <c:v>267000</c:v>
+                  <c:v>265500</c:v>
                 </c:pt>
                 <c:pt idx="3">
                   <c:v>48000</c:v>
@@ -351,10 +351,10 @@
               <c:strCache>
                 <c:ptCount val="5"/>
                 <c:pt idx="0">
-                  <c:v>Nairobi</c:v>
+                  <c:v>Kisumu</c:v>
                 </c:pt>
                 <c:pt idx="1">
-                  <c:v>Kisumu</c:v>
+                  <c:v>Nairobi</c:v>
                 </c:pt>
                 <c:pt idx="2">
                   <c:v>Mombasa</c:v>
@@ -375,10 +375,10 @@
                 <c:formatCode>General</c:formatCode>
                 <c:ptCount val="5"/>
                 <c:pt idx="0">
-                  <c:v>72500</c:v>
+                  <c:v>66375</c:v>
                 </c:pt>
                 <c:pt idx="1">
-                  <c:v>66750</c:v>
+                  <c:v>65000</c:v>
                 </c:pt>
                 <c:pt idx="2">
                   <c:v>60000</c:v>
@@ -803,7 +803,7 @@
                   <c:v>4</c:v>
                 </c:pt>
                 <c:pt idx="1">
-                  <c:v>2</c:v>
+                  <c:v>3</c:v>
                 </c:pt>
                 <c:pt idx="2">
                   <c:v>2</c:v>
@@ -962,7 +962,7 @@
                   <c:v>2</c:v>
                 </c:pt>
                 <c:pt idx="4">
-                  <c:v>3</c:v>
+                  <c:v>4</c:v>
                 </c:pt>
               </c:numCache>
             </c:numRef>
@@ -3989,7 +3989,7 @@
                 <a:ea typeface="Quattrocento Sans" pitchFamily="34" charset="-122"/>
                 <a:cs typeface="Quattrocento Sans" pitchFamily="34" charset="-120"/>
               </a:rPr>
-              <a:t>Nairobi</a:t>
+              <a:t>Kisumu</a:t>
             </a:r>
             <a:pPr algn="l">
               <a:lnSpc>
@@ -4021,7 +4021,7 @@
                 <a:ea typeface="Quattrocento Sans" pitchFamily="34" charset="-122"/>
                 <a:cs typeface="Quattrocento Sans" pitchFamily="34" charset="-120"/>
               </a:rPr>
-              <a:t>KES 72,500</a:t>
+              <a:t>KES 66,375</a:t>
             </a:r>
             <a:pPr algn="l">
               <a:lnSpc>
@@ -4037,7 +4037,7 @@
                 <a:ea typeface="Quattrocento Sans" pitchFamily="34" charset="-122"/>
                 <a:cs typeface="Quattrocento Sans" pitchFamily="34" charset="-120"/>
               </a:rPr>
-              <a:t>, driven by one senior hire.</a:t>
+              <a:t>, Nairobi close behind at KES 65,000.</a:t>
             </a:r>
             <a:endParaRPr lang="en-US" sz="1600" dirty="0"/>
           </a:p>
@@ -4588,7 +4588,7 @@
         </p:nvGraphicFramePr>
         <p:xfrm>
           <a:off x="762000" y="1783080"/>
-          <a:ext cx="14732000" cy="6303873"/>
+          <a:ext cx="14732000" cy="6317589"/>
         </p:xfrm>
         <a:graphic>
           <a:graphicData uri="http://schemas.openxmlformats.org/drawingml/2006/table">
@@ -4933,7 +4933,7 @@
                   </a:tcPr>
                 </a:tc>
               </a:tr>
-              <a:tr h="566928">
+              <a:tr h="516635">
                 <a:tc>
                   <a:txBody>
                     <a:bodyPr/>
@@ -5213,7 +5213,7 @@
                           <a:ea typeface="Quattrocento Sans" pitchFamily="34" charset="-122"/>
                           <a:cs typeface="Quattrocento Sans" pitchFamily="34" charset="-120"/>
                         </a:rPr>
-                        <a:t>+42.6%</a:t>
+                        <a:t>+45.7%</a:t>
                       </a:r>
                       <a:endParaRPr lang="en-US" sz="1600" dirty="0">
                         <a:latin typeface="Quattrocento Sans" charset="0"/>
@@ -5265,7 +5265,7 @@
                   </a:tcPr>
                 </a:tc>
               </a:tr>
-              <a:tr h="566928">
+              <a:tr h="516635">
                 <a:tc>
                   <a:txBody>
                     <a:bodyPr/>
@@ -5545,7 +5545,7 @@
                           <a:ea typeface="Quattrocento Sans" pitchFamily="34" charset="-122"/>
                           <a:cs typeface="Quattrocento Sans" pitchFamily="34" charset="-120"/>
                         </a:rPr>
-                        <a:t>+18.9%</a:t>
+                        <a:t>+21.4%</a:t>
                       </a:r>
                       <a:endParaRPr lang="en-US" sz="1600" dirty="0">
                         <a:latin typeface="Quattrocento Sans" charset="0"/>
@@ -5597,7 +5597,7 @@
                   </a:tcPr>
                 </a:tc>
               </a:tr>
-              <a:tr h="566928">
+              <a:tr h="516635">
                 <a:tc>
                   <a:txBody>
                     <a:bodyPr/>
@@ -5877,7 +5877,7 @@
                           <a:ea typeface="Quattrocento Sans" pitchFamily="34" charset="-122"/>
                           <a:cs typeface="Quattrocento Sans" pitchFamily="34" charset="-120"/>
                         </a:rPr>
-                        <a:t>+10.9%</a:t>
+                        <a:t>+13.3%</a:t>
                       </a:r>
                       <a:endParaRPr lang="en-US" sz="1600" dirty="0">
                         <a:latin typeface="Quattrocento Sans" charset="0"/>
@@ -5929,7 +5929,7 @@
                   </a:tcPr>
                 </a:tc>
               </a:tr>
-              <a:tr h="566928">
+              <a:tr h="516635">
                 <a:tc>
                   <a:txBody>
                     <a:bodyPr/>
@@ -6209,7 +6209,7 @@
                           <a:ea typeface="Quattrocento Sans" pitchFamily="34" charset="-122"/>
                           <a:cs typeface="Quattrocento Sans" pitchFamily="34" charset="-120"/>
                         </a:rPr>
-                        <a:t>-1.7%</a:t>
+                        <a:t>+0.4%</a:t>
                       </a:r>
                       <a:endParaRPr lang="en-US" sz="1600" dirty="0">
                         <a:latin typeface="Quattrocento Sans" charset="0"/>
@@ -6261,7 +6261,7 @@
                   </a:tcPr>
                 </a:tc>
               </a:tr>
-              <a:tr h="566928">
+              <a:tr h="516635">
                 <a:tc>
                   <a:txBody>
                     <a:bodyPr/>
@@ -6343,7 +6343,7 @@
                           <a:ea typeface="Quattrocento Sans" pitchFamily="34" charset="-122"/>
                           <a:cs typeface="Quattrocento Sans" pitchFamily="34" charset="-120"/>
                         </a:rPr>
-                        <a:t>Charlie</a:t>
+                        <a:t>Jamal</a:t>
                       </a:r>
                       <a:endParaRPr lang="en-US" sz="1600" dirty="0">
                         <a:latin typeface="Quattrocento Sans" charset="0"/>
@@ -6541,7 +6541,7 @@
                           <a:ea typeface="Quattrocento Sans" pitchFamily="34" charset="-122"/>
                           <a:cs typeface="Quattrocento Sans" pitchFamily="34" charset="-120"/>
                         </a:rPr>
-                        <a:t>-3.3%</a:t>
+                        <a:t>-1.3%</a:t>
                       </a:r>
                       <a:endParaRPr lang="en-US" sz="1600" dirty="0">
                         <a:latin typeface="Quattrocento Sans" charset="0"/>
@@ -6593,7 +6593,7 @@
                   </a:tcPr>
                 </a:tc>
               </a:tr>
-              <a:tr h="566928">
+              <a:tr h="516635">
                 <a:tc>
                   <a:txBody>
                     <a:bodyPr/>
@@ -6675,7 +6675,7 @@
                           <a:ea typeface="Quattrocento Sans" pitchFamily="34" charset="-122"/>
                           <a:cs typeface="Quattrocento Sans" pitchFamily="34" charset="-120"/>
                         </a:rPr>
-                        <a:t>Jamal</a:t>
+                        <a:t>Charlie</a:t>
                       </a:r>
                       <a:endParaRPr lang="en-US" sz="1600" dirty="0">
                         <a:latin typeface="Quattrocento Sans" charset="0"/>
@@ -6807,7 +6807,7 @@
                           <a:ea typeface="Quattrocento Sans" pitchFamily="34" charset="-122"/>
                           <a:cs typeface="Quattrocento Sans" pitchFamily="34" charset="-120"/>
                         </a:rPr>
-                        <a:t>61,000</a:t>
+                        <a:t>59,500</a:t>
                       </a:r>
                       <a:endParaRPr lang="en-US" sz="1600" dirty="0">
                         <a:latin typeface="Quattrocento Sans" charset="0"/>
@@ -6873,7 +6873,7 @@
                           <a:ea typeface="Quattrocento Sans" pitchFamily="34" charset="-122"/>
                           <a:cs typeface="Quattrocento Sans" pitchFamily="34" charset="-120"/>
                         </a:rPr>
-                        <a:t>-3.3%</a:t>
+                        <a:t>-3.7%</a:t>
                       </a:r>
                       <a:endParaRPr lang="en-US" sz="1600" dirty="0">
                         <a:latin typeface="Quattrocento Sans" charset="0"/>
@@ -6925,7 +6925,7 @@
                   </a:tcPr>
                 </a:tc>
               </a:tr>
-              <a:tr h="566928">
+              <a:tr h="516635">
                 <a:tc>
                   <a:txBody>
                     <a:bodyPr/>
@@ -7205,7 +7205,7 @@
                           <a:ea typeface="Quattrocento Sans" pitchFamily="34" charset="-122"/>
                           <a:cs typeface="Quattrocento Sans" pitchFamily="34" charset="-120"/>
                         </a:rPr>
-                        <a:t>-8.1%</a:t>
+                        <a:t>-6.1%</a:t>
                       </a:r>
                       <a:endParaRPr lang="en-US" sz="1600" dirty="0">
                         <a:latin typeface="Quattrocento Sans" charset="0"/>
@@ -7257,7 +7257,7 @@
                   </a:tcPr>
                 </a:tc>
               </a:tr>
-              <a:tr h="566928">
+              <a:tr h="516635">
                 <a:tc>
                   <a:txBody>
                     <a:bodyPr/>
@@ -7537,7 +7537,7 @@
                           <a:ea typeface="Quattrocento Sans" pitchFamily="34" charset="-122"/>
                           <a:cs typeface="Quattrocento Sans" pitchFamily="34" charset="-120"/>
                         </a:rPr>
-                        <a:t>-12.8%</a:t>
+                        <a:t>-11.0%</a:t>
                       </a:r>
                       <a:endParaRPr lang="en-US" sz="1600" dirty="0">
                         <a:latin typeface="Quattrocento Sans" charset="0"/>
@@ -7589,7 +7589,7 @@
                   </a:tcPr>
                 </a:tc>
               </a:tr>
-              <a:tr h="566928">
+              <a:tr h="516635">
                 <a:tc>
                   <a:txBody>
                     <a:bodyPr/>
@@ -7869,7 +7869,7 @@
                           <a:ea typeface="Quattrocento Sans" pitchFamily="34" charset="-122"/>
                           <a:cs typeface="Quattrocento Sans" pitchFamily="34" charset="-120"/>
                         </a:rPr>
-                        <a:t>-19.2%</a:t>
+                        <a:t>-17.4%</a:t>
                       </a:r>
                       <a:endParaRPr lang="en-US" sz="1600" dirty="0">
                         <a:latin typeface="Quattrocento Sans" charset="0"/>
@@ -7921,7 +7921,7 @@
                   </a:tcPr>
                 </a:tc>
               </a:tr>
-              <a:tr h="566928">
+              <a:tr h="516635">
                 <a:tc>
                   <a:txBody>
                     <a:bodyPr/>
@@ -7938,6 +7938,338 @@
                           <a:cs typeface="Quattrocento Sans" pitchFamily="34" charset="-120"/>
                         </a:rPr>
                         <a:t>10</a:t>
+                      </a:r>
+                      <a:endParaRPr lang="en-US" sz="1600" dirty="0">
+                        <a:latin typeface="Quattrocento Sans" charset="0"/>
+                        <a:ea typeface="Quattrocento Sans" charset="0"/>
+                        <a:cs typeface="Quattrocento Sans" charset="0"/>
+                      </a:endParaRPr>
+                    </a:p>
+                  </a:txBody>
+                  <a:tcPr marL="54864" marR="54864" marT="0" marB="0" anchor="ctr">
+                    <a:lnL w="12700" cap="flat" cmpd="sng" algn="ctr">
+                      <a:solidFill>
+                        <a:srgbClr val="2A3544"/>
+                      </a:solidFill>
+                      <a:prstDash val="solid"/>
+                      <a:round/>
+                      <a:headEnd type="none" w="med" len="med"/>
+                      <a:tailEnd type="none" w="med" len="med"/>
+                    </a:lnL>
+                    <a:lnR w="12700" cap="flat" cmpd="sng" algn="ctr">
+                      <a:solidFill>
+                        <a:srgbClr val="2A3544"/>
+                      </a:solidFill>
+                      <a:prstDash val="solid"/>
+                      <a:round/>
+                      <a:headEnd type="none" w="med" len="med"/>
+                      <a:tailEnd type="none" w="med" len="med"/>
+                    </a:lnR>
+                    <a:lnT w="12700" cap="flat" cmpd="sng" algn="ctr">
+                      <a:solidFill>
+                        <a:srgbClr val="2A3544"/>
+                      </a:solidFill>
+                      <a:prstDash val="solid"/>
+                      <a:round/>
+                      <a:headEnd type="none" w="med" len="med"/>
+                      <a:tailEnd type="none" w="med" len="med"/>
+                    </a:lnT>
+                    <a:lnB w="12700" cap="flat" cmpd="sng" algn="ctr">
+                      <a:solidFill>
+                        <a:srgbClr val="2A3544"/>
+                      </a:solidFill>
+                      <a:prstDash val="solid"/>
+                      <a:round/>
+                      <a:headEnd type="none" w="med" len="med"/>
+                      <a:tailEnd type="none" w="med" len="med"/>
+                    </a:lnB>
+                    <a:solidFill>
+                      <a:srgbClr val="0F1923"/>
+                    </a:solidFill>
+                  </a:tcPr>
+                </a:tc>
+                <a:tc>
+                  <a:txBody>
+                    <a:bodyPr/>
+                    <a:lstStyle/>
+                    <a:p>
+                      <a:pPr algn="ctr"/>
+                      <a:r>
+                        <a:rPr lang="en-US" sz="1600" dirty="0">
+                          <a:solidFill>
+                            <a:srgbClr val="F0F2F5"/>
+                          </a:solidFill>
+                          <a:latin typeface="Quattrocento Sans" pitchFamily="34" charset="0"/>
+                          <a:ea typeface="Quattrocento Sans" pitchFamily="34" charset="-122"/>
+                          <a:cs typeface="Quattrocento Sans" pitchFamily="34" charset="-120"/>
+                        </a:rPr>
+                        <a:t>Kamau</a:t>
+                      </a:r>
+                      <a:endParaRPr lang="en-US" sz="1600" dirty="0">
+                        <a:latin typeface="Quattrocento Sans" charset="0"/>
+                        <a:ea typeface="Quattrocento Sans" charset="0"/>
+                        <a:cs typeface="Quattrocento Sans" charset="0"/>
+                      </a:endParaRPr>
+                    </a:p>
+                  </a:txBody>
+                  <a:tcPr marL="54864" marR="54864" marT="0" marB="0" anchor="ctr">
+                    <a:lnL w="12700" cap="flat" cmpd="sng" algn="ctr">
+                      <a:solidFill>
+                        <a:srgbClr val="2A3544"/>
+                      </a:solidFill>
+                      <a:prstDash val="solid"/>
+                      <a:round/>
+                      <a:headEnd type="none" w="med" len="med"/>
+                      <a:tailEnd type="none" w="med" len="med"/>
+                    </a:lnL>
+                    <a:lnR w="12700" cap="flat" cmpd="sng" algn="ctr">
+                      <a:solidFill>
+                        <a:srgbClr val="2A3544"/>
+                      </a:solidFill>
+                      <a:prstDash val="solid"/>
+                      <a:round/>
+                      <a:headEnd type="none" w="med" len="med"/>
+                      <a:tailEnd type="none" w="med" len="med"/>
+                    </a:lnR>
+                    <a:lnT w="12700" cap="flat" cmpd="sng" algn="ctr">
+                      <a:solidFill>
+                        <a:srgbClr val="2A3544"/>
+                      </a:solidFill>
+                      <a:prstDash val="solid"/>
+                      <a:round/>
+                      <a:headEnd type="none" w="med" len="med"/>
+                      <a:tailEnd type="none" w="med" len="med"/>
+                    </a:lnT>
+                    <a:lnB w="12700" cap="flat" cmpd="sng" algn="ctr">
+                      <a:solidFill>
+                        <a:srgbClr val="2A3544"/>
+                      </a:solidFill>
+                      <a:prstDash val="solid"/>
+                      <a:round/>
+                      <a:headEnd type="none" w="med" len="med"/>
+                      <a:tailEnd type="none" w="med" len="med"/>
+                    </a:lnB>
+                    <a:solidFill>
+                      <a:srgbClr val="0F1923"/>
+                    </a:solidFill>
+                  </a:tcPr>
+                </a:tc>
+                <a:tc>
+                  <a:txBody>
+                    <a:bodyPr/>
+                    <a:lstStyle/>
+                    <a:p>
+                      <a:pPr algn="ctr"/>
+                      <a:r>
+                        <a:rPr lang="en-US" sz="1600" dirty="0">
+                          <a:solidFill>
+                            <a:srgbClr val="F0F2F5"/>
+                          </a:solidFill>
+                          <a:latin typeface="Quattrocento Sans" pitchFamily="34" charset="0"/>
+                          <a:ea typeface="Quattrocento Sans" pitchFamily="34" charset="-122"/>
+                          <a:cs typeface="Quattrocento Sans" pitchFamily="34" charset="-120"/>
+                        </a:rPr>
+                        <a:t>Nairobi</a:t>
+                      </a:r>
+                      <a:endParaRPr lang="en-US" sz="1600" dirty="0">
+                        <a:latin typeface="Quattrocento Sans" charset="0"/>
+                        <a:ea typeface="Quattrocento Sans" charset="0"/>
+                        <a:cs typeface="Quattrocento Sans" charset="0"/>
+                      </a:endParaRPr>
+                    </a:p>
+                  </a:txBody>
+                  <a:tcPr marL="54864" marR="54864" marT="0" marB="0" anchor="ctr">
+                    <a:lnL w="12700" cap="flat" cmpd="sng" algn="ctr">
+                      <a:solidFill>
+                        <a:srgbClr val="2A3544"/>
+                      </a:solidFill>
+                      <a:prstDash val="solid"/>
+                      <a:round/>
+                      <a:headEnd type="none" w="med" len="med"/>
+                      <a:tailEnd type="none" w="med" len="med"/>
+                    </a:lnL>
+                    <a:lnR w="12700" cap="flat" cmpd="sng" algn="ctr">
+                      <a:solidFill>
+                        <a:srgbClr val="2A3544"/>
+                      </a:solidFill>
+                      <a:prstDash val="solid"/>
+                      <a:round/>
+                      <a:headEnd type="none" w="med" len="med"/>
+                      <a:tailEnd type="none" w="med" len="med"/>
+                    </a:lnR>
+                    <a:lnT w="12700" cap="flat" cmpd="sng" algn="ctr">
+                      <a:solidFill>
+                        <a:srgbClr val="2A3544"/>
+                      </a:solidFill>
+                      <a:prstDash val="solid"/>
+                      <a:round/>
+                      <a:headEnd type="none" w="med" len="med"/>
+                      <a:tailEnd type="none" w="med" len="med"/>
+                    </a:lnT>
+                    <a:lnB w="12700" cap="flat" cmpd="sng" algn="ctr">
+                      <a:solidFill>
+                        <a:srgbClr val="2A3544"/>
+                      </a:solidFill>
+                      <a:prstDash val="solid"/>
+                      <a:round/>
+                      <a:headEnd type="none" w="med" len="med"/>
+                      <a:tailEnd type="none" w="med" len="med"/>
+                    </a:lnB>
+                    <a:solidFill>
+                      <a:srgbClr val="0F1923"/>
+                    </a:solidFill>
+                  </a:tcPr>
+                </a:tc>
+                <a:tc>
+                  <a:txBody>
+                    <a:bodyPr/>
+                    <a:lstStyle/>
+                    <a:p>
+                      <a:pPr algn="ctr"/>
+                      <a:r>
+                        <a:rPr lang="en-US" sz="1600" b="1" dirty="0">
+                          <a:solidFill>
+                            <a:srgbClr val="F0F2F5"/>
+                          </a:solidFill>
+                          <a:latin typeface="Quattrocento Sans" pitchFamily="34" charset="0"/>
+                          <a:ea typeface="Quattrocento Sans" pitchFamily="34" charset="-122"/>
+                          <a:cs typeface="Quattrocento Sans" pitchFamily="34" charset="-120"/>
+                        </a:rPr>
+                        <a:t>50,000</a:t>
+                      </a:r>
+                      <a:endParaRPr lang="en-US" sz="1600" dirty="0">
+                        <a:latin typeface="Quattrocento Sans" charset="0"/>
+                        <a:ea typeface="Quattrocento Sans" charset="0"/>
+                        <a:cs typeface="Quattrocento Sans" charset="0"/>
+                      </a:endParaRPr>
+                    </a:p>
+                  </a:txBody>
+                  <a:tcPr marL="54864" marR="54864" marT="0" marB="0" anchor="ctr">
+                    <a:lnL w="12700" cap="flat" cmpd="sng" algn="ctr">
+                      <a:solidFill>
+                        <a:srgbClr val="2A3544"/>
+                      </a:solidFill>
+                      <a:prstDash val="solid"/>
+                      <a:round/>
+                      <a:headEnd type="none" w="med" len="med"/>
+                      <a:tailEnd type="none" w="med" len="med"/>
+                    </a:lnL>
+                    <a:lnR w="12700" cap="flat" cmpd="sng" algn="ctr">
+                      <a:solidFill>
+                        <a:srgbClr val="2A3544"/>
+                      </a:solidFill>
+                      <a:prstDash val="solid"/>
+                      <a:round/>
+                      <a:headEnd type="none" w="med" len="med"/>
+                      <a:tailEnd type="none" w="med" len="med"/>
+                    </a:lnR>
+                    <a:lnT w="12700" cap="flat" cmpd="sng" algn="ctr">
+                      <a:solidFill>
+                        <a:srgbClr val="2A3544"/>
+                      </a:solidFill>
+                      <a:prstDash val="solid"/>
+                      <a:round/>
+                      <a:headEnd type="none" w="med" len="med"/>
+                      <a:tailEnd type="none" w="med" len="med"/>
+                    </a:lnT>
+                    <a:lnB w="12700" cap="flat" cmpd="sng" algn="ctr">
+                      <a:solidFill>
+                        <a:srgbClr val="2A3544"/>
+                      </a:solidFill>
+                      <a:prstDash val="solid"/>
+                      <a:round/>
+                      <a:headEnd type="none" w="med" len="med"/>
+                      <a:tailEnd type="none" w="med" len="med"/>
+                    </a:lnB>
+                    <a:solidFill>
+                      <a:srgbClr val="0F1923"/>
+                    </a:solidFill>
+                  </a:tcPr>
+                </a:tc>
+                <a:tc>
+                  <a:txBody>
+                    <a:bodyPr/>
+                    <a:lstStyle/>
+                    <a:p>
+                      <a:pPr algn="ctr"/>
+                      <a:r>
+                        <a:rPr lang="en-US" sz="1600" dirty="0">
+                          <a:solidFill>
+                            <a:srgbClr val="E57373"/>
+                          </a:solidFill>
+                          <a:latin typeface="Quattrocento Sans" pitchFamily="34" charset="0"/>
+                          <a:ea typeface="Quattrocento Sans" pitchFamily="34" charset="-122"/>
+                          <a:cs typeface="Quattrocento Sans" pitchFamily="34" charset="-120"/>
+                        </a:rPr>
+                        <a:t>-19.1%</a:t>
+                      </a:r>
+                      <a:endParaRPr lang="en-US" sz="1600" dirty="0">
+                        <a:latin typeface="Quattrocento Sans" charset="0"/>
+                        <a:ea typeface="Quattrocento Sans" charset="0"/>
+                        <a:cs typeface="Quattrocento Sans" charset="0"/>
+                      </a:endParaRPr>
+                    </a:p>
+                  </a:txBody>
+                  <a:tcPr marL="54864" marR="54864" marT="0" marB="0" anchor="ctr">
+                    <a:lnL w="12700" cap="flat" cmpd="sng" algn="ctr">
+                      <a:solidFill>
+                        <a:srgbClr val="2A3544"/>
+                      </a:solidFill>
+                      <a:prstDash val="solid"/>
+                      <a:round/>
+                      <a:headEnd type="none" w="med" len="med"/>
+                      <a:tailEnd type="none" w="med" len="med"/>
+                    </a:lnL>
+                    <a:lnR w="12700" cap="flat" cmpd="sng" algn="ctr">
+                      <a:solidFill>
+                        <a:srgbClr val="2A3544"/>
+                      </a:solidFill>
+                      <a:prstDash val="solid"/>
+                      <a:round/>
+                      <a:headEnd type="none" w="med" len="med"/>
+                      <a:tailEnd type="none" w="med" len="med"/>
+                    </a:lnR>
+                    <a:lnT w="12700" cap="flat" cmpd="sng" algn="ctr">
+                      <a:solidFill>
+                        <a:srgbClr val="2A3544"/>
+                      </a:solidFill>
+                      <a:prstDash val="solid"/>
+                      <a:round/>
+                      <a:headEnd type="none" w="med" len="med"/>
+                      <a:tailEnd type="none" w="med" len="med"/>
+                    </a:lnT>
+                    <a:lnB w="12700" cap="flat" cmpd="sng" algn="ctr">
+                      <a:solidFill>
+                        <a:srgbClr val="2A3544"/>
+                      </a:solidFill>
+                      <a:prstDash val="solid"/>
+                      <a:round/>
+                      <a:headEnd type="none" w="med" len="med"/>
+                      <a:tailEnd type="none" w="med" len="med"/>
+                    </a:lnB>
+                    <a:solidFill>
+                      <a:srgbClr val="0F1923"/>
+                    </a:solidFill>
+                  </a:tcPr>
+                </a:tc>
+              </a:tr>
+              <a:tr h="516635">
+                <a:tc>
+                  <a:txBody>
+                    <a:bodyPr/>
+                    <a:lstStyle/>
+                    <a:p>
+                      <a:pPr algn="ctr"/>
+                      <a:r>
+                        <a:rPr lang="en-US" sz="1600" dirty="0">
+                          <a:solidFill>
+                            <a:srgbClr val="F5A623"/>
+                          </a:solidFill>
+                          <a:latin typeface="Quattrocento Sans" pitchFamily="34" charset="0"/>
+                          <a:ea typeface="Quattrocento Sans" pitchFamily="34" charset="-122"/>
+                          <a:cs typeface="Quattrocento Sans" pitchFamily="34" charset="-120"/>
+                        </a:rPr>
+                        <a:t>11</a:t>
                       </a:r>
                       <a:endParaRPr lang="en-US" sz="1600" dirty="0">
                         <a:latin typeface="Quattrocento Sans" charset="0"/>
@@ -8201,7 +8533,7 @@
                           <a:ea typeface="Quattrocento Sans" pitchFamily="34" charset="-122"/>
                           <a:cs typeface="Quattrocento Sans" pitchFamily="34" charset="-120"/>
                         </a:rPr>
-                        <a:t>-23.9%</a:t>
+                        <a:t>-22.3%</a:t>
                       </a:r>
                       <a:endParaRPr lang="en-US" sz="1600" dirty="0">
                         <a:latin typeface="Quattrocento Sans" charset="0"/>
@@ -8961,7 +9293,7 @@
                 <a:ea typeface="Quattrocento Sans" pitchFamily="34" charset="-122"/>
                 <a:cs typeface="Quattrocento Sans" pitchFamily="34" charset="-120"/>
               </a:rPr>
-              <a:t>one hire in January, then two a month, and three in May</a:t>
+              <a:t>one hire in January, two a month from February to April, and four in May</a:t>
             </a:r>
             <a:pPr algn="l">
               <a:lnSpc>
@@ -8977,7 +9309,7 @@
                 <a:ea typeface="Quattrocento Sans" pitchFamily="34" charset="-122"/>
                 <a:cs typeface="Quattrocento Sans" pitchFamily="34" charset="-120"/>
               </a:rPr>
-              <a:t>. Kisumu has the largest team (4 employees, one city assumed), followed by Nairobi and Mombasa (2 each).</a:t>
+              <a:t>. Kisumu has the largest team (4 employees, one of them an assumed city), with Nairobi next on 3 and Mombasa on 2.</a:t>
             </a:r>
             <a:endParaRPr lang="en-US" sz="1600" dirty="0"/>
           </a:p>
@@ -9258,7 +9590,7 @@
                 <a:ea typeface="Quattrocento Sans" pitchFamily="34" charset="-122"/>
                 <a:cs typeface="Quattrocento Sans" pitchFamily="34" charset="-120"/>
               </a:rPr>
-              <a:t>Nairobi</a:t>
+              <a:t>Kisumu</a:t>
             </a:r>
             <a:pPr algn="l">
               <a:lnSpc>
@@ -9290,7 +9622,7 @@
                 <a:ea typeface="Quattrocento Sans" pitchFamily="34" charset="-122"/>
                 <a:cs typeface="Quattrocento Sans" pitchFamily="34" charset="-120"/>
               </a:rPr>
-              <a:t>KES 72,500</a:t>
+              <a:t>KES 66,375</a:t>
             </a:r>
             <a:pPr algn="l">
               <a:lnSpc>
@@ -9306,7 +9638,7 @@
                 <a:ea typeface="Quattrocento Sans" pitchFamily="34" charset="-122"/>
                 <a:cs typeface="Quattrocento Sans" pitchFamily="34" charset="-120"/>
               </a:rPr>
-              <a:t>, driven by one senior hire — without that one person it falls to KES 55,000, below the company mean. </a:t>
+              <a:t>, and Nairobi close behind at KES 65,000 — a figure carried by one senior hire, falling to KES 52,500 without him. </a:t>
             </a:r>
             <a:pPr algn="l">
               <a:lnSpc>
@@ -9386,7 +9718,7 @@
                 <a:ea typeface="Quattrocento Sans" pitchFamily="34" charset="-122"/>
                 <a:cs typeface="Quattrocento Sans" pitchFamily="34" charset="-120"/>
               </a:rPr>
-              <a:t>51% gap</a:t>
+              <a:t>38% gap</a:t>
             </a:r>
             <a:pPr algn="l">
               <a:lnSpc>
@@ -9593,7 +9925,7 @@
                 <a:ea typeface="Quattrocento Sans" pitchFamily="34" charset="-122"/>
                 <a:cs typeface="Quattrocento Sans" pitchFamily="34" charset="-120"/>
               </a:rPr>
-              <a:t> (one of them an assumed city). Nairobi and Mombasa each have </a:t>
+              <a:t> (one of the assumed city). Remove Diana and it ties Nairobi on 3; Mombasa has </a:t>
             </a:r>
             <a:pPr algn="l">
               <a:lnSpc>
@@ -9609,7 +9941,7 @@
                 <a:ea typeface="Quattrocento Sans" pitchFamily="34" charset="-122"/>
                 <a:cs typeface="Quattrocento Sans" pitchFamily="34" charset="-120"/>
               </a:rPr>
-              <a:t>2 employees</a:t>
+              <a:t>2</a:t>
             </a:r>
             <a:pPr algn="l">
               <a:lnSpc>
@@ -9625,7 +9957,7 @@
                 <a:ea typeface="Quattrocento Sans" pitchFamily="34" charset="-122"/>
                 <a:cs typeface="Quattrocento Sans" pitchFamily="34" charset="-120"/>
               </a:rPr>
-              <a:t>, while Eldoret and Nakuru have </a:t>
+              <a:t>, Eldoret and Nakuru </a:t>
             </a:r>
             <a:pPr algn="l">
               <a:lnSpc>
@@ -9816,7 +10148,7 @@
                 <a:ea typeface="Quattrocento Sans" pitchFamily="34" charset="-122"/>
                 <a:cs typeface="Quattrocento Sans" pitchFamily="34" charset="-120"/>
               </a:rPr>
-              <a:t>one hire in January, then two a month, and three in May</a:t>
+              <a:t>one hire in January, two a month from February to April, and four in May</a:t>
             </a:r>
             <a:pPr algn="l">
               <a:lnSpc>
@@ -9991,7 +10323,7 @@
                 <a:ea typeface="Quattrocento Sans" pitchFamily="34" charset="-122"/>
                 <a:cs typeface="Quattrocento Sans" pitchFamily="34" charset="-120"/>
               </a:rPr>
-              <a:t>KES 631,000</a:t>
+              <a:t>KES 679,500</a:t>
             </a:r>
             <a:pPr algn="l">
               <a:lnSpc>
@@ -10023,7 +10355,7 @@
                 <a:ea typeface="Quattrocento Sans" pitchFamily="34" charset="-122"/>
                 <a:cs typeface="Quattrocento Sans" pitchFamily="34" charset="-120"/>
               </a:rPr>
-              <a:t>KES 63,100</a:t>
+              <a:t>KES 61,773</a:t>
             </a:r>
             <a:pPr algn="l">
               <a:lnSpc>
@@ -10039,7 +10371,7 @@
                 <a:ea typeface="Quattrocento Sans" pitchFamily="34" charset="-122"/>
                 <a:cs typeface="Quattrocento Sans" pitchFamily="34" charset="-120"/>
               </a:rPr>
-              <a:t> per employee. Payroll ramped from KES 55,000 in January to KES 631,000 by May as headcount grew from 1 to 10.</a:t>
+              <a:t> per employee. Payroll ramped from KES 55,000 in January to KES 679,500 by May as headcount grew from 1 to 11.</a:t>
             </a:r>
             <a:endParaRPr lang="en-US" sz="1600" dirty="0"/>
           </a:p>
@@ -13020,7 +13352,7 @@
                 <a:ea typeface="Quattrocento Sans" pitchFamily="34" charset="-122"/>
                 <a:cs typeface="Quattrocento Sans" pitchFamily="34" charset="-120"/>
               </a:rPr>
-              <a:t>10 employees</a:t>
+              <a:t>11 employees</a:t>
             </a:r>
             <a:pPr algn="ctr">
               <a:lnSpc>
@@ -14226,7 +14558,7 @@
                           <a:ea typeface="Quattrocento Sans" pitchFamily="34" charset="-122"/>
                           <a:cs typeface="Quattrocento Sans" pitchFamily="34" charset="-120"/>
                         </a:rPr>
-                        <a:t>Filled with median age (30)</a:t>
+                        <a:t>Filled with median age (29)</a:t>
                       </a:r>
                       <a:endParaRPr lang="en-US" sz="1600" dirty="0">
                         <a:latin typeface="Quattrocento Sans" charset="0"/>
@@ -14426,7 +14758,7 @@
                           <a:ea typeface="Quattrocento Sans" pitchFamily="34" charset="-122"/>
                           <a:cs typeface="Quattrocento Sans" pitchFamily="34" charset="-120"/>
                         </a:rPr>
-                        <a:t>Reset to missing, re-filled with median (30)</a:t>
+                        <a:t>Reset to missing, re-filled with median (29)</a:t>
                       </a:r>
                       <a:endParaRPr lang="en-US" sz="1600" dirty="0">
                         <a:latin typeface="Quattrocento Sans" charset="0"/>
@@ -14626,7 +14958,7 @@
                           <a:ea typeface="Quattrocento Sans" pitchFamily="34" charset="-122"/>
                           <a:cs typeface="Quattrocento Sans" pitchFamily="34" charset="-120"/>
                         </a:rPr>
-                        <a:t>Filled with median salary (61,000)</a:t>
+                        <a:t>Filled with median salary (59,500)</a:t>
                       </a:r>
                       <a:endParaRPr lang="en-US" sz="1600" dirty="0">
                         <a:latin typeface="Quattrocento Sans" charset="0"/>
@@ -15717,7 +16049,7 @@
                 <a:ea typeface="Liter" pitchFamily="34" charset="-122"/>
                 <a:cs typeface="Liter" pitchFamily="34" charset="-120"/>
               </a:rPr>
-              <a:t>The 117% Finding</a:t>
+              <a:t>The 109% Finding</a:t>
             </a:r>
             <a:endParaRPr lang="en-US" sz="2000" dirty="0"/>
           </a:p>
@@ -15769,7 +16101,7 @@
                 <a:ea typeface="Quattrocento Sans" pitchFamily="34" charset="-122"/>
                 <a:cs typeface="Quattrocento Sans" pitchFamily="34" charset="-120"/>
               </a:rPr>
-              <a:t>KES 136,750</a:t>
+              <a:t>KES 128,864</a:t>
             </a:r>
             <a:r>
               <a:rPr lang="en-US" sz="1600" dirty="0">
@@ -15791,7 +16123,7 @@
                 <a:ea typeface="Quattrocento Sans" pitchFamily="34" charset="-122"/>
                 <a:cs typeface="Quattrocento Sans" pitchFamily="34" charset="-120"/>
               </a:rPr>
-              <a:t>KES 63,100</a:t>
+              <a:t>KES 61,773</a:t>
             </a:r>
             <a:r>
               <a:rPr lang="en-US" sz="1600" dirty="0">
@@ -15813,7 +16145,7 @@
                 <a:ea typeface="Quattrocento Sans" pitchFamily="34" charset="-122"/>
                 <a:cs typeface="Quattrocento Sans" pitchFamily="34" charset="-120"/>
               </a:rPr>
-              <a:t>inflation of 117%</a:t>
+              <a:t>inflation of 109%</a:t>
             </a:r>
             <a:r>
               <a:rPr lang="en-US" sz="1600" dirty="0">
@@ -16015,7 +16347,7 @@
                 <a:ea typeface="Quattrocento Sans" pitchFamily="34" charset="-122"/>
                 <a:cs typeface="Quattrocento Sans" pitchFamily="34" charset="-120"/>
               </a:rPr>
-              <a:t>KES 66,750</a:t>
+              <a:t>KES 66,375</a:t>
             </a:r>
             <a:r>
               <a:rPr lang="en-US" sz="1600" dirty="0">
@@ -16037,7 +16369,7 @@
                 <a:ea typeface="Quattrocento Sans" pitchFamily="34" charset="-122"/>
                 <a:cs typeface="Quattrocento Sans" pitchFamily="34" charset="-120"/>
               </a:rPr>
-              <a:t>KES 65,667</a:t>
+              <a:t>KES 65,167</a:t>
             </a:r>
             <a:r>
               <a:rPr lang="en-US" sz="1600" dirty="0">
@@ -16426,7 +16758,7 @@
                 <a:ea typeface="Quattrocento Sans" pitchFamily="34" charset="-122"/>
                 <a:cs typeface="Quattrocento Sans" pitchFamily="34" charset="-120"/>
               </a:rPr>
-              <a:t>9 of 10</a:t>
+              <a:t>10 of 11</a:t>
             </a:r>
             <a:r>
               <a:rPr lang="en-US" sz="1600" dirty="0">
@@ -16437,7 +16769,7 @@
                 <a:ea typeface="Quattrocento Sans" pitchFamily="34" charset="-122"/>
                 <a:cs typeface="Quattrocento Sans" pitchFamily="34" charset="-120"/>
               </a:rPr>
-              <a:t> employees in the city view. Total, mean, median, the 117% finding and the distribution analysis stay </a:t>
+              <a:t> employees in the city view. Total, mean, median, the 109% finding and the distribution analysis stay </a:t>
             </a:r>
             <a:r>
               <a:rPr lang="en-US" sz="1600" b="1" dirty="0">
@@ -17143,7 +17475,7 @@
                 <a:ea typeface="Liter" pitchFamily="34" charset="-122"/>
                 <a:cs typeface="Liter" pitchFamily="34" charset="-120"/>
               </a:rPr>
-              <a:t>10</a:t>
+              <a:t>11</a:t>
             </a:r>
             <a:endParaRPr lang="en-US" sz="5200" dirty="0"/>
           </a:p>
@@ -17475,7 +17807,7 @@
                 <a:ea typeface="Liter" pitchFamily="34" charset="-122"/>
                 <a:cs typeface="Liter" pitchFamily="34" charset="-120"/>
               </a:rPr>
-              <a:t>KES 631,000</a:t>
+              <a:t>KES 679,500</a:t>
             </a:r>
             <a:endParaRPr lang="en-US" sz="3600" dirty="0"/>
           </a:p>
@@ -17875,7 +18207,7 @@
                 <a:ea typeface="Liter" pitchFamily="34" charset="-122"/>
                 <a:cs typeface="Liter" pitchFamily="34" charset="-120"/>
               </a:rPr>
-              <a:t>KES 63,100</a:t>
+              <a:t>KES 61,773</a:t>
             </a:r>
             <a:endParaRPr lang="en-US" sz="3600" dirty="0"/>
           </a:p>
@@ -18129,7 +18461,7 @@
                 <a:ea typeface="Liter" pitchFamily="34" charset="-122"/>
                 <a:cs typeface="Liter" pitchFamily="34" charset="-120"/>
               </a:rPr>
-              <a:t>30.5</a:t>
+              <a:t>30.1</a:t>
             </a:r>
             <a:endParaRPr lang="en-US" sz="5200" dirty="0"/>
           </a:p>

</xml_diff>

<commit_message>
Update PPTX to 13-employee snapshot with London at Eldoret
</commit_message>
<xml_diff>
--- a/reports/Employee Salary & Headcount Dashboard.pptx
+++ b/reports/Employee Salary & Headcount Dashboard.pptx
@@ -103,19 +103,19 @@
               <c:strCache>
                 <c:ptCount val="5"/>
                 <c:pt idx="0">
-                  <c:v>Nairobi</c:v>
+                  <c:v>Kisumu</c:v>
                 </c:pt>
                 <c:pt idx="1">
                   <c:v>Mombasa</c:v>
                 </c:pt>
                 <c:pt idx="2">
-                  <c:v>Kisumu</c:v>
+                  <c:v>Nairobi</c:v>
                 </c:pt>
                 <c:pt idx="3">
-                  <c:v>Nakuru</c:v>
+                  <c:v>Eldoret</c:v>
                 </c:pt>
                 <c:pt idx="4">
-                  <c:v>Eldoret</c:v>
+                  <c:v>Nakuru</c:v>
                 </c:pt>
               </c:strCache>
             </c:strRef>
@@ -127,19 +127,19 @@
                 <c:formatCode>General</c:formatCode>
                 <c:ptCount val="5"/>
                 <c:pt idx="0">
+                  <c:v>267500</c:v>
+                </c:pt>
+                <c:pt idx="1">
+                  <c:v>200000</c:v>
+                </c:pt>
+                <c:pt idx="2">
                   <c:v>195000</c:v>
                 </c:pt>
-                <c:pt idx="1">
-                  <c:v>120000</c:v>
-                </c:pt>
-                <c:pt idx="2">
-                  <c:v>265500</c:v>
-                </c:pt>
                 <c:pt idx="3">
-                  <c:v>48000</c:v>
+                  <c:v>126000</c:v>
                 </c:pt>
                 <c:pt idx="4">
-                  <c:v>51000</c:v>
+                  <c:v>48000</c:v>
                 </c:pt>
               </c:numCache>
             </c:numRef>
@@ -354,10 +354,10 @@
                   <c:v>Kisumu</c:v>
                 </c:pt>
                 <c:pt idx="1">
-                  <c:v>Nairobi</c:v>
+                  <c:v>Mombasa</c:v>
                 </c:pt>
                 <c:pt idx="2">
-                  <c:v>Mombasa</c:v>
+                  <c:v>Nairobi</c:v>
                 </c:pt>
                 <c:pt idx="3">
                   <c:v>Eldoret</c:v>
@@ -375,16 +375,16 @@
                 <c:formatCode>General</c:formatCode>
                 <c:ptCount val="5"/>
                 <c:pt idx="0">
-                  <c:v>66375</c:v>
+                  <c:v>66875</c:v>
                 </c:pt>
                 <c:pt idx="1">
+                  <c:v>66667</c:v>
+                </c:pt>
+                <c:pt idx="2">
                   <c:v>65000</c:v>
                 </c:pt>
-                <c:pt idx="2">
-                  <c:v>60000</c:v>
-                </c:pt>
                 <c:pt idx="3">
-                  <c:v>51000</c:v>
+                  <c:v>63000</c:v>
                 </c:pt>
                 <c:pt idx="4">
                   <c:v>48000</c:v>
@@ -779,10 +779,10 @@
                   <c:v>Kisumu</c:v>
                 </c:pt>
                 <c:pt idx="1">
-                  <c:v>Nairobi</c:v>
+                  <c:v>Mombasa</c:v>
                 </c:pt>
                 <c:pt idx="2">
-                  <c:v>Mombasa</c:v>
+                  <c:v>Nairobi</c:v>
                 </c:pt>
                 <c:pt idx="3">
                   <c:v>Eldoret</c:v>
@@ -806,10 +806,10 @@
                   <c:v>3</c:v>
                 </c:pt>
                 <c:pt idx="2">
-                  <c:v>2</c:v>
+                  <c:v>3</c:v>
                 </c:pt>
                 <c:pt idx="3">
-                  <c:v>1</c:v>
+                  <c:v>2</c:v>
                 </c:pt>
                 <c:pt idx="4">
                   <c:v>1</c:v>
@@ -4021,7 +4021,7 @@
                 <a:ea typeface="Quattrocento Sans" pitchFamily="34" charset="-122"/>
                 <a:cs typeface="Quattrocento Sans" pitchFamily="34" charset="-120"/>
               </a:rPr>
-              <a:t>KES 66,375</a:t>
+              <a:t>KES 66,875</a:t>
             </a:r>
             <a:pPr algn="l">
               <a:lnSpc>
@@ -4037,7 +4037,7 @@
                 <a:ea typeface="Quattrocento Sans" pitchFamily="34" charset="-122"/>
                 <a:cs typeface="Quattrocento Sans" pitchFamily="34" charset="-120"/>
               </a:rPr>
-              <a:t>, Nairobi close behind at KES 65,000.</a:t>
+              <a:t>, with Mombasa close behind at KES 66,667 — a figure carried by a single senior hire.</a:t>
             </a:r>
             <a:endParaRPr lang="en-US" sz="1600" dirty="0"/>
           </a:p>
@@ -4588,7 +4588,7 @@
         </p:nvGraphicFramePr>
         <p:xfrm>
           <a:off x="762000" y="1783080"/>
-          <a:ext cx="14732000" cy="6317589"/>
+          <a:ext cx="14732000" cy="7350861"/>
         </p:xfrm>
         <a:graphic>
           <a:graphicData uri="http://schemas.openxmlformats.org/drawingml/2006/table">
@@ -5213,7 +5213,7 @@
                           <a:ea typeface="Quattrocento Sans" pitchFamily="34" charset="-122"/>
                           <a:cs typeface="Quattrocento Sans" pitchFamily="34" charset="-120"/>
                         </a:rPr>
-                        <a:t>+45.7%</a:t>
+                        <a:t>+39.8%</a:t>
                       </a:r>
                       <a:endParaRPr lang="en-US" sz="1600" dirty="0">
                         <a:latin typeface="Quattrocento Sans" charset="0"/>
@@ -5347,7 +5347,7 @@
                           <a:ea typeface="Quattrocento Sans" pitchFamily="34" charset="-122"/>
                           <a:cs typeface="Quattrocento Sans" pitchFamily="34" charset="-120"/>
                         </a:rPr>
-                        <a:t>Kirauti</a:t>
+                        <a:t>Haaland</a:t>
                       </a:r>
                       <a:endParaRPr lang="en-US" sz="1600" dirty="0">
                         <a:latin typeface="Quattrocento Sans" charset="0"/>
@@ -5413,7 +5413,7 @@
                           <a:ea typeface="Quattrocento Sans" pitchFamily="34" charset="-122"/>
                           <a:cs typeface="Quattrocento Sans" pitchFamily="34" charset="-120"/>
                         </a:rPr>
-                        <a:t>Kisumu</a:t>
+                        <a:t>Mombasa</a:t>
                       </a:r>
                       <a:endParaRPr lang="en-US" sz="1600" dirty="0">
                         <a:latin typeface="Quattrocento Sans" charset="0"/>
@@ -5479,7 +5479,7 @@
                           <a:ea typeface="Quattrocento Sans" pitchFamily="34" charset="-122"/>
                           <a:cs typeface="Quattrocento Sans" pitchFamily="34" charset="-120"/>
                         </a:rPr>
-                        <a:t>75,000</a:t>
+                        <a:t>80,000</a:t>
                       </a:r>
                       <a:endParaRPr lang="en-US" sz="1600" dirty="0">
                         <a:latin typeface="Quattrocento Sans" charset="0"/>
@@ -5545,7 +5545,7 @@
                           <a:ea typeface="Quattrocento Sans" pitchFamily="34" charset="-122"/>
                           <a:cs typeface="Quattrocento Sans" pitchFamily="34" charset="-120"/>
                         </a:rPr>
-                        <a:t>+21.4%</a:t>
+                        <a:t>+24.3%</a:t>
                       </a:r>
                       <a:endParaRPr lang="en-US" sz="1600" dirty="0">
                         <a:latin typeface="Quattrocento Sans" charset="0"/>
@@ -5679,7 +5679,7 @@
                           <a:ea typeface="Quattrocento Sans" pitchFamily="34" charset="-122"/>
                           <a:cs typeface="Quattrocento Sans" pitchFamily="34" charset="-120"/>
                         </a:rPr>
-                        <a:t>Diana</a:t>
+                        <a:t>Kirauti</a:t>
                       </a:r>
                       <a:endParaRPr lang="en-US" sz="1600" dirty="0">
                         <a:latin typeface="Quattrocento Sans" charset="0"/>
@@ -5811,7 +5811,7 @@
                           <a:ea typeface="Quattrocento Sans" pitchFamily="34" charset="-122"/>
                           <a:cs typeface="Quattrocento Sans" pitchFamily="34" charset="-120"/>
                         </a:rPr>
-                        <a:t>70,000</a:t>
+                        <a:t>75,000</a:t>
                       </a:r>
                       <a:endParaRPr lang="en-US" sz="1600" dirty="0">
                         <a:latin typeface="Quattrocento Sans" charset="0"/>
@@ -5877,7 +5877,7 @@
                           <a:ea typeface="Quattrocento Sans" pitchFamily="34" charset="-122"/>
                           <a:cs typeface="Quattrocento Sans" pitchFamily="34" charset="-120"/>
                         </a:rPr>
-                        <a:t>+13.3%</a:t>
+                        <a:t>+16.6%</a:t>
                       </a:r>
                       <a:endParaRPr lang="en-US" sz="1600" dirty="0">
                         <a:latin typeface="Quattrocento Sans" charset="0"/>
@@ -6011,7 +6011,7 @@
                           <a:ea typeface="Quattrocento Sans" pitchFamily="34" charset="-122"/>
                           <a:cs typeface="Quattrocento Sans" pitchFamily="34" charset="-120"/>
                         </a:rPr>
-                        <a:t>Bob</a:t>
+                        <a:t>London</a:t>
                       </a:r>
                       <a:endParaRPr lang="en-US" sz="1600" dirty="0">
                         <a:latin typeface="Quattrocento Sans" charset="0"/>
@@ -6077,7 +6077,7 @@
                           <a:ea typeface="Quattrocento Sans" pitchFamily="34" charset="-122"/>
                           <a:cs typeface="Quattrocento Sans" pitchFamily="34" charset="-120"/>
                         </a:rPr>
-                        <a:t>Mombasa</a:t>
+                        <a:t>Eldoret</a:t>
                       </a:r>
                       <a:endParaRPr lang="en-US" sz="1600" dirty="0">
                         <a:latin typeface="Quattrocento Sans" charset="0"/>
@@ -6143,7 +6143,7 @@
                           <a:ea typeface="Quattrocento Sans" pitchFamily="34" charset="-122"/>
                           <a:cs typeface="Quattrocento Sans" pitchFamily="34" charset="-120"/>
                         </a:rPr>
-                        <a:t>62,000</a:t>
+                        <a:t>75,000</a:t>
                       </a:r>
                       <a:endParaRPr lang="en-US" sz="1600" dirty="0">
                         <a:latin typeface="Quattrocento Sans" charset="0"/>
@@ -6209,7 +6209,7 @@
                           <a:ea typeface="Quattrocento Sans" pitchFamily="34" charset="-122"/>
                           <a:cs typeface="Quattrocento Sans" pitchFamily="34" charset="-120"/>
                         </a:rPr>
-                        <a:t>+0.4%</a:t>
+                        <a:t>+16.6%</a:t>
                       </a:r>
                       <a:endParaRPr lang="en-US" sz="1600" dirty="0">
                         <a:latin typeface="Quattrocento Sans" charset="0"/>
@@ -6343,7 +6343,7 @@
                           <a:ea typeface="Quattrocento Sans" pitchFamily="34" charset="-122"/>
                           <a:cs typeface="Quattrocento Sans" pitchFamily="34" charset="-120"/>
                         </a:rPr>
-                        <a:t>Jamal</a:t>
+                        <a:t>Diana</a:t>
                       </a:r>
                       <a:endParaRPr lang="en-US" sz="1600" dirty="0">
                         <a:latin typeface="Quattrocento Sans" charset="0"/>
@@ -6475,7 +6475,7 @@
                           <a:ea typeface="Quattrocento Sans" pitchFamily="34" charset="-122"/>
                           <a:cs typeface="Quattrocento Sans" pitchFamily="34" charset="-120"/>
                         </a:rPr>
-                        <a:t>61,000</a:t>
+                        <a:t>70,000</a:t>
                       </a:r>
                       <a:endParaRPr lang="en-US" sz="1600" dirty="0">
                         <a:latin typeface="Quattrocento Sans" charset="0"/>
@@ -6541,7 +6541,7 @@
                           <a:ea typeface="Quattrocento Sans" pitchFamily="34" charset="-122"/>
                           <a:cs typeface="Quattrocento Sans" pitchFamily="34" charset="-120"/>
                         </a:rPr>
-                        <a:t>-1.3%</a:t>
+                        <a:t>+8.8%</a:t>
                       </a:r>
                       <a:endParaRPr lang="en-US" sz="1600" dirty="0">
                         <a:latin typeface="Quattrocento Sans" charset="0"/>
@@ -6675,7 +6675,7 @@
                           <a:ea typeface="Quattrocento Sans" pitchFamily="34" charset="-122"/>
                           <a:cs typeface="Quattrocento Sans" pitchFamily="34" charset="-120"/>
                         </a:rPr>
-                        <a:t>Charlie</a:t>
+                        <a:t>Bob</a:t>
                       </a:r>
                       <a:endParaRPr lang="en-US" sz="1600" dirty="0">
                         <a:latin typeface="Quattrocento Sans" charset="0"/>
@@ -6741,7 +6741,7 @@
                           <a:ea typeface="Quattrocento Sans" pitchFamily="34" charset="-122"/>
                           <a:cs typeface="Quattrocento Sans" pitchFamily="34" charset="-120"/>
                         </a:rPr>
-                        <a:t>Kisumu</a:t>
+                        <a:t>Mombasa</a:t>
                       </a:r>
                       <a:endParaRPr lang="en-US" sz="1600" dirty="0">
                         <a:latin typeface="Quattrocento Sans" charset="0"/>
@@ -6807,7 +6807,7 @@
                           <a:ea typeface="Quattrocento Sans" pitchFamily="34" charset="-122"/>
                           <a:cs typeface="Quattrocento Sans" pitchFamily="34" charset="-120"/>
                         </a:rPr>
-                        <a:t>59,500</a:t>
+                        <a:t>62,000</a:t>
                       </a:r>
                       <a:endParaRPr lang="en-US" sz="1600" dirty="0">
                         <a:latin typeface="Quattrocento Sans" charset="0"/>
@@ -6873,7 +6873,7 @@
                           <a:ea typeface="Quattrocento Sans" pitchFamily="34" charset="-122"/>
                           <a:cs typeface="Quattrocento Sans" pitchFamily="34" charset="-120"/>
                         </a:rPr>
-                        <a:t>-3.7%</a:t>
+                        <a:t>-3.6%</a:t>
                       </a:r>
                       <a:endParaRPr lang="en-US" sz="1600" dirty="0">
                         <a:latin typeface="Quattrocento Sans" charset="0"/>
@@ -7007,7 +7007,7 @@
                           <a:ea typeface="Quattrocento Sans" pitchFamily="34" charset="-122"/>
                           <a:cs typeface="Quattrocento Sans" pitchFamily="34" charset="-120"/>
                         </a:rPr>
-                        <a:t>Hassan</a:t>
+                        <a:t>Jamal</a:t>
                       </a:r>
                       <a:endParaRPr lang="en-US" sz="1600" dirty="0">
                         <a:latin typeface="Quattrocento Sans" charset="0"/>
@@ -7073,7 +7073,7 @@
                           <a:ea typeface="Quattrocento Sans" pitchFamily="34" charset="-122"/>
                           <a:cs typeface="Quattrocento Sans" pitchFamily="34" charset="-120"/>
                         </a:rPr>
-                        <a:t>Mombasa</a:t>
+                        <a:t>Kisumu</a:t>
                       </a:r>
                       <a:endParaRPr lang="en-US" sz="1600" dirty="0">
                         <a:latin typeface="Quattrocento Sans" charset="0"/>
@@ -7139,7 +7139,7 @@
                           <a:ea typeface="Quattrocento Sans" pitchFamily="34" charset="-122"/>
                           <a:cs typeface="Quattrocento Sans" pitchFamily="34" charset="-120"/>
                         </a:rPr>
-                        <a:t>58,000</a:t>
+                        <a:t>61,000</a:t>
                       </a:r>
                       <a:endParaRPr lang="en-US" sz="1600" dirty="0">
                         <a:latin typeface="Quattrocento Sans" charset="0"/>
@@ -7205,7 +7205,7 @@
                           <a:ea typeface="Quattrocento Sans" pitchFamily="34" charset="-122"/>
                           <a:cs typeface="Quattrocento Sans" pitchFamily="34" charset="-120"/>
                         </a:rPr>
-                        <a:t>-6.1%</a:t>
+                        <a:t>-5.2%</a:t>
                       </a:r>
                       <a:endParaRPr lang="en-US" sz="1600" dirty="0">
                         <a:latin typeface="Quattrocento Sans" charset="0"/>
@@ -7339,7 +7339,7 @@
                           <a:ea typeface="Quattrocento Sans" pitchFamily="34" charset="-122"/>
                           <a:cs typeface="Quattrocento Sans" pitchFamily="34" charset="-120"/>
                         </a:rPr>
-                        <a:t>Alice</a:t>
+                        <a:t>Charlie</a:t>
                       </a:r>
                       <a:endParaRPr lang="en-US" sz="1600" dirty="0">
                         <a:latin typeface="Quattrocento Sans" charset="0"/>
@@ -7405,7 +7405,7 @@
                           <a:ea typeface="Quattrocento Sans" pitchFamily="34" charset="-122"/>
                           <a:cs typeface="Quattrocento Sans" pitchFamily="34" charset="-120"/>
                         </a:rPr>
-                        <a:t>Nairobi</a:t>
+                        <a:t>Kisumu</a:t>
                       </a:r>
                       <a:endParaRPr lang="en-US" sz="1600" dirty="0">
                         <a:latin typeface="Quattrocento Sans" charset="0"/>
@@ -7471,7 +7471,7 @@
                           <a:ea typeface="Quattrocento Sans" pitchFamily="34" charset="-122"/>
                           <a:cs typeface="Quattrocento Sans" pitchFamily="34" charset="-120"/>
                         </a:rPr>
-                        <a:t>55,000</a:t>
+                        <a:t>61,500</a:t>
                       </a:r>
                       <a:endParaRPr lang="en-US" sz="1600" dirty="0">
                         <a:latin typeface="Quattrocento Sans" charset="0"/>
@@ -7537,7 +7537,7 @@
                           <a:ea typeface="Quattrocento Sans" pitchFamily="34" charset="-122"/>
                           <a:cs typeface="Quattrocento Sans" pitchFamily="34" charset="-120"/>
                         </a:rPr>
-                        <a:t>-11.0%</a:t>
+                        <a:t>-4.4%</a:t>
                       </a:r>
                       <a:endParaRPr lang="en-US" sz="1600" dirty="0">
                         <a:latin typeface="Quattrocento Sans" charset="0"/>
@@ -7671,7 +7671,7 @@
                           <a:ea typeface="Quattrocento Sans" pitchFamily="34" charset="-122"/>
                           <a:cs typeface="Quattrocento Sans" pitchFamily="34" charset="-120"/>
                         </a:rPr>
-                        <a:t>Faith</a:t>
+                        <a:t>Hassan</a:t>
                       </a:r>
                       <a:endParaRPr lang="en-US" sz="1600" dirty="0">
                         <a:latin typeface="Quattrocento Sans" charset="0"/>
@@ -7737,7 +7737,7 @@
                           <a:ea typeface="Quattrocento Sans" pitchFamily="34" charset="-122"/>
                           <a:cs typeface="Quattrocento Sans" pitchFamily="34" charset="-120"/>
                         </a:rPr>
-                        <a:t>Eldoret</a:t>
+                        <a:t>Mombasa</a:t>
                       </a:r>
                       <a:endParaRPr lang="en-US" sz="1600" dirty="0">
                         <a:latin typeface="Quattrocento Sans" charset="0"/>
@@ -7803,7 +7803,7 @@
                           <a:ea typeface="Quattrocento Sans" pitchFamily="34" charset="-122"/>
                           <a:cs typeface="Quattrocento Sans" pitchFamily="34" charset="-120"/>
                         </a:rPr>
-                        <a:t>51,000</a:t>
+                        <a:t>58,000</a:t>
                       </a:r>
                       <a:endParaRPr lang="en-US" sz="1600" dirty="0">
                         <a:latin typeface="Quattrocento Sans" charset="0"/>
@@ -7869,7 +7869,7 @@
                           <a:ea typeface="Quattrocento Sans" pitchFamily="34" charset="-122"/>
                           <a:cs typeface="Quattrocento Sans" pitchFamily="34" charset="-120"/>
                         </a:rPr>
-                        <a:t>-17.4%</a:t>
+                        <a:t>-9.9%</a:t>
                       </a:r>
                       <a:endParaRPr lang="en-US" sz="1600" dirty="0">
                         <a:latin typeface="Quattrocento Sans" charset="0"/>
@@ -8003,7 +8003,7 @@
                           <a:ea typeface="Quattrocento Sans" pitchFamily="34" charset="-122"/>
                           <a:cs typeface="Quattrocento Sans" pitchFamily="34" charset="-120"/>
                         </a:rPr>
-                        <a:t>Kamau</a:t>
+                        <a:t>Alice</a:t>
                       </a:r>
                       <a:endParaRPr lang="en-US" sz="1600" dirty="0">
                         <a:latin typeface="Quattrocento Sans" charset="0"/>
@@ -8135,7 +8135,7 @@
                           <a:ea typeface="Quattrocento Sans" pitchFamily="34" charset="-122"/>
                           <a:cs typeface="Quattrocento Sans" pitchFamily="34" charset="-120"/>
                         </a:rPr>
-                        <a:t>50,000</a:t>
+                        <a:t>55,000</a:t>
                       </a:r>
                       <a:endParaRPr lang="en-US" sz="1600" dirty="0">
                         <a:latin typeface="Quattrocento Sans" charset="0"/>
@@ -8201,7 +8201,7 @@
                           <a:ea typeface="Quattrocento Sans" pitchFamily="34" charset="-122"/>
                           <a:cs typeface="Quattrocento Sans" pitchFamily="34" charset="-120"/>
                         </a:rPr>
-                        <a:t>-19.1%</a:t>
+                        <a:t>-14.5%</a:t>
                       </a:r>
                       <a:endParaRPr lang="en-US" sz="1600" dirty="0">
                         <a:latin typeface="Quattrocento Sans" charset="0"/>
@@ -8335,7 +8335,7 @@
                           <a:ea typeface="Quattrocento Sans" pitchFamily="34" charset="-122"/>
                           <a:cs typeface="Quattrocento Sans" pitchFamily="34" charset="-120"/>
                         </a:rPr>
-                        <a:t>Evan</a:t>
+                        <a:t>Faith</a:t>
                       </a:r>
                       <a:endParaRPr lang="en-US" sz="1600" dirty="0">
                         <a:latin typeface="Quattrocento Sans" charset="0"/>
@@ -8401,7 +8401,7 @@
                           <a:ea typeface="Quattrocento Sans" pitchFamily="34" charset="-122"/>
                           <a:cs typeface="Quattrocento Sans" pitchFamily="34" charset="-120"/>
                         </a:rPr>
-                        <a:t>Nakuru</a:t>
+                        <a:t>Eldoret</a:t>
                       </a:r>
                       <a:endParaRPr lang="en-US" sz="1600" dirty="0">
                         <a:latin typeface="Quattrocento Sans" charset="0"/>
@@ -8467,7 +8467,339 @@
                           <a:ea typeface="Quattrocento Sans" pitchFamily="34" charset="-122"/>
                           <a:cs typeface="Quattrocento Sans" pitchFamily="34" charset="-120"/>
                         </a:rPr>
-                        <a:t>48,000</a:t>
+                        <a:t>51,000</a:t>
+                      </a:r>
+                      <a:endParaRPr lang="en-US" sz="1600" dirty="0">
+                        <a:latin typeface="Quattrocento Sans" charset="0"/>
+                        <a:ea typeface="Quattrocento Sans" charset="0"/>
+                        <a:cs typeface="Quattrocento Sans" charset="0"/>
+                      </a:endParaRPr>
+                    </a:p>
+                  </a:txBody>
+                  <a:tcPr marL="54864" marR="54864" marT="0" marB="0" anchor="ctr">
+                    <a:lnL w="12700" cap="flat" cmpd="sng" algn="ctr">
+                      <a:solidFill>
+                        <a:srgbClr val="2A3544"/>
+                      </a:solidFill>
+                      <a:prstDash val="solid"/>
+                      <a:round/>
+                      <a:headEnd type="none" w="med" len="med"/>
+                      <a:tailEnd type="none" w="med" len="med"/>
+                    </a:lnL>
+                    <a:lnR w="12700" cap="flat" cmpd="sng" algn="ctr">
+                      <a:solidFill>
+                        <a:srgbClr val="2A3544"/>
+                      </a:solidFill>
+                      <a:prstDash val="solid"/>
+                      <a:round/>
+                      <a:headEnd type="none" w="med" len="med"/>
+                      <a:tailEnd type="none" w="med" len="med"/>
+                    </a:lnR>
+                    <a:lnT w="12700" cap="flat" cmpd="sng" algn="ctr">
+                      <a:solidFill>
+                        <a:srgbClr val="2A3544"/>
+                      </a:solidFill>
+                      <a:prstDash val="solid"/>
+                      <a:round/>
+                      <a:headEnd type="none" w="med" len="med"/>
+                      <a:tailEnd type="none" w="med" len="med"/>
+                    </a:lnT>
+                    <a:lnB w="12700" cap="flat" cmpd="sng" algn="ctr">
+                      <a:solidFill>
+                        <a:srgbClr val="2A3544"/>
+                      </a:solidFill>
+                      <a:prstDash val="solid"/>
+                      <a:round/>
+                      <a:headEnd type="none" w="med" len="med"/>
+                      <a:tailEnd type="none" w="med" len="med"/>
+                    </a:lnB>
+                    <a:solidFill>
+                      <a:srgbClr val="0F1923"/>
+                    </a:solidFill>
+                  </a:tcPr>
+                </a:tc>
+                <a:tc>
+                  <a:txBody>
+                    <a:bodyPr/>
+                    <a:lstStyle/>
+                    <a:p>
+                      <a:pPr algn="ctr"/>
+                      <a:r>
+                        <a:rPr lang="en-US" sz="1600" dirty="0">
+                          <a:solidFill>
+                            <a:srgbClr val="E57373"/>
+                          </a:solidFill>
+                          <a:latin typeface="Quattrocento Sans" pitchFamily="34" charset="0"/>
+                          <a:ea typeface="Quattrocento Sans" pitchFamily="34" charset="-122"/>
+                          <a:cs typeface="Quattrocento Sans" pitchFamily="34" charset="-120"/>
+                        </a:rPr>
+                        <a:t>-20.7%</a:t>
+                      </a:r>
+                      <a:endParaRPr lang="en-US" sz="1600" dirty="0">
+                        <a:latin typeface="Quattrocento Sans" charset="0"/>
+                        <a:ea typeface="Quattrocento Sans" charset="0"/>
+                        <a:cs typeface="Quattrocento Sans" charset="0"/>
+                      </a:endParaRPr>
+                    </a:p>
+                  </a:txBody>
+                  <a:tcPr marL="54864" marR="54864" marT="0" marB="0" anchor="ctr">
+                    <a:lnL w="12700" cap="flat" cmpd="sng" algn="ctr">
+                      <a:solidFill>
+                        <a:srgbClr val="2A3544"/>
+                      </a:solidFill>
+                      <a:prstDash val="solid"/>
+                      <a:round/>
+                      <a:headEnd type="none" w="med" len="med"/>
+                      <a:tailEnd type="none" w="med" len="med"/>
+                    </a:lnL>
+                    <a:lnR w="12700" cap="flat" cmpd="sng" algn="ctr">
+                      <a:solidFill>
+                        <a:srgbClr val="2A3544"/>
+                      </a:solidFill>
+                      <a:prstDash val="solid"/>
+                      <a:round/>
+                      <a:headEnd type="none" w="med" len="med"/>
+                      <a:tailEnd type="none" w="med" len="med"/>
+                    </a:lnR>
+                    <a:lnT w="12700" cap="flat" cmpd="sng" algn="ctr">
+                      <a:solidFill>
+                        <a:srgbClr val="2A3544"/>
+                      </a:solidFill>
+                      <a:prstDash val="solid"/>
+                      <a:round/>
+                      <a:headEnd type="none" w="med" len="med"/>
+                      <a:tailEnd type="none" w="med" len="med"/>
+                    </a:lnT>
+                    <a:lnB w="12700" cap="flat" cmpd="sng" algn="ctr">
+                      <a:solidFill>
+                        <a:srgbClr val="2A3544"/>
+                      </a:solidFill>
+                      <a:prstDash val="solid"/>
+                      <a:round/>
+                      <a:headEnd type="none" w="med" len="med"/>
+                      <a:tailEnd type="none" w="med" len="med"/>
+                    </a:lnB>
+                    <a:solidFill>
+                      <a:srgbClr val="0F1923"/>
+                    </a:solidFill>
+                  </a:tcPr>
+                </a:tc>
+              </a:tr>
+              <a:tr h="516635">
+                <a:tc>
+                  <a:txBody>
+                    <a:bodyPr/>
+                    <a:lstStyle/>
+                    <a:p>
+                      <a:pPr algn="ctr"/>
+                      <a:r>
+                        <a:rPr lang="en-US" sz="1600" dirty="0">
+                          <a:solidFill>
+                            <a:srgbClr val="F5A623"/>
+                          </a:solidFill>
+                          <a:latin typeface="Quattrocento Sans" pitchFamily="34" charset="0"/>
+                          <a:ea typeface="Quattrocento Sans" pitchFamily="34" charset="-122"/>
+                          <a:cs typeface="Quattrocento Sans" pitchFamily="34" charset="-120"/>
+                        </a:rPr>
+                        <a:t>12</a:t>
+                      </a:r>
+                      <a:endParaRPr lang="en-US" sz="1600" dirty="0">
+                        <a:latin typeface="Quattrocento Sans" charset="0"/>
+                        <a:ea typeface="Quattrocento Sans" charset="0"/>
+                        <a:cs typeface="Quattrocento Sans" charset="0"/>
+                      </a:endParaRPr>
+                    </a:p>
+                  </a:txBody>
+                  <a:tcPr marL="54864" marR="54864" marT="0" marB="0" anchor="ctr">
+                    <a:lnL w="12700" cap="flat" cmpd="sng" algn="ctr">
+                      <a:solidFill>
+                        <a:srgbClr val="2A3544"/>
+                      </a:solidFill>
+                      <a:prstDash val="solid"/>
+                      <a:round/>
+                      <a:headEnd type="none" w="med" len="med"/>
+                      <a:tailEnd type="none" w="med" len="med"/>
+                    </a:lnL>
+                    <a:lnR w="12700" cap="flat" cmpd="sng" algn="ctr">
+                      <a:solidFill>
+                        <a:srgbClr val="2A3544"/>
+                      </a:solidFill>
+                      <a:prstDash val="solid"/>
+                      <a:round/>
+                      <a:headEnd type="none" w="med" len="med"/>
+                      <a:tailEnd type="none" w="med" len="med"/>
+                    </a:lnR>
+                    <a:lnT w="12700" cap="flat" cmpd="sng" algn="ctr">
+                      <a:solidFill>
+                        <a:srgbClr val="2A3544"/>
+                      </a:solidFill>
+                      <a:prstDash val="solid"/>
+                      <a:round/>
+                      <a:headEnd type="none" w="med" len="med"/>
+                      <a:tailEnd type="none" w="med" len="med"/>
+                    </a:lnT>
+                    <a:lnB w="12700" cap="flat" cmpd="sng" algn="ctr">
+                      <a:solidFill>
+                        <a:srgbClr val="2A3544"/>
+                      </a:solidFill>
+                      <a:prstDash val="solid"/>
+                      <a:round/>
+                      <a:headEnd type="none" w="med" len="med"/>
+                      <a:tailEnd type="none" w="med" len="med"/>
+                    </a:lnB>
+                    <a:solidFill>
+                      <a:srgbClr val="0F1923"/>
+                    </a:solidFill>
+                  </a:tcPr>
+                </a:tc>
+                <a:tc>
+                  <a:txBody>
+                    <a:bodyPr/>
+                    <a:lstStyle/>
+                    <a:p>
+                      <a:pPr algn="ctr"/>
+                      <a:r>
+                        <a:rPr lang="en-US" sz="1600" dirty="0">
+                          <a:solidFill>
+                            <a:srgbClr val="F0F2F5"/>
+                          </a:solidFill>
+                          <a:latin typeface="Quattrocento Sans" pitchFamily="34" charset="0"/>
+                          <a:ea typeface="Quattrocento Sans" pitchFamily="34" charset="-122"/>
+                          <a:cs typeface="Quattrocento Sans" pitchFamily="34" charset="-120"/>
+                        </a:rPr>
+                        <a:t>Kamau</a:t>
+                      </a:r>
+                      <a:endParaRPr lang="en-US" sz="1600" dirty="0">
+                        <a:latin typeface="Quattrocento Sans" charset="0"/>
+                        <a:ea typeface="Quattrocento Sans" charset="0"/>
+                        <a:cs typeface="Quattrocento Sans" charset="0"/>
+                      </a:endParaRPr>
+                    </a:p>
+                  </a:txBody>
+                  <a:tcPr marL="54864" marR="54864" marT="0" marB="0" anchor="ctr">
+                    <a:lnL w="12700" cap="flat" cmpd="sng" algn="ctr">
+                      <a:solidFill>
+                        <a:srgbClr val="2A3544"/>
+                      </a:solidFill>
+                      <a:prstDash val="solid"/>
+                      <a:round/>
+                      <a:headEnd type="none" w="med" len="med"/>
+                      <a:tailEnd type="none" w="med" len="med"/>
+                    </a:lnL>
+                    <a:lnR w="12700" cap="flat" cmpd="sng" algn="ctr">
+                      <a:solidFill>
+                        <a:srgbClr val="2A3544"/>
+                      </a:solidFill>
+                      <a:prstDash val="solid"/>
+                      <a:round/>
+                      <a:headEnd type="none" w="med" len="med"/>
+                      <a:tailEnd type="none" w="med" len="med"/>
+                    </a:lnR>
+                    <a:lnT w="12700" cap="flat" cmpd="sng" algn="ctr">
+                      <a:solidFill>
+                        <a:srgbClr val="2A3544"/>
+                      </a:solidFill>
+                      <a:prstDash val="solid"/>
+                      <a:round/>
+                      <a:headEnd type="none" w="med" len="med"/>
+                      <a:tailEnd type="none" w="med" len="med"/>
+                    </a:lnT>
+                    <a:lnB w="12700" cap="flat" cmpd="sng" algn="ctr">
+                      <a:solidFill>
+                        <a:srgbClr val="2A3544"/>
+                      </a:solidFill>
+                      <a:prstDash val="solid"/>
+                      <a:round/>
+                      <a:headEnd type="none" w="med" len="med"/>
+                      <a:tailEnd type="none" w="med" len="med"/>
+                    </a:lnB>
+                    <a:solidFill>
+                      <a:srgbClr val="0F1923"/>
+                    </a:solidFill>
+                  </a:tcPr>
+                </a:tc>
+                <a:tc>
+                  <a:txBody>
+                    <a:bodyPr/>
+                    <a:lstStyle/>
+                    <a:p>
+                      <a:pPr algn="ctr"/>
+                      <a:r>
+                        <a:rPr lang="en-US" sz="1600" dirty="0">
+                          <a:solidFill>
+                            <a:srgbClr val="F0F2F5"/>
+                          </a:solidFill>
+                          <a:latin typeface="Quattrocento Sans" pitchFamily="34" charset="0"/>
+                          <a:ea typeface="Quattrocento Sans" pitchFamily="34" charset="-122"/>
+                          <a:cs typeface="Quattrocento Sans" pitchFamily="34" charset="-120"/>
+                        </a:rPr>
+                        <a:t>Nairobi</a:t>
+                      </a:r>
+                      <a:endParaRPr lang="en-US" sz="1600" dirty="0">
+                        <a:latin typeface="Quattrocento Sans" charset="0"/>
+                        <a:ea typeface="Quattrocento Sans" charset="0"/>
+                        <a:cs typeface="Quattrocento Sans" charset="0"/>
+                      </a:endParaRPr>
+                    </a:p>
+                  </a:txBody>
+                  <a:tcPr marL="54864" marR="54864" marT="0" marB="0" anchor="ctr">
+                    <a:lnL w="12700" cap="flat" cmpd="sng" algn="ctr">
+                      <a:solidFill>
+                        <a:srgbClr val="2A3544"/>
+                      </a:solidFill>
+                      <a:prstDash val="solid"/>
+                      <a:round/>
+                      <a:headEnd type="none" w="med" len="med"/>
+                      <a:tailEnd type="none" w="med" len="med"/>
+                    </a:lnL>
+                    <a:lnR w="12700" cap="flat" cmpd="sng" algn="ctr">
+                      <a:solidFill>
+                        <a:srgbClr val="2A3544"/>
+                      </a:solidFill>
+                      <a:prstDash val="solid"/>
+                      <a:round/>
+                      <a:headEnd type="none" w="med" len="med"/>
+                      <a:tailEnd type="none" w="med" len="med"/>
+                    </a:lnR>
+                    <a:lnT w="12700" cap="flat" cmpd="sng" algn="ctr">
+                      <a:solidFill>
+                        <a:srgbClr val="2A3544"/>
+                      </a:solidFill>
+                      <a:prstDash val="solid"/>
+                      <a:round/>
+                      <a:headEnd type="none" w="med" len="med"/>
+                      <a:tailEnd type="none" w="med" len="med"/>
+                    </a:lnT>
+                    <a:lnB w="12700" cap="flat" cmpd="sng" algn="ctr">
+                      <a:solidFill>
+                        <a:srgbClr val="2A3544"/>
+                      </a:solidFill>
+                      <a:prstDash val="solid"/>
+                      <a:round/>
+                      <a:headEnd type="none" w="med" len="med"/>
+                      <a:tailEnd type="none" w="med" len="med"/>
+                    </a:lnB>
+                    <a:solidFill>
+                      <a:srgbClr val="0F1923"/>
+                    </a:solidFill>
+                  </a:tcPr>
+                </a:tc>
+                <a:tc>
+                  <a:txBody>
+                    <a:bodyPr/>
+                    <a:lstStyle/>
+                    <a:p>
+                      <a:pPr algn="ctr"/>
+                      <a:r>
+                        <a:rPr lang="en-US" sz="1600" b="1" dirty="0">
+                          <a:solidFill>
+                            <a:srgbClr val="F0F2F5"/>
+                          </a:solidFill>
+                          <a:latin typeface="Quattrocento Sans" pitchFamily="34" charset="0"/>
+                          <a:ea typeface="Quattrocento Sans" pitchFamily="34" charset="-122"/>
+                          <a:cs typeface="Quattrocento Sans" pitchFamily="34" charset="-120"/>
+                        </a:rPr>
+                        <a:t>50,000</a:t>
                       </a:r>
                       <a:endParaRPr lang="en-US" sz="1600" dirty="0">
                         <a:latin typeface="Quattrocento Sans" charset="0"/>
@@ -9622,7 +9954,7 @@
                 <a:ea typeface="Quattrocento Sans" pitchFamily="34" charset="-122"/>
                 <a:cs typeface="Quattrocento Sans" pitchFamily="34" charset="-120"/>
               </a:rPr>
-              <a:t>KES 66,375</a:t>
+              <a:t>KES 66,875</a:t>
             </a:r>
             <a:pPr algn="l">
               <a:lnSpc>
@@ -9638,7 +9970,7 @@
                 <a:ea typeface="Quattrocento Sans" pitchFamily="34" charset="-122"/>
                 <a:cs typeface="Quattrocento Sans" pitchFamily="34" charset="-120"/>
               </a:rPr>
-              <a:t>, and Nairobi close behind at KES 65,000 — a figure carried by one senior hire, falling to KES 52,500 without him. </a:t>
+              <a:t>, and Mombasa close behind at KES 66,667 — a figure carried by a single senior hire.</a:t>
             </a:r>
             <a:pPr algn="l">
               <a:lnSpc>
@@ -9718,7 +10050,7 @@
                 <a:ea typeface="Quattrocento Sans" pitchFamily="34" charset="-122"/>
                 <a:cs typeface="Quattrocento Sans" pitchFamily="34" charset="-120"/>
               </a:rPr>
-              <a:t>38% gap</a:t>
+              <a:t>39% gap</a:t>
             </a:r>
             <a:pPr algn="l">
               <a:lnSpc>
@@ -10323,7 +10655,7 @@
                 <a:ea typeface="Quattrocento Sans" pitchFamily="34" charset="-122"/>
                 <a:cs typeface="Quattrocento Sans" pitchFamily="34" charset="-120"/>
               </a:rPr>
-              <a:t>KES 679,500</a:t>
+              <a:t>KES 836,500</a:t>
             </a:r>
             <a:pPr algn="l">
               <a:lnSpc>
@@ -10355,7 +10687,7 @@
                 <a:ea typeface="Quattrocento Sans" pitchFamily="34" charset="-122"/>
                 <a:cs typeface="Quattrocento Sans" pitchFamily="34" charset="-120"/>
               </a:rPr>
-              <a:t>KES 61,773</a:t>
+              <a:t>KES 64,346</a:t>
             </a:r>
             <a:pPr algn="l">
               <a:lnSpc>
@@ -10371,7 +10703,7 @@
                 <a:ea typeface="Quattrocento Sans" pitchFamily="34" charset="-122"/>
                 <a:cs typeface="Quattrocento Sans" pitchFamily="34" charset="-120"/>
               </a:rPr>
-              <a:t> per employee. Payroll ramped from KES 55,000 in January to KES 679,500 by May as headcount grew from 1 to 11.</a:t>
+              <a:t> per employee. Payroll ramped from KES 55,000 in January to KES 836,500 by May as headcount grew from 1 to 13.</a:t>
             </a:r>
             <a:endParaRPr lang="en-US" sz="1600" dirty="0"/>
           </a:p>
@@ -11902,6 +12234,10 @@
           </a:solidFill>
           <a:ln/>
         </p:spPr>
+        <p:txBody>
+          <a:bodyPr/>
+          <a:p/>
+        </p:txBody>
       </p:sp>
       <p:sp>
         <p:nvSpPr>
@@ -11963,6 +12299,10 @@
           </a:solidFill>
           <a:ln/>
         </p:spPr>
+        <p:txBody>
+          <a:bodyPr/>
+          <a:p/>
+        </p:txBody>
       </p:sp>
       <p:sp>
         <p:nvSpPr>
@@ -12105,6 +12445,10 @@
           </a:solidFill>
           <a:ln/>
         </p:spPr>
+        <p:txBody>
+          <a:bodyPr/>
+          <a:p/>
+        </p:txBody>
       </p:sp>
       <p:sp>
         <p:nvSpPr>
@@ -12294,6 +12638,10 @@
             <a:tailEnd type="arrow"/>
           </a:ln>
         </p:spPr>
+        <p:txBody>
+          <a:bodyPr/>
+          <a:p/>
+        </p:txBody>
       </p:sp>
       <p:sp>
         <p:nvSpPr>
@@ -12314,6 +12662,10 @@
           </a:solidFill>
           <a:ln/>
         </p:spPr>
+        <p:txBody>
+          <a:bodyPr/>
+          <a:p/>
+        </p:txBody>
       </p:sp>
       <p:sp>
         <p:nvSpPr>
@@ -12452,6 +12804,10 @@
           </a:solidFill>
           <a:ln/>
         </p:spPr>
+        <p:txBody>
+          <a:bodyPr/>
+          <a:p/>
+        </p:txBody>
       </p:sp>
       <p:sp>
         <p:nvSpPr>
@@ -12641,6 +12997,10 @@
             <a:tailEnd type="arrow"/>
           </a:ln>
         </p:spPr>
+        <p:txBody>
+          <a:bodyPr/>
+          <a:p/>
+        </p:txBody>
       </p:sp>
       <p:sp>
         <p:nvSpPr>
@@ -12661,6 +13021,10 @@
           </a:solidFill>
           <a:ln/>
         </p:spPr>
+        <p:txBody>
+          <a:bodyPr/>
+          <a:p/>
+        </p:txBody>
       </p:sp>
       <p:sp>
         <p:nvSpPr>
@@ -12801,6 +13165,10 @@
           </a:solidFill>
           <a:ln/>
         </p:spPr>
+        <p:txBody>
+          <a:bodyPr/>
+          <a:p/>
+        </p:txBody>
       </p:sp>
       <p:sp>
         <p:nvSpPr>
@@ -12990,6 +13358,10 @@
             <a:tailEnd type="arrow"/>
           </a:ln>
         </p:spPr>
+        <p:txBody>
+          <a:bodyPr/>
+          <a:p/>
+        </p:txBody>
       </p:sp>
       <p:sp>
         <p:nvSpPr>
@@ -13010,6 +13382,10 @@
           </a:solidFill>
           <a:ln/>
         </p:spPr>
+        <p:txBody>
+          <a:bodyPr/>
+          <a:p/>
+        </p:txBody>
       </p:sp>
       <p:sp>
         <p:nvSpPr>
@@ -13136,6 +13512,10 @@
           </a:solidFill>
           <a:ln/>
         </p:spPr>
+        <p:txBody>
+          <a:bodyPr/>
+          <a:p/>
+        </p:txBody>
       </p:sp>
       <p:sp>
         <p:nvSpPr>
@@ -13352,7 +13732,7 @@
                 <a:ea typeface="Quattrocento Sans" pitchFamily="34" charset="-122"/>
                 <a:cs typeface="Quattrocento Sans" pitchFamily="34" charset="-120"/>
               </a:rPr>
-              <a:t>11 employees</a:t>
+              <a:t>13 employees</a:t>
             </a:r>
             <a:pPr algn="ctr">
               <a:lnSpc>
@@ -16049,7 +16429,7 @@
                 <a:ea typeface="Liter" pitchFamily="34" charset="-122"/>
                 <a:cs typeface="Liter" pitchFamily="34" charset="-120"/>
               </a:rPr>
-              <a:t>The 109% Finding</a:t>
+              <a:t>The 88% Finding</a:t>
             </a:r>
             <a:endParaRPr lang="en-US" sz="2000" dirty="0"/>
           </a:p>
@@ -16101,7 +16481,7 @@
                 <a:ea typeface="Quattrocento Sans" pitchFamily="34" charset="-122"/>
                 <a:cs typeface="Quattrocento Sans" pitchFamily="34" charset="-120"/>
               </a:rPr>
-              <a:t>KES 128,864</a:t>
+              <a:t>KES 120,962</a:t>
             </a:r>
             <a:r>
               <a:rPr lang="en-US" sz="1600" dirty="0">
@@ -16123,7 +16503,7 @@
                 <a:ea typeface="Quattrocento Sans" pitchFamily="34" charset="-122"/>
                 <a:cs typeface="Quattrocento Sans" pitchFamily="34" charset="-120"/>
               </a:rPr>
-              <a:t>KES 61,773</a:t>
+              <a:t>KES 64,346</a:t>
             </a:r>
             <a:r>
               <a:rPr lang="en-US" sz="1600" dirty="0">
@@ -16145,7 +16525,7 @@
                 <a:ea typeface="Quattrocento Sans" pitchFamily="34" charset="-122"/>
                 <a:cs typeface="Quattrocento Sans" pitchFamily="34" charset="-120"/>
               </a:rPr>
-              <a:t>inflation of 109%</a:t>
+              <a:t>inflation of 88%</a:t>
             </a:r>
             <a:r>
               <a:rPr lang="en-US" sz="1600" dirty="0">
@@ -16347,7 +16727,7 @@
                 <a:ea typeface="Quattrocento Sans" pitchFamily="34" charset="-122"/>
                 <a:cs typeface="Quattrocento Sans" pitchFamily="34" charset="-120"/>
               </a:rPr>
-              <a:t>KES 66,375</a:t>
+              <a:t>KES 66,875</a:t>
             </a:r>
             <a:r>
               <a:rPr lang="en-US" sz="1600" dirty="0">
@@ -16369,7 +16749,7 @@
                 <a:ea typeface="Quattrocento Sans" pitchFamily="34" charset="-122"/>
                 <a:cs typeface="Quattrocento Sans" pitchFamily="34" charset="-120"/>
               </a:rPr>
-              <a:t>KES 65,167</a:t>
+              <a:t>KES 65,800</a:t>
             </a:r>
             <a:r>
               <a:rPr lang="en-US" sz="1600" dirty="0">
@@ -16758,7 +17138,7 @@
                 <a:ea typeface="Quattrocento Sans" pitchFamily="34" charset="-122"/>
                 <a:cs typeface="Quattrocento Sans" pitchFamily="34" charset="-120"/>
               </a:rPr>
-              <a:t>10 of 11</a:t>
+              <a:t>12 of 13</a:t>
             </a:r>
             <a:r>
               <a:rPr lang="en-US" sz="1600" dirty="0">
@@ -16769,7 +17149,7 @@
                 <a:ea typeface="Quattrocento Sans" pitchFamily="34" charset="-122"/>
                 <a:cs typeface="Quattrocento Sans" pitchFamily="34" charset="-120"/>
               </a:rPr>
-              <a:t> employees in the city view. Total, mean, median, the 109% finding and the distribution analysis stay </a:t>
+              <a:t> employees in the city view. Total, mean, median, the 88% finding and the distribution analysis stay </a:t>
             </a:r>
             <a:r>
               <a:rPr lang="en-US" sz="1600" b="1" dirty="0">
@@ -17475,7 +17855,7 @@
                 <a:ea typeface="Liter" pitchFamily="34" charset="-122"/>
                 <a:cs typeface="Liter" pitchFamily="34" charset="-120"/>
               </a:rPr>
-              <a:t>11</a:t>
+              <a:t>13</a:t>
             </a:r>
             <a:endParaRPr lang="en-US" sz="5200" dirty="0"/>
           </a:p>
@@ -17807,7 +18187,7 @@
                 <a:ea typeface="Liter" pitchFamily="34" charset="-122"/>
                 <a:cs typeface="Liter" pitchFamily="34" charset="-120"/>
               </a:rPr>
-              <a:t>KES 679,500</a:t>
+              <a:t>KES 836,500</a:t>
             </a:r>
             <a:endParaRPr lang="en-US" sz="3600" dirty="0"/>
           </a:p>
@@ -18207,7 +18587,7 @@
                 <a:ea typeface="Liter" pitchFamily="34" charset="-122"/>
                 <a:cs typeface="Liter" pitchFamily="34" charset="-120"/>
               </a:rPr>
-              <a:t>KES 61,773</a:t>
+              <a:t>KES 64,346</a:t>
             </a:r>
             <a:endParaRPr lang="en-US" sz="3600" dirty="0"/>
           </a:p>
@@ -18461,7 +18841,7 @@
                 <a:ea typeface="Liter" pitchFamily="34" charset="-122"/>
                 <a:cs typeface="Liter" pitchFamily="34" charset="-120"/>
               </a:rPr>
-              <a:t>30.1</a:t>
+              <a:t>31.0</a:t>
             </a:r>
             <a:endParaRPr lang="en-US" sz="5200" dirty="0"/>
           </a:p>

</xml_diff>